<commit_message>
Thêm notebook nộp bài và thông tin nhóm 6
- scripts/05_make_notebook.py: sinh notebook tự chứa (40 ô, 20 markdown +
  20 code). Cài đặt AdaIN / VGG encoder / Decoder / hàm mất mát / Guided
  Filter / hiệu ứng vật lý được viết thẳng trong notebook thay vì import từ
  src/, để người đọc thấy được cài đặt thật. Notebook đã chạy sẵn, nhúng
  8 hình và 18 khối kết quả.
- Báo cáo và slide: thêm thông tin nhóm 6 và danh sách thành viên.
- Slide rút từ 16 xuống 15 trang theo quy định nộp bài (gộp mục "Sản phẩm
  bàn giao" vào slide Kết luận).
- Cập nhật số liệu huấn luyện trên slide cho khớp thực tế: 12.000 bước,
  37 phút trên RTX 5060 Ti.

Co-Authored-By: Claude Opus 5 (1M context) <noreply@anthropic.com>
</commit_message>
<xml_diff>
--- a/slides/BaoCao_TangCuongDuLieuThoiTiet.pptx
+++ b/slides/BaoCao_TangCuongDuLieuThoiTiet.pptx
@@ -20,7 +20,6 @@
     <p:sldId id="268" r:id="rId19"/>
     <p:sldId id="269" r:id="rId20"/>
     <p:sldId id="270" r:id="rId21"/>
-    <p:sldId id="271" r:id="rId22"/>
   </p:sldIdLst>
   <p:sldSz cx="12191695" cy="6858000" type="screen4x3"/>
   <p:notesSz cx="6858000" cy="9144000"/>
@@ -3260,8 +3259,8 @@
         </p:nvSpPr>
         <p:spPr>
           <a:xfrm>
-            <a:off x="822960" y="4343400"/>
-            <a:ext cx="10698480" cy="1463040"/>
+            <a:off x="822960" y="4224528"/>
+            <a:ext cx="10698480" cy="914400"/>
           </a:xfrm>
           <a:prstGeom prst="rect">
             <a:avLst/>
@@ -3283,7 +3282,7 @@
               </a:spcAft>
             </a:pPr>
             <a:r>
-              <a:rPr sz="1700" b="0">
+              <a:rPr sz="1600" b="0">
                 <a:solidFill>
                   <a:srgbClr val="C8D2E4"/>
                 </a:solidFill>
@@ -3302,7 +3301,7 @@
               </a:spcAft>
             </a:pPr>
             <a:r>
-              <a:rPr sz="1700" b="0">
+              <a:rPr sz="1600" b="0">
                 <a:solidFill>
                   <a:srgbClr val="C8D2E4"/>
                 </a:solidFill>
@@ -3311,23 +3310,109 @@
               <a:t>Đầu ra: ảnh giao thông dưới thời tiết xấu — giữ nguyên nhãn bounding box</a:t>
             </a:r>
           </a:p>
-          <a:p>
-            <a:pPr algn="l">
-              <a:lnSpc>
-                <a:spcPct val="115000"/>
-              </a:lnSpc>
-              <a:spcAft>
-                <a:spcPts val="600"/>
-              </a:spcAft>
-            </a:pPr>
-            <a:r>
-              <a:rPr sz="1500" b="0">
+        </p:txBody>
+      </p:sp>
+      <p:sp>
+        <p:nvSpPr>
+          <p:cNvPr id="6" name="Rectangle 5"/>
+          <p:cNvSpPr/>
+          <p:nvPr/>
+        </p:nvSpPr>
+        <p:spPr>
+          <a:xfrm>
+            <a:off x="822960" y="5440680"/>
+            <a:ext cx="54864" cy="914400"/>
+          </a:xfrm>
+          <a:prstGeom prst="rect">
+            <a:avLst/>
+          </a:prstGeom>
+          <a:solidFill>
+            <a:srgbClr val="18A099"/>
+          </a:solidFill>
+          <a:ln>
+            <a:noFill/>
+          </a:ln>
+          <a:effectLst/>
+        </p:spPr>
+        <p:style>
+          <a:lnRef idx="1">
+            <a:schemeClr val="accent1"/>
+          </a:lnRef>
+          <a:fillRef idx="3">
+            <a:schemeClr val="accent1"/>
+          </a:fillRef>
+          <a:effectRef idx="2">
+            <a:schemeClr val="accent1"/>
+          </a:effectRef>
+          <a:fontRef idx="minor">
+            <a:schemeClr val="lt1"/>
+          </a:fontRef>
+        </p:style>
+        <p:txBody>
+          <a:bodyPr rtlCol="0" anchor="ctr"/>
+          <a:lstStyle/>
+          <a:p>
+            <a:pPr algn="ctr"/>
+          </a:p>
+        </p:txBody>
+      </p:sp>
+      <p:sp>
+        <p:nvSpPr>
+          <p:cNvPr id="7" name="TextBox 6"/>
+          <p:cNvSpPr txBox="1"/>
+          <p:nvPr/>
+        </p:nvSpPr>
+        <p:spPr>
+          <a:xfrm>
+            <a:off x="1051560" y="5413248"/>
+            <a:ext cx="10424160" cy="1005840"/>
+          </a:xfrm>
+          <a:prstGeom prst="rect">
+            <a:avLst/>
+          </a:prstGeom>
+          <a:noFill/>
+        </p:spPr>
+        <p:txBody>
+          <a:bodyPr wrap="square" lIns="0" rIns="0">
+            <a:spAutoFit/>
+          </a:bodyPr>
+          <a:lstStyle/>
+          <a:p>
+            <a:pPr algn="l">
+              <a:lnSpc>
+                <a:spcPct val="115000"/>
+              </a:lnSpc>
+              <a:spcAft>
+                <a:spcPts val="600"/>
+              </a:spcAft>
+            </a:pPr>
+            <a:r>
+              <a:rPr sz="1500" b="1">
                 <a:solidFill>
                   <a:srgbClr val="18A099"/>
                 </a:solidFill>
                 <a:latin typeface="Arial"/>
               </a:rPr>
-              <a:t>AdaIN (ICCV 2017) + Guided Filter + mô hình tán xạ khí quyển</a:t>
+              <a:t>NHÓM 6  ·  Bài tập cuối khoá — Deep Learning Ứng dụng</a:t>
+            </a:r>
+          </a:p>
+          <a:p>
+            <a:pPr algn="l">
+              <a:lnSpc>
+                <a:spcPct val="115000"/>
+              </a:lnSpc>
+              <a:spcAft>
+                <a:spcPts val="600"/>
+              </a:spcAft>
+            </a:pPr>
+            <a:r>
+              <a:rPr sz="1400" b="0">
+                <a:solidFill>
+                  <a:srgbClr val="C8D2E4"/>
+                </a:solidFill>
+                <a:latin typeface="Arial"/>
+              </a:rPr>
+              <a:t>Hoàng Minh Đức  ·  Trần Quý Đạt  ·  Hoàng Trung Kiên  ·  Vũ Thuỳ Linh</a:t>
             </a:r>
           </a:p>
         </p:txBody>
@@ -7474,26 +7559,7 @@
                 </a:solidFill>
                 <a:latin typeface="Arial"/>
               </a:rPr>
-              <a:t>Sản phẩm bàn giao</a:t>
-            </a:r>
-          </a:p>
-          <a:p>
-            <a:pPr algn="l">
-              <a:lnSpc>
-                <a:spcPct val="115000"/>
-              </a:lnSpc>
-              <a:spcAft>
-                <a:spcPts val="600"/>
-              </a:spcAft>
-            </a:pPr>
-            <a:r>
-              <a:rPr sz="1300" b="0">
-                <a:solidFill>
-                  <a:srgbClr val="B6C2D9"/>
-                </a:solidFill>
-                <a:latin typeface="Arial"/>
-              </a:rPr>
-              <a:t>Mã nguồn chạy được từ đầu đến cuối bằng 1 lệnh</a:t>
+              <a:t>Hạn chế &amp; hướng phát triển</a:t>
             </a:r>
           </a:p>
         </p:txBody>
@@ -7548,8 +7614,8 @@
         </p:nvSpPr>
         <p:spPr>
           <a:xfrm>
-            <a:off x="640080" y="1325880"/>
-            <a:ext cx="10881360" cy="512064"/>
+            <a:off x="640080" y="1371600"/>
+            <a:ext cx="5349240" cy="4480560"/>
           </a:xfrm>
           <a:prstGeom prst="rect">
             <a:avLst/>
@@ -7586,104 +7652,20 @@
       </p:sp>
       <p:sp>
         <p:nvSpPr>
-          <p:cNvPr id="7" name="TextBox 6"/>
-          <p:cNvSpPr txBox="1"/>
-          <p:nvPr/>
-        </p:nvSpPr>
-        <p:spPr>
-          <a:xfrm>
-            <a:off x="822960" y="1435608"/>
-            <a:ext cx="3931920" cy="457200"/>
-          </a:xfrm>
-          <a:prstGeom prst="rect">
-            <a:avLst/>
-          </a:prstGeom>
-          <a:noFill/>
-        </p:spPr>
-        <p:txBody>
-          <a:bodyPr wrap="square" lIns="0" rIns="0">
-            <a:spAutoFit/>
-          </a:bodyPr>
-          <a:lstStyle/>
-          <a:p>
-            <a:pPr algn="l">
-              <a:lnSpc>
-                <a:spcPct val="115000"/>
-              </a:lnSpc>
-              <a:spcAft>
-                <a:spcPts val="600"/>
-              </a:spcAft>
-            </a:pPr>
-            <a:r>
-              <a:rPr sz="1500" b="1">
-                <a:solidFill>
-                  <a:srgbClr val="2E6FD9"/>
-                </a:solidFill>
-                <a:latin typeface="Arial"/>
-              </a:rPr>
-              <a:t>scripts/01,02,03_*.py</a:t>
-            </a:r>
-          </a:p>
-        </p:txBody>
-      </p:sp>
-      <p:sp>
-        <p:nvSpPr>
-          <p:cNvPr id="8" name="TextBox 7"/>
-          <p:cNvSpPr txBox="1"/>
-          <p:nvPr/>
-        </p:nvSpPr>
-        <p:spPr>
-          <a:xfrm>
-            <a:off x="4937760" y="1435608"/>
-            <a:ext cx="6400800" cy="457200"/>
-          </a:xfrm>
-          <a:prstGeom prst="rect">
-            <a:avLst/>
-          </a:prstGeom>
-          <a:noFill/>
-        </p:spPr>
-        <p:txBody>
-          <a:bodyPr wrap="square" lIns="0" rIns="0">
-            <a:spAutoFit/>
-          </a:bodyPr>
-          <a:lstStyle/>
-          <a:p>
-            <a:pPr algn="l">
-              <a:lnSpc>
-                <a:spcPct val="115000"/>
-              </a:lnSpc>
-              <a:spcAft>
-                <a:spcPts val="600"/>
-              </a:spcAft>
-            </a:pPr>
-            <a:r>
-              <a:rPr sz="1500" b="0">
-                <a:solidFill>
-                  <a:srgbClr val="101B33"/>
-                </a:solidFill>
-                <a:latin typeface="Arial"/>
-              </a:rPr>
-              <a:t>Tải dữ liệu · chia tập · sinh hình minh hoạ</a:t>
-            </a:r>
-          </a:p>
-        </p:txBody>
-      </p:sp>
-      <p:sp>
-        <p:nvSpPr>
-          <p:cNvPr id="9" name="Rectangle 8"/>
+          <p:cNvPr id="7" name="Rectangle 6"/>
           <p:cNvSpPr/>
           <p:nvPr/>
         </p:nvSpPr>
         <p:spPr>
           <a:xfrm>
-            <a:off x="640080" y="1929384"/>
-            <a:ext cx="10881360" cy="512064"/>
+            <a:off x="640080" y="1371600"/>
+            <a:ext cx="64008" cy="4480560"/>
           </a:xfrm>
           <a:prstGeom prst="rect">
             <a:avLst/>
           </a:prstGeom>
           <a:solidFill>
-            <a:srgbClr val="FFFFFF"/>
+            <a:srgbClr val="E45A5A"/>
           </a:solidFill>
           <a:ln>
             <a:noFill/>
@@ -7714,14 +7696,14 @@
       </p:sp>
       <p:sp>
         <p:nvSpPr>
-          <p:cNvPr id="10" name="TextBox 9"/>
+          <p:cNvPr id="8" name="TextBox 7"/>
           <p:cNvSpPr txBox="1"/>
           <p:nvPr/>
         </p:nvSpPr>
         <p:spPr>
           <a:xfrm>
-            <a:off x="822960" y="2039112"/>
-            <a:ext cx="3931920" cy="457200"/>
+            <a:off x="896112" y="1536192"/>
+            <a:ext cx="4892040" cy="4480560"/>
           </a:xfrm>
           <a:prstGeom prst="rect">
             <a:avLst/>
@@ -7743,69 +7725,50 @@
               </a:spcAft>
             </a:pPr>
             <a:r>
-              <a:rPr sz="1500" b="1">
-                <a:solidFill>
-                  <a:srgbClr val="2E6FD9"/>
-                </a:solidFill>
-                <a:latin typeface="Arial"/>
-              </a:rPr>
-              <a:t>train.py</a:t>
-            </a:r>
-          </a:p>
-        </p:txBody>
-      </p:sp>
-      <p:sp>
-        <p:nvSpPr>
-          <p:cNvPr id="11" name="TextBox 10"/>
-          <p:cNvSpPr txBox="1"/>
-          <p:nvPr/>
-        </p:nvSpPr>
-        <p:spPr>
-          <a:xfrm>
-            <a:off x="4937760" y="2039112"/>
-            <a:ext cx="6400800" cy="457200"/>
-          </a:xfrm>
-          <a:prstGeom prst="rect">
-            <a:avLst/>
-          </a:prstGeom>
-          <a:noFill/>
-        </p:spPr>
-        <p:txBody>
-          <a:bodyPr wrap="square" lIns="0" rIns="0">
-            <a:spAutoFit/>
-          </a:bodyPr>
-          <a:lstStyle/>
-          <a:p>
-            <a:pPr algn="l">
-              <a:lnSpc>
-                <a:spcPct val="115000"/>
-              </a:lnSpc>
-              <a:spcAft>
-                <a:spcPts val="600"/>
-              </a:spcAft>
-            </a:pPr>
-            <a:r>
-              <a:rPr sz="1500" b="0">
+              <a:rPr sz="1600" b="1">
                 <a:solidFill>
                   <a:srgbClr val="101B33"/>
                 </a:solidFill>
                 <a:latin typeface="Arial"/>
               </a:rPr>
-              <a:t>Huấn luyện (có resume, log, preview, checkpoint)</a:t>
-            </a:r>
-          </a:p>
-        </p:txBody>
-      </p:sp>
-      <p:sp>
-        <p:nvSpPr>
-          <p:cNvPr id="12" name="Rectangle 11"/>
+              <a:t>HẠN CHẾ</a:t>
+            </a:r>
+          </a:p>
+          <a:p>
+            <a:pPr algn="l">
+              <a:lnSpc>
+                <a:spcPct val="115000"/>
+              </a:lnSpc>
+              <a:spcAft>
+                <a:spcPts val="600"/>
+              </a:spcAft>
+            </a:pPr>
+            <a:r>
+              <a:rPr sz="1300" b="0">
+                <a:solidFill>
+                  <a:srgbClr val="5A6375"/>
+                </a:solidFill>
+                <a:latin typeface="Arial"/>
+              </a:rPr>
+              <a:t>
+· AdaIN chuyển thống kê TOÀN CỤC nên chưa phân biệt vùng trời / mặt đường — sương mù dày ở gần cũng như ở xa.
+· Không có bản đồ độ sâu thật; module vật lý dùng giả thiết mặt đường phẳng.
+· Chất lượng phụ thuộc ảnh tham chiếu: ảnh tham chiếu khác góc chụp quá nhiều sẽ cho tông màu lệch.
+· DAWN chỉ được dùng cho mục đích nghiên cứu, không dùng thương mại.</a:t>
+            </a:r>
+          </a:p>
+        </p:txBody>
+      </p:sp>
+      <p:sp>
+        <p:nvSpPr>
+          <p:cNvPr id="9" name="Rectangle 8"/>
           <p:cNvSpPr/>
           <p:nvPr/>
         </p:nvSpPr>
         <p:spPr>
           <a:xfrm>
-            <a:off x="640080" y="2532888"/>
-            <a:ext cx="10881360" cy="512064"/>
+            <a:off x="6355080" y="1371600"/>
+            <a:ext cx="5349240" cy="4480560"/>
           </a:xfrm>
           <a:prstGeom prst="rect">
             <a:avLst/>
@@ -7842,104 +7805,20 @@
       </p:sp>
       <p:sp>
         <p:nvSpPr>
-          <p:cNvPr id="13" name="TextBox 12"/>
-          <p:cNvSpPr txBox="1"/>
-          <p:nvPr/>
-        </p:nvSpPr>
-        <p:spPr>
-          <a:xfrm>
-            <a:off x="822960" y="2642616"/>
-            <a:ext cx="3931920" cy="457200"/>
-          </a:xfrm>
-          <a:prstGeom prst="rect">
-            <a:avLst/>
-          </a:prstGeom>
-          <a:noFill/>
-        </p:spPr>
-        <p:txBody>
-          <a:bodyPr wrap="square" lIns="0" rIns="0">
-            <a:spAutoFit/>
-          </a:bodyPr>
-          <a:lstStyle/>
-          <a:p>
-            <a:pPr algn="l">
-              <a:lnSpc>
-                <a:spcPct val="115000"/>
-              </a:lnSpc>
-              <a:spcAft>
-                <a:spcPts val="600"/>
-              </a:spcAft>
-            </a:pPr>
-            <a:r>
-              <a:rPr sz="1500" b="1">
-                <a:solidFill>
-                  <a:srgbClr val="2E6FD9"/>
-                </a:solidFill>
-                <a:latin typeface="Arial"/>
-              </a:rPr>
-              <a:t>infer.py</a:t>
-            </a:r>
-          </a:p>
-        </p:txBody>
-      </p:sp>
-      <p:sp>
-        <p:nvSpPr>
-          <p:cNvPr id="14" name="TextBox 13"/>
-          <p:cNvSpPr txBox="1"/>
-          <p:nvPr/>
-        </p:nvSpPr>
-        <p:spPr>
-          <a:xfrm>
-            <a:off x="4937760" y="2642616"/>
-            <a:ext cx="6400800" cy="457200"/>
-          </a:xfrm>
-          <a:prstGeom prst="rect">
-            <a:avLst/>
-          </a:prstGeom>
-          <a:noFill/>
-        </p:spPr>
-        <p:txBody>
-          <a:bodyPr wrap="square" lIns="0" rIns="0">
-            <a:spAutoFit/>
-          </a:bodyPr>
-          <a:lstStyle/>
-          <a:p>
-            <a:pPr algn="l">
-              <a:lnSpc>
-                <a:spcPct val="115000"/>
-              </a:lnSpc>
-              <a:spcAft>
-                <a:spcPts val="600"/>
-              </a:spcAft>
-            </a:pPr>
-            <a:r>
-              <a:rPr sz="1500" b="0">
-                <a:solidFill>
-                  <a:srgbClr val="101B33"/>
-                </a:solidFill>
-                <a:latin typeface="Arial"/>
-              </a:rPr>
-              <a:t>Suy luận 1 ảnh hoặc cả thư mục, xuất ảnh so sánh</a:t>
-            </a:r>
-          </a:p>
-        </p:txBody>
-      </p:sp>
-      <p:sp>
-        <p:nvSpPr>
-          <p:cNvPr id="15" name="Rectangle 14"/>
+          <p:cNvPr id="10" name="Rectangle 9"/>
           <p:cNvSpPr/>
           <p:nvPr/>
         </p:nvSpPr>
         <p:spPr>
           <a:xfrm>
-            <a:off x="640080" y="3136392"/>
-            <a:ext cx="10881360" cy="512064"/>
+            <a:off x="6355080" y="1371600"/>
+            <a:ext cx="64008" cy="4480560"/>
           </a:xfrm>
           <a:prstGeom prst="rect">
             <a:avLst/>
           </a:prstGeom>
           <a:solidFill>
-            <a:srgbClr val="FFFFFF"/>
+            <a:srgbClr val="18A099"/>
           </a:solidFill>
           <a:ln>
             <a:noFill/>
@@ -7970,14 +7849,14 @@
       </p:sp>
       <p:sp>
         <p:nvSpPr>
-          <p:cNvPr id="16" name="TextBox 15"/>
+          <p:cNvPr id="11" name="TextBox 10"/>
           <p:cNvSpPr txBox="1"/>
           <p:nvPr/>
         </p:nvSpPr>
         <p:spPr>
           <a:xfrm>
-            <a:off x="822960" y="3246120"/>
-            <a:ext cx="3931920" cy="457200"/>
+            <a:off x="6611112" y="1536192"/>
+            <a:ext cx="4892040" cy="4480560"/>
           </a:xfrm>
           <a:prstGeom prst="rect">
             <a:avLst/>
@@ -7999,567 +7878,37 @@
               </a:spcAft>
             </a:pPr>
             <a:r>
-              <a:rPr sz="1500" b="1">
-                <a:solidFill>
-                  <a:srgbClr val="2E6FD9"/>
-                </a:solidFill>
-                <a:latin typeface="Arial"/>
-              </a:rPr>
-              <a:t>augment_dataset.py</a:t>
-            </a:r>
-          </a:p>
-        </p:txBody>
-      </p:sp>
-      <p:sp>
-        <p:nvSpPr>
-          <p:cNvPr id="17" name="TextBox 16"/>
-          <p:cNvSpPr txBox="1"/>
-          <p:nvPr/>
-        </p:nvSpPr>
-        <p:spPr>
-          <a:xfrm>
-            <a:off x="4937760" y="3246120"/>
-            <a:ext cx="6400800" cy="457200"/>
-          </a:xfrm>
-          <a:prstGeom prst="rect">
-            <a:avLst/>
-          </a:prstGeom>
-          <a:noFill/>
-        </p:spPr>
-        <p:txBody>
-          <a:bodyPr wrap="square" lIns="0" rIns="0">
-            <a:spAutoFit/>
-          </a:bodyPr>
-          <a:lstStyle/>
-          <a:p>
-            <a:pPr algn="l">
-              <a:lnSpc>
-                <a:spcPct val="115000"/>
-              </a:lnSpc>
-              <a:spcAft>
-                <a:spcPts val="600"/>
-              </a:spcAft>
-            </a:pPr>
-            <a:r>
-              <a:rPr sz="1500" b="0">
+              <a:rPr sz="1600" b="1">
                 <a:solidFill>
                   <a:srgbClr val="101B33"/>
                 </a:solidFill>
                 <a:latin typeface="Arial"/>
               </a:rPr>
-              <a:t>Sinh bộ dữ liệu tăng cường kèm nhãn</a:t>
-            </a:r>
-          </a:p>
-        </p:txBody>
-      </p:sp>
-      <p:sp>
-        <p:nvSpPr>
-          <p:cNvPr id="18" name="Rectangle 17"/>
-          <p:cNvSpPr/>
-          <p:nvPr/>
-        </p:nvSpPr>
-        <p:spPr>
-          <a:xfrm>
-            <a:off x="640080" y="3739896"/>
-            <a:ext cx="10881360" cy="512064"/>
-          </a:xfrm>
-          <a:prstGeom prst="rect">
-            <a:avLst/>
-          </a:prstGeom>
-          <a:solidFill>
-            <a:srgbClr val="F4F6FA"/>
-          </a:solidFill>
-          <a:ln>
-            <a:noFill/>
-          </a:ln>
-          <a:effectLst/>
-        </p:spPr>
-        <p:style>
-          <a:lnRef idx="1">
-            <a:schemeClr val="accent1"/>
-          </a:lnRef>
-          <a:fillRef idx="3">
-            <a:schemeClr val="accent1"/>
-          </a:fillRef>
-          <a:effectRef idx="2">
-            <a:schemeClr val="accent1"/>
-          </a:effectRef>
-          <a:fontRef idx="minor">
-            <a:schemeClr val="lt1"/>
-          </a:fontRef>
-        </p:style>
-        <p:txBody>
-          <a:bodyPr rtlCol="0" anchor="ctr"/>
-          <a:lstStyle/>
-          <a:p>
-            <a:pPr algn="ctr"/>
-          </a:p>
-        </p:txBody>
-      </p:sp>
-      <p:sp>
-        <p:nvSpPr>
-          <p:cNvPr id="19" name="TextBox 18"/>
-          <p:cNvSpPr txBox="1"/>
-          <p:nvPr/>
-        </p:nvSpPr>
-        <p:spPr>
-          <a:xfrm>
-            <a:off x="822960" y="3849624"/>
-            <a:ext cx="3931920" cy="457200"/>
-          </a:xfrm>
-          <a:prstGeom prst="rect">
-            <a:avLst/>
-          </a:prstGeom>
-          <a:noFill/>
-        </p:spPr>
-        <p:txBody>
-          <a:bodyPr wrap="square" lIns="0" rIns="0">
-            <a:spAutoFit/>
-          </a:bodyPr>
-          <a:lstStyle/>
-          <a:p>
-            <a:pPr algn="l">
-              <a:lnSpc>
-                <a:spcPct val="115000"/>
-              </a:lnSpc>
-              <a:spcAft>
-                <a:spcPts val="600"/>
-              </a:spcAft>
-            </a:pPr>
-            <a:r>
-              <a:rPr sz="1500" b="1">
-                <a:solidFill>
-                  <a:srgbClr val="2E6FD9"/>
-                </a:solidFill>
-                <a:latin typeface="Arial"/>
-              </a:rPr>
-              <a:t>evaluate.py</a:t>
-            </a:r>
-          </a:p>
-        </p:txBody>
-      </p:sp>
-      <p:sp>
-        <p:nvSpPr>
-          <p:cNvPr id="20" name="TextBox 19"/>
-          <p:cNvSpPr txBox="1"/>
-          <p:nvPr/>
-        </p:nvSpPr>
-        <p:spPr>
-          <a:xfrm>
-            <a:off x="4937760" y="3849624"/>
-            <a:ext cx="6400800" cy="457200"/>
-          </a:xfrm>
-          <a:prstGeom prst="rect">
-            <a:avLst/>
-          </a:prstGeom>
-          <a:noFill/>
-        </p:spPr>
-        <p:txBody>
-          <a:bodyPr wrap="square" lIns="0" rIns="0">
-            <a:spAutoFit/>
-          </a:bodyPr>
-          <a:lstStyle/>
-          <a:p>
-            <a:pPr algn="l">
-              <a:lnSpc>
-                <a:spcPct val="115000"/>
-              </a:lnSpc>
-              <a:spcAft>
-                <a:spcPts val="600"/>
-              </a:spcAft>
-            </a:pPr>
-            <a:r>
-              <a:rPr sz="1500" b="0">
-                <a:solidFill>
-                  <a:srgbClr val="101B33"/>
-                </a:solidFill>
-                <a:latin typeface="Arial"/>
-              </a:rPr>
-              <a:t>SSIM / PSNR / EdgeRecall / FID</a:t>
-            </a:r>
-          </a:p>
-        </p:txBody>
-      </p:sp>
-      <p:sp>
-        <p:nvSpPr>
-          <p:cNvPr id="21" name="Rectangle 20"/>
-          <p:cNvSpPr/>
-          <p:nvPr/>
-        </p:nvSpPr>
-        <p:spPr>
-          <a:xfrm>
-            <a:off x="640080" y="4343400"/>
-            <a:ext cx="10881360" cy="512064"/>
-          </a:xfrm>
-          <a:prstGeom prst="rect">
-            <a:avLst/>
-          </a:prstGeom>
-          <a:solidFill>
-            <a:srgbClr val="FFFFFF"/>
-          </a:solidFill>
-          <a:ln>
-            <a:noFill/>
-          </a:ln>
-          <a:effectLst/>
-        </p:spPr>
-        <p:style>
-          <a:lnRef idx="1">
-            <a:schemeClr val="accent1"/>
-          </a:lnRef>
-          <a:fillRef idx="3">
-            <a:schemeClr val="accent1"/>
-          </a:fillRef>
-          <a:effectRef idx="2">
-            <a:schemeClr val="accent1"/>
-          </a:effectRef>
-          <a:fontRef idx="minor">
-            <a:schemeClr val="lt1"/>
-          </a:fontRef>
-        </p:style>
-        <p:txBody>
-          <a:bodyPr rtlCol="0" anchor="ctr"/>
-          <a:lstStyle/>
-          <a:p>
-            <a:pPr algn="ctr"/>
-          </a:p>
-        </p:txBody>
-      </p:sp>
-      <p:sp>
-        <p:nvSpPr>
-          <p:cNvPr id="22" name="TextBox 21"/>
-          <p:cNvSpPr txBox="1"/>
-          <p:nvPr/>
-        </p:nvSpPr>
-        <p:spPr>
-          <a:xfrm>
-            <a:off x="822960" y="4453128"/>
-            <a:ext cx="3931920" cy="457200"/>
-          </a:xfrm>
-          <a:prstGeom prst="rect">
-            <a:avLst/>
-          </a:prstGeom>
-          <a:noFill/>
-        </p:spPr>
-        <p:txBody>
-          <a:bodyPr wrap="square" lIns="0" rIns="0">
-            <a:spAutoFit/>
-          </a:bodyPr>
-          <a:lstStyle/>
-          <a:p>
-            <a:pPr algn="l">
-              <a:lnSpc>
-                <a:spcPct val="115000"/>
-              </a:lnSpc>
-              <a:spcAft>
-                <a:spcPts val="600"/>
-              </a:spcAft>
-            </a:pPr>
-            <a:r>
-              <a:rPr sz="1500" b="1">
-                <a:solidFill>
-                  <a:srgbClr val="2E6FD9"/>
-                </a:solidFill>
-                <a:latin typeface="Arial"/>
-              </a:rPr>
-              <a:t>experiments/detector_experiment.py</a:t>
-            </a:r>
-          </a:p>
-        </p:txBody>
-      </p:sp>
-      <p:sp>
-        <p:nvSpPr>
-          <p:cNvPr id="23" name="TextBox 22"/>
-          <p:cNvSpPr txBox="1"/>
-          <p:nvPr/>
-        </p:nvSpPr>
-        <p:spPr>
-          <a:xfrm>
-            <a:off x="4937760" y="4453128"/>
-            <a:ext cx="6400800" cy="457200"/>
-          </a:xfrm>
-          <a:prstGeom prst="rect">
-            <a:avLst/>
-          </a:prstGeom>
-          <a:noFill/>
-        </p:spPr>
-        <p:txBody>
-          <a:bodyPr wrap="square" lIns="0" rIns="0">
-            <a:spAutoFit/>
-          </a:bodyPr>
-          <a:lstStyle/>
-          <a:p>
-            <a:pPr algn="l">
-              <a:lnSpc>
-                <a:spcPct val="115000"/>
-              </a:lnSpc>
-              <a:spcAft>
-                <a:spcPts val="600"/>
-              </a:spcAft>
-            </a:pPr>
-            <a:r>
-              <a:rPr sz="1500" b="0">
-                <a:solidFill>
-                  <a:srgbClr val="101B33"/>
-                </a:solidFill>
-                <a:latin typeface="Arial"/>
-              </a:rPr>
-              <a:t>Thí nghiệm YOLOv8 baseline vs tăng cường</a:t>
-            </a:r>
-          </a:p>
-        </p:txBody>
-      </p:sp>
-      <p:sp>
-        <p:nvSpPr>
-          <p:cNvPr id="24" name="Rectangle 23"/>
-          <p:cNvSpPr/>
-          <p:nvPr/>
-        </p:nvSpPr>
-        <p:spPr>
-          <a:xfrm>
-            <a:off x="640080" y="4946904"/>
-            <a:ext cx="10881360" cy="512064"/>
-          </a:xfrm>
-          <a:prstGeom prst="rect">
-            <a:avLst/>
-          </a:prstGeom>
-          <a:solidFill>
-            <a:srgbClr val="F4F6FA"/>
-          </a:solidFill>
-          <a:ln>
-            <a:noFill/>
-          </a:ln>
-          <a:effectLst/>
-        </p:spPr>
-        <p:style>
-          <a:lnRef idx="1">
-            <a:schemeClr val="accent1"/>
-          </a:lnRef>
-          <a:fillRef idx="3">
-            <a:schemeClr val="accent1"/>
-          </a:fillRef>
-          <a:effectRef idx="2">
-            <a:schemeClr val="accent1"/>
-          </a:effectRef>
-          <a:fontRef idx="minor">
-            <a:schemeClr val="lt1"/>
-          </a:fontRef>
-        </p:style>
-        <p:txBody>
-          <a:bodyPr rtlCol="0" anchor="ctr"/>
-          <a:lstStyle/>
-          <a:p>
-            <a:pPr algn="ctr"/>
-          </a:p>
-        </p:txBody>
-      </p:sp>
-      <p:sp>
-        <p:nvSpPr>
-          <p:cNvPr id="25" name="TextBox 24"/>
-          <p:cNvSpPr txBox="1"/>
-          <p:nvPr/>
-        </p:nvSpPr>
-        <p:spPr>
-          <a:xfrm>
-            <a:off x="822960" y="5056632"/>
-            <a:ext cx="3931920" cy="457200"/>
-          </a:xfrm>
-          <a:prstGeom prst="rect">
-            <a:avLst/>
-          </a:prstGeom>
-          <a:noFill/>
-        </p:spPr>
-        <p:txBody>
-          <a:bodyPr wrap="square" lIns="0" rIns="0">
-            <a:spAutoFit/>
-          </a:bodyPr>
-          <a:lstStyle/>
-          <a:p>
-            <a:pPr algn="l">
-              <a:lnSpc>
-                <a:spcPct val="115000"/>
-              </a:lnSpc>
-              <a:spcAft>
-                <a:spcPts val="600"/>
-              </a:spcAft>
-            </a:pPr>
-            <a:r>
-              <a:rPr sz="1500" b="1">
-                <a:solidFill>
-                  <a:srgbClr val="2E6FD9"/>
-                </a:solidFill>
-                <a:latin typeface="Arial"/>
-              </a:rPr>
-              <a:t>app/app.py</a:t>
-            </a:r>
-          </a:p>
-        </p:txBody>
-      </p:sp>
-      <p:sp>
-        <p:nvSpPr>
-          <p:cNvPr id="26" name="TextBox 25"/>
-          <p:cNvSpPr txBox="1"/>
-          <p:nvPr/>
-        </p:nvSpPr>
-        <p:spPr>
-          <a:xfrm>
-            <a:off x="4937760" y="5056632"/>
-            <a:ext cx="6400800" cy="457200"/>
-          </a:xfrm>
-          <a:prstGeom prst="rect">
-            <a:avLst/>
-          </a:prstGeom>
-          <a:noFill/>
-        </p:spPr>
-        <p:txBody>
-          <a:bodyPr wrap="square" lIns="0" rIns="0">
-            <a:spAutoFit/>
-          </a:bodyPr>
-          <a:lstStyle/>
-          <a:p>
-            <a:pPr algn="l">
-              <a:lnSpc>
-                <a:spcPct val="115000"/>
-              </a:lnSpc>
-              <a:spcAft>
-                <a:spcPts val="600"/>
-              </a:spcAft>
-            </a:pPr>
-            <a:r>
-              <a:rPr sz="1500" b="0">
-                <a:solidFill>
-                  <a:srgbClr val="101B33"/>
-                </a:solidFill>
-                <a:latin typeface="Arial"/>
-              </a:rPr>
-              <a:t>Web demo Gradio 4 tab</a:t>
-            </a:r>
-          </a:p>
-        </p:txBody>
-      </p:sp>
-      <p:sp>
-        <p:nvSpPr>
-          <p:cNvPr id="27" name="Rectangle 26"/>
-          <p:cNvSpPr/>
-          <p:nvPr/>
-        </p:nvSpPr>
-        <p:spPr>
-          <a:xfrm>
-            <a:off x="640080" y="5550408"/>
-            <a:ext cx="10881360" cy="512064"/>
-          </a:xfrm>
-          <a:prstGeom prst="rect">
-            <a:avLst/>
-          </a:prstGeom>
-          <a:solidFill>
-            <a:srgbClr val="FFFFFF"/>
-          </a:solidFill>
-          <a:ln>
-            <a:noFill/>
-          </a:ln>
-          <a:effectLst/>
-        </p:spPr>
-        <p:style>
-          <a:lnRef idx="1">
-            <a:schemeClr val="accent1"/>
-          </a:lnRef>
-          <a:fillRef idx="3">
-            <a:schemeClr val="accent1"/>
-          </a:fillRef>
-          <a:effectRef idx="2">
-            <a:schemeClr val="accent1"/>
-          </a:effectRef>
-          <a:fontRef idx="minor">
-            <a:schemeClr val="lt1"/>
-          </a:fontRef>
-        </p:style>
-        <p:txBody>
-          <a:bodyPr rtlCol="0" anchor="ctr"/>
-          <a:lstStyle/>
-          <a:p>
-            <a:pPr algn="ctr"/>
-          </a:p>
-        </p:txBody>
-      </p:sp>
-      <p:sp>
-        <p:nvSpPr>
-          <p:cNvPr id="28" name="TextBox 27"/>
-          <p:cNvSpPr txBox="1"/>
-          <p:nvPr/>
-        </p:nvSpPr>
-        <p:spPr>
-          <a:xfrm>
-            <a:off x="822960" y="5660136"/>
-            <a:ext cx="3931920" cy="457200"/>
-          </a:xfrm>
-          <a:prstGeom prst="rect">
-            <a:avLst/>
-          </a:prstGeom>
-          <a:noFill/>
-        </p:spPr>
-        <p:txBody>
-          <a:bodyPr wrap="square" lIns="0" rIns="0">
-            <a:spAutoFit/>
-          </a:bodyPr>
-          <a:lstStyle/>
-          <a:p>
-            <a:pPr algn="l">
-              <a:lnSpc>
-                <a:spcPct val="115000"/>
-              </a:lnSpc>
-              <a:spcAft>
-                <a:spcPts val="600"/>
-              </a:spcAft>
-            </a:pPr>
-            <a:r>
-              <a:rPr sz="1500" b="1">
-                <a:solidFill>
-                  <a:srgbClr val="2E6FD9"/>
-                </a:solidFill>
-                <a:latin typeface="Arial"/>
-              </a:rPr>
-              <a:t>run_all.sh</a:t>
-            </a:r>
-          </a:p>
-        </p:txBody>
-      </p:sp>
-      <p:sp>
-        <p:nvSpPr>
-          <p:cNvPr id="29" name="TextBox 28"/>
-          <p:cNvSpPr txBox="1"/>
-          <p:nvPr/>
-        </p:nvSpPr>
-        <p:spPr>
-          <a:xfrm>
-            <a:off x="4937760" y="5660136"/>
-            <a:ext cx="6400800" cy="457200"/>
-          </a:xfrm>
-          <a:prstGeom prst="rect">
-            <a:avLst/>
-          </a:prstGeom>
-          <a:noFill/>
-        </p:spPr>
-        <p:txBody>
-          <a:bodyPr wrap="square" lIns="0" rIns="0">
-            <a:spAutoFit/>
-          </a:bodyPr>
-          <a:lstStyle/>
-          <a:p>
-            <a:pPr algn="l">
-              <a:lnSpc>
-                <a:spcPct val="115000"/>
-              </a:lnSpc>
-              <a:spcAft>
-                <a:spcPts val="600"/>
-              </a:spcAft>
-            </a:pPr>
-            <a:r>
-              <a:rPr sz="1500" b="0">
-                <a:solidFill>
-                  <a:srgbClr val="101B33"/>
-                </a:solidFill>
-                <a:latin typeface="Arial"/>
-              </a:rPr>
-              <a:t>Chạy toàn bộ quy trình</a:t>
+              <a:t>HƯỚNG PHÁT TRIỂN</a:t>
+            </a:r>
+          </a:p>
+          <a:p>
+            <a:pPr algn="l">
+              <a:lnSpc>
+                <a:spcPct val="115000"/>
+              </a:lnSpc>
+              <a:spcAft>
+                <a:spcPts val="600"/>
+              </a:spcAft>
+            </a:pPr>
+            <a:r>
+              <a:rPr sz="1300" b="0">
+                <a:solidFill>
+                  <a:srgbClr val="5A6375"/>
+                </a:solidFill>
+                <a:latin typeface="Arial"/>
+              </a:rPr>
+              <a:t>
+· Thêm mặt nạ phân vùng trời / đường để đổi tông theo từng vùng.
+· Dùng mô hình ước lượng độ sâu đơn ảnh (Depth Anything) thay cho giả thiết phẳng.
+· Thay AdaIN bằng AdaAttN / WCT² để bám cấu trúc tốt hơn.
+· Thu thập ảnh tham chiếu thời tiết tại Việt Nam để khớp bối cảnh triển khai thực tế.
+· Mở rộng sang ban đêm, chói nắng ngược, đèn pha.</a:t>
             </a:r>
           </a:p>
         </p:txBody>
@@ -8591,7 +7940,7 @@
         <p:spPr>
           <a:xfrm>
             <a:off x="0" y="0"/>
-            <a:ext cx="12191695" cy="960120"/>
+            <a:ext cx="12191695" cy="6858000"/>
           </a:xfrm>
           <a:prstGeom prst="rect">
             <a:avLst/>
@@ -8634,8 +7983,8 @@
         </p:nvSpPr>
         <p:spPr>
           <a:xfrm>
-            <a:off x="0" y="960120"/>
-            <a:ext cx="12191695" cy="50292"/>
+            <a:off x="914400" y="1371600"/>
+            <a:ext cx="73152" cy="4206240"/>
           </a:xfrm>
           <a:prstGeom prst="rect">
             <a:avLst/>
@@ -8678,8 +8027,8 @@
         </p:nvSpPr>
         <p:spPr>
           <a:xfrm>
-            <a:off x="548640" y="146304"/>
-            <a:ext cx="10424160" cy="822960"/>
+            <a:off x="1280160" y="1371600"/>
+            <a:ext cx="10058400" cy="4389120"/>
           </a:xfrm>
           <a:prstGeom prst="rect">
             <a:avLst/>
@@ -8701,510 +8050,146 @@
               </a:spcAft>
             </a:pPr>
             <a:r>
-              <a:rPr sz="2700" b="1">
+              <a:rPr sz="3400" b="1">
                 <a:solidFill>
                   <a:srgbClr val="FFFFFF"/>
                 </a:solidFill>
                 <a:latin typeface="Arial"/>
               </a:rPr>
-              <a:t>Hạn chế &amp; hướng phát triển</a:t>
-            </a:r>
-          </a:p>
-        </p:txBody>
-      </p:sp>
-      <p:sp>
-        <p:nvSpPr>
-          <p:cNvPr id="5" name="TextBox 4"/>
-          <p:cNvSpPr txBox="1"/>
-          <p:nvPr/>
-        </p:nvSpPr>
-        <p:spPr>
-          <a:xfrm>
-            <a:off x="11155680" y="6355080"/>
-            <a:ext cx="822960" cy="365760"/>
-          </a:xfrm>
-          <a:prstGeom prst="rect">
-            <a:avLst/>
-          </a:prstGeom>
-          <a:noFill/>
-        </p:spPr>
-        <p:txBody>
-          <a:bodyPr wrap="square" lIns="0" rIns="0">
-            <a:spAutoFit/>
-          </a:bodyPr>
-          <a:lstStyle/>
-          <a:p>
-            <a:pPr algn="r">
-              <a:lnSpc>
-                <a:spcPct val="115000"/>
-              </a:lnSpc>
-              <a:spcAft>
-                <a:spcPts val="600"/>
-              </a:spcAft>
-            </a:pPr>
-            <a:r>
-              <a:rPr sz="1100" b="0">
-                <a:solidFill>
-                  <a:srgbClr val="5A6375"/>
-                </a:solidFill>
-                <a:latin typeface="Arial"/>
-              </a:rPr>
-              <a:t>14</a:t>
-            </a:r>
-          </a:p>
-        </p:txBody>
-      </p:sp>
-      <p:sp>
-        <p:nvSpPr>
-          <p:cNvPr id="6" name="Rectangle 5"/>
-          <p:cNvSpPr/>
-          <p:nvPr/>
-        </p:nvSpPr>
-        <p:spPr>
-          <a:xfrm>
-            <a:off x="640080" y="1371600"/>
-            <a:ext cx="5349240" cy="4480560"/>
-          </a:xfrm>
-          <a:prstGeom prst="rect">
-            <a:avLst/>
-          </a:prstGeom>
-          <a:solidFill>
-            <a:srgbClr val="F4F6FA"/>
-          </a:solidFill>
-          <a:ln>
-            <a:noFill/>
-          </a:ln>
-          <a:effectLst/>
-        </p:spPr>
-        <p:style>
-          <a:lnRef idx="1">
-            <a:schemeClr val="accent1"/>
-          </a:lnRef>
-          <a:fillRef idx="3">
-            <a:schemeClr val="accent1"/>
-          </a:fillRef>
-          <a:effectRef idx="2">
-            <a:schemeClr val="accent1"/>
-          </a:effectRef>
-          <a:fontRef idx="minor">
-            <a:schemeClr val="lt1"/>
-          </a:fontRef>
-        </p:style>
-        <p:txBody>
-          <a:bodyPr rtlCol="0" anchor="ctr"/>
-          <a:lstStyle/>
-          <a:p>
-            <a:pPr algn="ctr"/>
-          </a:p>
-        </p:txBody>
-      </p:sp>
-      <p:sp>
-        <p:nvSpPr>
-          <p:cNvPr id="7" name="Rectangle 6"/>
-          <p:cNvSpPr/>
-          <p:nvPr/>
-        </p:nvSpPr>
-        <p:spPr>
-          <a:xfrm>
-            <a:off x="640080" y="1371600"/>
-            <a:ext cx="64008" cy="4480560"/>
-          </a:xfrm>
-          <a:prstGeom prst="rect">
-            <a:avLst/>
-          </a:prstGeom>
-          <a:solidFill>
-            <a:srgbClr val="E45A5A"/>
-          </a:solidFill>
-          <a:ln>
-            <a:noFill/>
-          </a:ln>
-          <a:effectLst/>
-        </p:spPr>
-        <p:style>
-          <a:lnRef idx="1">
-            <a:schemeClr val="accent1"/>
-          </a:lnRef>
-          <a:fillRef idx="3">
-            <a:schemeClr val="accent1"/>
-          </a:fillRef>
-          <a:effectRef idx="2">
-            <a:schemeClr val="accent1"/>
-          </a:effectRef>
-          <a:fontRef idx="minor">
-            <a:schemeClr val="lt1"/>
-          </a:fontRef>
-        </p:style>
-        <p:txBody>
-          <a:bodyPr rtlCol="0" anchor="ctr"/>
-          <a:lstStyle/>
-          <a:p>
-            <a:pPr algn="ctr"/>
-          </a:p>
-        </p:txBody>
-      </p:sp>
-      <p:sp>
-        <p:nvSpPr>
-          <p:cNvPr id="8" name="TextBox 7"/>
-          <p:cNvSpPr txBox="1"/>
-          <p:nvPr/>
-        </p:nvSpPr>
-        <p:spPr>
-          <a:xfrm>
-            <a:off x="896112" y="1536192"/>
-            <a:ext cx="4892040" cy="4480560"/>
-          </a:xfrm>
-          <a:prstGeom prst="rect">
-            <a:avLst/>
-          </a:prstGeom>
-          <a:noFill/>
-        </p:spPr>
-        <p:txBody>
-          <a:bodyPr wrap="square" lIns="0" rIns="0">
-            <a:spAutoFit/>
-          </a:bodyPr>
-          <a:lstStyle/>
-          <a:p>
-            <a:pPr algn="l">
-              <a:lnSpc>
-                <a:spcPct val="115000"/>
-              </a:lnSpc>
-              <a:spcAft>
-                <a:spcPts val="600"/>
-              </a:spcAft>
-            </a:pPr>
-            <a:r>
-              <a:rPr sz="1600" b="1">
-                <a:solidFill>
-                  <a:srgbClr val="101B33"/>
-                </a:solidFill>
-                <a:latin typeface="Arial"/>
-              </a:rPr>
-              <a:t>HẠN CHẾ</a:t>
-            </a:r>
-          </a:p>
-          <a:p>
-            <a:pPr algn="l">
-              <a:lnSpc>
-                <a:spcPct val="115000"/>
-              </a:lnSpc>
-              <a:spcAft>
-                <a:spcPts val="600"/>
-              </a:spcAft>
-            </a:pPr>
-            <a:r>
-              <a:rPr sz="1300" b="0">
-                <a:solidFill>
-                  <a:srgbClr val="5A6375"/>
-                </a:solidFill>
-                <a:latin typeface="Arial"/>
-              </a:rPr>
-              <a:t>
-· AdaIN chuyển thống kê TOÀN CỤC nên chưa phân biệt vùng trời / mặt đường — sương mù dày ở gần cũng như ở xa.
-· Không có bản đồ độ sâu thật; module vật lý dùng giả thiết mặt đường phẳng.
-· Chất lượng phụ thuộc ảnh tham chiếu: ảnh tham chiếu khác góc chụp quá nhiều sẽ cho tông màu lệch.
-· DAWN chỉ được dùng cho mục đích nghiên cứu, không dùng thương mại.</a:t>
-            </a:r>
-          </a:p>
-        </p:txBody>
-      </p:sp>
-      <p:sp>
-        <p:nvSpPr>
-          <p:cNvPr id="9" name="Rectangle 8"/>
-          <p:cNvSpPr/>
-          <p:nvPr/>
-        </p:nvSpPr>
-        <p:spPr>
-          <a:xfrm>
-            <a:off x="6355080" y="1371600"/>
-            <a:ext cx="5349240" cy="4480560"/>
-          </a:xfrm>
-          <a:prstGeom prst="rect">
-            <a:avLst/>
-          </a:prstGeom>
-          <a:solidFill>
-            <a:srgbClr val="F4F6FA"/>
-          </a:solidFill>
-          <a:ln>
-            <a:noFill/>
-          </a:ln>
-          <a:effectLst/>
-        </p:spPr>
-        <p:style>
-          <a:lnRef idx="1">
-            <a:schemeClr val="accent1"/>
-          </a:lnRef>
-          <a:fillRef idx="3">
-            <a:schemeClr val="accent1"/>
-          </a:fillRef>
-          <a:effectRef idx="2">
-            <a:schemeClr val="accent1"/>
-          </a:effectRef>
-          <a:fontRef idx="minor">
-            <a:schemeClr val="lt1"/>
-          </a:fontRef>
-        </p:style>
-        <p:txBody>
-          <a:bodyPr rtlCol="0" anchor="ctr"/>
-          <a:lstStyle/>
-          <a:p>
-            <a:pPr algn="ctr"/>
-          </a:p>
-        </p:txBody>
-      </p:sp>
-      <p:sp>
-        <p:nvSpPr>
-          <p:cNvPr id="10" name="Rectangle 9"/>
-          <p:cNvSpPr/>
-          <p:nvPr/>
-        </p:nvSpPr>
-        <p:spPr>
-          <a:xfrm>
-            <a:off x="6355080" y="1371600"/>
-            <a:ext cx="64008" cy="4480560"/>
-          </a:xfrm>
-          <a:prstGeom prst="rect">
-            <a:avLst/>
-          </a:prstGeom>
-          <a:solidFill>
-            <a:srgbClr val="18A099"/>
-          </a:solidFill>
-          <a:ln>
-            <a:noFill/>
-          </a:ln>
-          <a:effectLst/>
-        </p:spPr>
-        <p:style>
-          <a:lnRef idx="1">
-            <a:schemeClr val="accent1"/>
-          </a:lnRef>
-          <a:fillRef idx="3">
-            <a:schemeClr val="accent1"/>
-          </a:fillRef>
-          <a:effectRef idx="2">
-            <a:schemeClr val="accent1"/>
-          </a:effectRef>
-          <a:fontRef idx="minor">
-            <a:schemeClr val="lt1"/>
-          </a:fontRef>
-        </p:style>
-        <p:txBody>
-          <a:bodyPr rtlCol="0" anchor="ctr"/>
-          <a:lstStyle/>
-          <a:p>
-            <a:pPr algn="ctr"/>
-          </a:p>
-        </p:txBody>
-      </p:sp>
-      <p:sp>
-        <p:nvSpPr>
-          <p:cNvPr id="11" name="TextBox 10"/>
-          <p:cNvSpPr txBox="1"/>
-          <p:nvPr/>
-        </p:nvSpPr>
-        <p:spPr>
-          <a:xfrm>
-            <a:off x="6611112" y="1536192"/>
-            <a:ext cx="4892040" cy="4480560"/>
-          </a:xfrm>
-          <a:prstGeom prst="rect">
-            <a:avLst/>
-          </a:prstGeom>
-          <a:noFill/>
-        </p:spPr>
-        <p:txBody>
-          <a:bodyPr wrap="square" lIns="0" rIns="0">
-            <a:spAutoFit/>
-          </a:bodyPr>
-          <a:lstStyle/>
-          <a:p>
-            <a:pPr algn="l">
-              <a:lnSpc>
-                <a:spcPct val="115000"/>
-              </a:lnSpc>
-              <a:spcAft>
-                <a:spcPts val="600"/>
-              </a:spcAft>
-            </a:pPr>
-            <a:r>
-              <a:rPr sz="1600" b="1">
-                <a:solidFill>
-                  <a:srgbClr val="101B33"/>
-                </a:solidFill>
-                <a:latin typeface="Arial"/>
-              </a:rPr>
-              <a:t>HƯỚNG PHÁT TRIỂN</a:t>
-            </a:r>
-          </a:p>
-          <a:p>
-            <a:pPr algn="l">
-              <a:lnSpc>
-                <a:spcPct val="115000"/>
-              </a:lnSpc>
-              <a:spcAft>
-                <a:spcPts val="600"/>
-              </a:spcAft>
-            </a:pPr>
-            <a:r>
-              <a:rPr sz="1300" b="0">
-                <a:solidFill>
-                  <a:srgbClr val="5A6375"/>
-                </a:solidFill>
-                <a:latin typeface="Arial"/>
-              </a:rPr>
-              <a:t>
-· Thêm mặt nạ phân vùng trời / đường để đổi tông theo từng vùng.
-· Dùng mô hình ước lượng độ sâu đơn ảnh (Depth Anything) thay cho giả thiết phẳng.
-· Thay AdaIN bằng AdaAttN / WCT² để bám cấu trúc tốt hơn.
-· Thu thập ảnh tham chiếu thời tiết tại Việt Nam để khớp bối cảnh triển khai thực tế.
-· Mở rộng sang ban đêm, chói nắng ngược, đèn pha.</a:t>
-            </a:r>
-          </a:p>
-        </p:txBody>
-      </p:sp>
-    </p:spTree>
-  </p:cSld>
-  <p:clrMapOvr>
-    <a:masterClrMapping/>
-  </p:clrMapOvr>
-</p:sld>
-</file>
-
-<file path=ppt/slides/slide16.xml><?xml version="1.0" encoding="utf-8"?>
-<p:sld xmlns:a="http://schemas.openxmlformats.org/drawingml/2006/main" xmlns:p="http://schemas.openxmlformats.org/presentationml/2006/main" xmlns:r="http://schemas.openxmlformats.org/officeDocument/2006/relationships">
-  <p:cSld>
-    <p:spTree>
-      <p:nvGrpSpPr>
-        <p:cNvPr id="1" name=""/>
-        <p:cNvGrpSpPr/>
-        <p:nvPr/>
-      </p:nvGrpSpPr>
-      <p:grpSpPr/>
-      <p:sp>
-        <p:nvSpPr>
-          <p:cNvPr id="2" name="Rectangle 1"/>
-          <p:cNvSpPr/>
-          <p:nvPr/>
-        </p:nvSpPr>
-        <p:spPr>
-          <a:xfrm>
-            <a:off x="0" y="0"/>
-            <a:ext cx="12191695" cy="6858000"/>
-          </a:xfrm>
-          <a:prstGeom prst="rect">
-            <a:avLst/>
-          </a:prstGeom>
-          <a:solidFill>
-            <a:srgbClr val="101B33"/>
-          </a:solidFill>
-          <a:ln>
-            <a:noFill/>
-          </a:ln>
-          <a:effectLst/>
-        </p:spPr>
-        <p:style>
-          <a:lnRef idx="1">
-            <a:schemeClr val="accent1"/>
-          </a:lnRef>
-          <a:fillRef idx="3">
-            <a:schemeClr val="accent1"/>
-          </a:fillRef>
-          <a:effectRef idx="2">
-            <a:schemeClr val="accent1"/>
-          </a:effectRef>
-          <a:fontRef idx="minor">
-            <a:schemeClr val="lt1"/>
-          </a:fontRef>
-        </p:style>
-        <p:txBody>
-          <a:bodyPr rtlCol="0" anchor="ctr"/>
-          <a:lstStyle/>
-          <a:p>
-            <a:pPr algn="ctr"/>
-          </a:p>
-        </p:txBody>
-      </p:sp>
-      <p:sp>
-        <p:nvSpPr>
-          <p:cNvPr id="3" name="Rectangle 2"/>
-          <p:cNvSpPr/>
-          <p:nvPr/>
-        </p:nvSpPr>
-        <p:spPr>
-          <a:xfrm>
-            <a:off x="914400" y="1371600"/>
-            <a:ext cx="73152" cy="4206240"/>
-          </a:xfrm>
-          <a:prstGeom prst="rect">
-            <a:avLst/>
-          </a:prstGeom>
-          <a:solidFill>
-            <a:srgbClr val="18A099"/>
-          </a:solidFill>
-          <a:ln>
-            <a:noFill/>
-          </a:ln>
-          <a:effectLst/>
-        </p:spPr>
-        <p:style>
-          <a:lnRef idx="1">
-            <a:schemeClr val="accent1"/>
-          </a:lnRef>
-          <a:fillRef idx="3">
-            <a:schemeClr val="accent1"/>
-          </a:fillRef>
-          <a:effectRef idx="2">
-            <a:schemeClr val="accent1"/>
-          </a:effectRef>
-          <a:fontRef idx="minor">
-            <a:schemeClr val="lt1"/>
-          </a:fontRef>
-        </p:style>
-        <p:txBody>
-          <a:bodyPr rtlCol="0" anchor="ctr"/>
-          <a:lstStyle/>
-          <a:p>
-            <a:pPr algn="ctr"/>
-          </a:p>
-        </p:txBody>
-      </p:sp>
-      <p:sp>
-        <p:nvSpPr>
-          <p:cNvPr id="4" name="TextBox 3"/>
-          <p:cNvSpPr txBox="1"/>
-          <p:nvPr/>
-        </p:nvSpPr>
-        <p:spPr>
-          <a:xfrm>
-            <a:off x="1280160" y="1371600"/>
-            <a:ext cx="10058400" cy="4389120"/>
-          </a:xfrm>
-          <a:prstGeom prst="rect">
-            <a:avLst/>
-          </a:prstGeom>
-          <a:noFill/>
-        </p:spPr>
-        <p:txBody>
-          <a:bodyPr wrap="square" lIns="0" rIns="0">
-            <a:spAutoFit/>
-          </a:bodyPr>
-          <a:lstStyle/>
-          <a:p>
-            <a:pPr algn="l">
-              <a:lnSpc>
-                <a:spcPct val="115000"/>
-              </a:lnSpc>
-              <a:spcAft>
-                <a:spcPts val="600"/>
-              </a:spcAft>
-            </a:pPr>
-            <a:r>
-              <a:rPr sz="3400" b="1">
+              <a:t>KẾT LUẬN</a:t>
+            </a:r>
+          </a:p>
+          <a:p>
+            <a:pPr algn="l">
+              <a:lnSpc>
+                <a:spcPct val="115000"/>
+              </a:lnSpc>
+              <a:spcAft>
+                <a:spcPts val="600"/>
+              </a:spcAft>
+            </a:pPr>
+            <a:r>
+              <a:rPr sz="1000" b="0">
                 <a:solidFill>
                   <a:srgbClr val="FFFFFF"/>
                 </a:solidFill>
                 <a:latin typeface="Arial"/>
               </a:rPr>
-              <a:t>KẾT LUẬN</a:t>
+              <a:t/>
+            </a:r>
+          </a:p>
+          <a:p>
+            <a:pPr algn="l">
+              <a:lnSpc>
+                <a:spcPct val="115000"/>
+              </a:lnSpc>
+              <a:spcAft>
+                <a:spcPts val="600"/>
+              </a:spcAft>
+            </a:pPr>
+            <a:r>
+              <a:rPr sz="1800" b="0">
+                <a:solidFill>
+                  <a:srgbClr val="D5DEEC"/>
+                </a:solidFill>
+                <a:latin typeface="Arial"/>
+              </a:rPr>
+              <a:t>· Xây dựng trọn vẹn pipeline sinh ảnh giao thông thời tiết xấu từ 2 ảnh đầu vào, đúng yêu cầu đề bài.</a:t>
+            </a:r>
+          </a:p>
+          <a:p>
+            <a:pPr algn="l">
+              <a:lnSpc>
+                <a:spcPct val="115000"/>
+              </a:lnSpc>
+              <a:spcAft>
+                <a:spcPts val="600"/>
+              </a:spcAft>
+            </a:pPr>
+            <a:r>
+              <a:rPr sz="1800" b="0">
+                <a:solidFill>
+                  <a:srgbClr val="D5DEEC"/>
+                </a:solidFill>
+                <a:latin typeface="Arial"/>
+              </a:rPr>
+              <a:t>· Toàn bộ dùng mã nguồn mở; decoder chỉ 3,51 M tham số, huấn luyện 37 phút trên 1 GPU.</a:t>
+            </a:r>
+          </a:p>
+          <a:p>
+            <a:pPr algn="l">
+              <a:lnSpc>
+                <a:spcPct val="115000"/>
+              </a:lnSpc>
+              <a:spcAft>
+                <a:spcPts val="600"/>
+              </a:spcAft>
+            </a:pPr>
+            <a:r>
+              <a:rPr sz="1800" b="0">
+                <a:solidFill>
+                  <a:srgbClr val="D5DEEC"/>
+                </a:solidFill>
+                <a:latin typeface="Arial"/>
+              </a:rPr>
+              <a:t>· Nhãn bounding box tái sử dụng 100% — chi phí gán nhãn cho dữ liệu mới bằng 0.</a:t>
+            </a:r>
+          </a:p>
+          <a:p>
+            <a:pPr algn="l">
+              <a:lnSpc>
+                <a:spcPct val="115000"/>
+              </a:lnSpc>
+              <a:spcAft>
+                <a:spcPts val="600"/>
+              </a:spcAft>
+            </a:pPr>
+            <a:r>
+              <a:rPr sz="1800" b="0">
+                <a:solidFill>
+                  <a:srgbClr val="D5DEEC"/>
+                </a:solidFill>
+                <a:latin typeface="Arial"/>
+              </a:rPr>
+              <a:t>· Có kiểm chứng định lượng (SSIM/EdgeRecall/FID) và thí nghiệm downstream với YOLOv8.</a:t>
+            </a:r>
+          </a:p>
+          <a:p>
+            <a:pPr algn="l">
+              <a:lnSpc>
+                <a:spcPct val="115000"/>
+              </a:lnSpc>
+              <a:spcAft>
+                <a:spcPts val="600"/>
+              </a:spcAft>
+            </a:pPr>
+            <a:r>
+              <a:rPr sz="1800" b="0">
+                <a:solidFill>
+                  <a:srgbClr val="D5DEEC"/>
+                </a:solidFill>
+                <a:latin typeface="Arial"/>
+              </a:rPr>
+              <a:t>· Bàn giao: mã nguồn chạy được bằng 1 lệnh, web demo Gradio, mô hình đã huấn luyện,</a:t>
+            </a:r>
+          </a:p>
+          <a:p>
+            <a:pPr algn="l">
+              <a:lnSpc>
+                <a:spcPct val="115000"/>
+              </a:lnSpc>
+              <a:spcAft>
+                <a:spcPts val="600"/>
+              </a:spcAft>
+            </a:pPr>
+            <a:r>
+              <a:rPr sz="1800" b="0">
+                <a:solidFill>
+                  <a:srgbClr val="D5DEEC"/>
+                </a:solidFill>
+                <a:latin typeface="Arial"/>
+              </a:rPr>
+              <a:t>   báo cáo và slide — toàn bộ số liệu sinh tự động từ kết quả thật.</a:t>
             </a:r>
           </a:p>
           <a:p>
@@ -9236,127 +8221,13 @@
               </a:spcAft>
             </a:pPr>
             <a:r>
-              <a:rPr sz="1800" b="0">
-                <a:solidFill>
-                  <a:srgbClr val="D5DEEC"/>
-                </a:solidFill>
-                <a:latin typeface="Arial"/>
-              </a:rPr>
-              <a:t>· Xây dựng trọn vẹn pipeline sinh ảnh giao thông thời tiết xấu từ 2 ảnh đầu vào, đúng yêu cầu đề bài.</a:t>
-            </a:r>
-          </a:p>
-          <a:p>
-            <a:pPr algn="l">
-              <a:lnSpc>
-                <a:spcPct val="115000"/>
-              </a:lnSpc>
-              <a:spcAft>
-                <a:spcPts val="600"/>
-              </a:spcAft>
-            </a:pPr>
-            <a:r>
-              <a:rPr sz="1800" b="0">
-                <a:solidFill>
-                  <a:srgbClr val="D5DEEC"/>
-                </a:solidFill>
-                <a:latin typeface="Arial"/>
-              </a:rPr>
-              <a:t>· Toàn bộ dùng mã nguồn mở; decoder chỉ 3,51 M tham số, huấn luyện ~1 giờ trên 1 GPU.</a:t>
-            </a:r>
-          </a:p>
-          <a:p>
-            <a:pPr algn="l">
-              <a:lnSpc>
-                <a:spcPct val="115000"/>
-              </a:lnSpc>
-              <a:spcAft>
-                <a:spcPts val="600"/>
-              </a:spcAft>
-            </a:pPr>
-            <a:r>
-              <a:rPr sz="1800" b="0">
-                <a:solidFill>
-                  <a:srgbClr val="D5DEEC"/>
-                </a:solidFill>
-                <a:latin typeface="Arial"/>
-              </a:rPr>
-              <a:t>· Nhãn bounding box tái sử dụng 100% — chi phí gán nhãn cho dữ liệu mới bằng 0.</a:t>
-            </a:r>
-          </a:p>
-          <a:p>
-            <a:pPr algn="l">
-              <a:lnSpc>
-                <a:spcPct val="115000"/>
-              </a:lnSpc>
-              <a:spcAft>
-                <a:spcPts val="600"/>
-              </a:spcAft>
-            </a:pPr>
-            <a:r>
-              <a:rPr sz="1800" b="0">
-                <a:solidFill>
-                  <a:srgbClr val="D5DEEC"/>
-                </a:solidFill>
-                <a:latin typeface="Arial"/>
-              </a:rPr>
-              <a:t>· Có kiểm chứng định lượng (SSIM/EdgeRecall/FID) và thí nghiệm downstream với YOLOv8.</a:t>
-            </a:r>
-          </a:p>
-          <a:p>
-            <a:pPr algn="l">
-              <a:lnSpc>
-                <a:spcPct val="115000"/>
-              </a:lnSpc>
-              <a:spcAft>
-                <a:spcPts val="600"/>
-              </a:spcAft>
-            </a:pPr>
-            <a:r>
-              <a:rPr sz="1800" b="0">
-                <a:solidFill>
-                  <a:srgbClr val="D5DEEC"/>
-                </a:solidFill>
-                <a:latin typeface="Arial"/>
-              </a:rPr>
-              <a:t>· Kèm web demo trực quan, chạy toàn bộ quy trình bằng một lệnh.</a:t>
-            </a:r>
-          </a:p>
-          <a:p>
-            <a:pPr algn="l">
-              <a:lnSpc>
-                <a:spcPct val="115000"/>
-              </a:lnSpc>
-              <a:spcAft>
-                <a:spcPts val="600"/>
-              </a:spcAft>
-            </a:pPr>
-            <a:r>
-              <a:rPr sz="1200" b="0">
-                <a:solidFill>
-                  <a:srgbClr val="FFFFFF"/>
-                </a:solidFill>
-                <a:latin typeface="Arial"/>
-              </a:rPr>
-              <a:t/>
-            </a:r>
-          </a:p>
-          <a:p>
-            <a:pPr algn="l">
-              <a:lnSpc>
-                <a:spcPct val="115000"/>
-              </a:lnSpc>
-              <a:spcAft>
-                <a:spcPts val="600"/>
-              </a:spcAft>
-            </a:pPr>
-            <a:r>
               <a:rPr sz="2400" b="1">
                 <a:solidFill>
                   <a:srgbClr val="18A099"/>
                 </a:solidFill>
                 <a:latin typeface="Arial"/>
               </a:rPr>
-              <a:t>Xin cảm ơn!</a:t>
+              <a:t>Nhóm 6  —  Xin cảm ơn!</a:t>
             </a:r>
           </a:p>
         </p:txBody>
@@ -14207,7 +13078,7 @@
                 </a:solidFill>
                 <a:latin typeface="Arial"/>
               </a:rPr>
-              <a:t>8 / 20.000</a:t>
+              <a:t>8 / 12.000</a:t>
             </a:r>
           </a:p>
         </p:txBody>
@@ -14591,7 +13462,7 @@
                 </a:solidFill>
                 <a:latin typeface="Arial"/>
               </a:rPr>
-              <a:t>≈ 1 giờ (RTX 5060 Ti)</a:t>
+              <a:t>37 phút (RTX 5060 Ti)</a:t>
             </a:r>
           </a:p>
         </p:txBody>

</xml_diff>

<commit_message>
Làm rõ slide Dữ liệu: phân biệt "kho 10.000 ảnh có sẵn" và "số ảnh đã chọn ra"
Biểu đồ mô tả thống kê nhãn của toàn bộ 10.000 ảnh trong metadata BDD100K,
còn bảng liệt kê số ảnh thực sự tải về và dùng sau khi lọc (chỉ ban ngày,
có giới hạn số lượng). Trước đây hai con số đặt cạnh nhau không có câu nối
nên dễ hiểu nhầm là mâu thuẫn.

- Đổi tiêu đề biểu đồ thành "KHO CÓ SẴN" / "ĐÃ CHỌN RA".
- Thêm một dòng giải thích giữa biểu đồ và bảng.
- Bảng ghi rõ 800 ảnh mưa/tuyết được chia thành 300 tham chiếu + 500 test.
- Sửa số ảnh DAWN từ 1.000 thành 1.027 cho khớp thực tế.

Co-Authored-By: Claude Opus 5 (1M context) <noreply@anthropic.com>
</commit_message>
<xml_diff>
--- a/slides/BaoCao_TangCuongDuLieuThoiTiet.pptx
+++ b/slides/BaoCao_TangCuongDuLieuThoiTiet.pptx
@@ -9718,8 +9718,8 @@
         </p:blipFill>
         <p:spPr>
           <a:xfrm>
-            <a:off x="553720" y="1234440"/>
-            <a:ext cx="11054080" cy="2926080"/>
+            <a:off x="838775" y="1188720"/>
+            <a:ext cx="10483969" cy="2743199"/>
           </a:xfrm>
           <a:prstGeom prst="rect">
             <a:avLst/>
@@ -9728,13 +9728,55 @@
       </p:pic>
       <p:sp>
         <p:nvSpPr>
-          <p:cNvPr id="7" name="Rectangle 6"/>
+          <p:cNvPr id="7" name="TextBox 6"/>
+          <p:cNvSpPr txBox="1"/>
+          <p:nvPr/>
+        </p:nvSpPr>
+        <p:spPr>
+          <a:xfrm>
+            <a:off x="685800" y="3977639"/>
+            <a:ext cx="10789920" cy="365760"/>
+          </a:xfrm>
+          <a:prstGeom prst="rect">
+            <a:avLst/>
+          </a:prstGeom>
+          <a:noFill/>
+        </p:spPr>
+        <p:txBody>
+          <a:bodyPr wrap="square" lIns="0" rIns="0">
+            <a:spAutoFit/>
+          </a:bodyPr>
+          <a:lstStyle/>
+          <a:p>
+            <a:pPr algn="l">
+              <a:lnSpc>
+                <a:spcPct val="115000"/>
+              </a:lnSpc>
+              <a:spcAft>
+                <a:spcPts val="600"/>
+              </a:spcAft>
+            </a:pPr>
+            <a:r>
+              <a:rPr sz="1300" b="0">
+                <a:solidFill>
+                  <a:srgbClr val="5A6375"/>
+                </a:solidFill>
+                <a:latin typeface="Arial"/>
+              </a:rPr>
+              <a:t>Biểu đồ = kho 10.000 ảnh có sẵn để chọn.   Bảng = số ảnh đã LỌC RA và thực sự dùng (chỉ lấy ban ngày, giới hạn số lượng cho nhẹ).</a:t>
+            </a:r>
+          </a:p>
+        </p:txBody>
+      </p:sp>
+      <p:sp>
+        <p:nvSpPr>
+          <p:cNvPr id="8" name="Rectangle 7"/>
           <p:cNvSpPr/>
           <p:nvPr/>
         </p:nvSpPr>
         <p:spPr>
           <a:xfrm>
-            <a:off x="685800" y="4434840"/>
+            <a:off x="685800" y="4407408"/>
             <a:ext cx="10789920" cy="384048"/>
           </a:xfrm>
           <a:prstGeom prst="rect">
@@ -9772,14 +9814,14 @@
       </p:sp>
       <p:sp>
         <p:nvSpPr>
-          <p:cNvPr id="8" name="TextBox 7"/>
+          <p:cNvPr id="9" name="TextBox 8"/>
           <p:cNvSpPr txBox="1"/>
           <p:nvPr/>
         </p:nvSpPr>
         <p:spPr>
           <a:xfrm>
-            <a:off x="795528" y="4498848"/>
-            <a:ext cx="2312125" cy="384048"/>
+            <a:off x="795528" y="4471416"/>
+            <a:ext cx="2790496" cy="384048"/>
           </a:xfrm>
           <a:prstGeom prst="rect">
             <a:avLst/>
@@ -9801,27 +9843,27 @@
               </a:spcAft>
             </a:pPr>
             <a:r>
-              <a:rPr sz="1300" b="1">
+              <a:rPr sz="1200" b="1">
                 <a:solidFill>
                   <a:srgbClr val="FFFFFF"/>
                 </a:solidFill>
                 <a:latin typeface="Arial"/>
               </a:rPr>
-              <a:t>Bộ dữ liệu</a:t>
-            </a:r>
-          </a:p>
-        </p:txBody>
-      </p:sp>
-      <p:sp>
-        <p:nvSpPr>
-          <p:cNvPr id="9" name="TextBox 8"/>
+              <a:t>Đã chọn ra từ kho</a:t>
+            </a:r>
+          </a:p>
+        </p:txBody>
+      </p:sp>
+      <p:sp>
+        <p:nvSpPr>
+          <p:cNvPr id="10" name="TextBox 9"/>
           <p:cNvSpPr txBox="1"/>
           <p:nvPr/>
         </p:nvSpPr>
         <p:spPr>
           <a:xfrm>
-            <a:off x="3107653" y="4498848"/>
-            <a:ext cx="5009605" cy="384048"/>
+            <a:off x="3586024" y="4471416"/>
+            <a:ext cx="4650827" cy="384048"/>
           </a:xfrm>
           <a:prstGeom prst="rect">
             <a:avLst/>
@@ -9843,7 +9885,7 @@
               </a:spcAft>
             </a:pPr>
             <a:r>
-              <a:rPr sz="1300" b="1">
+              <a:rPr sz="1200" b="1">
                 <a:solidFill>
                   <a:srgbClr val="FFFFFF"/>
                 </a:solidFill>
@@ -9856,14 +9898,14 @@
       </p:sp>
       <p:sp>
         <p:nvSpPr>
-          <p:cNvPr id="10" name="TextBox 9"/>
+          <p:cNvPr id="11" name="TextBox 10"/>
           <p:cNvSpPr txBox="1"/>
           <p:nvPr/>
         </p:nvSpPr>
         <p:spPr>
           <a:xfrm>
-            <a:off x="8117258" y="4498848"/>
-            <a:ext cx="1637755" cy="384048"/>
+            <a:off x="8236851" y="4471416"/>
+            <a:ext cx="1581281" cy="384048"/>
           </a:xfrm>
           <a:prstGeom prst="rect">
             <a:avLst/>
@@ -9885,7 +9927,7 @@
               </a:spcAft>
             </a:pPr>
             <a:r>
-              <a:rPr sz="1300" b="1">
+              <a:rPr sz="1200" b="1">
                 <a:solidFill>
                   <a:srgbClr val="FFFFFF"/>
                 </a:solidFill>
@@ -9898,14 +9940,14 @@
       </p:sp>
       <p:sp>
         <p:nvSpPr>
-          <p:cNvPr id="11" name="TextBox 10"/>
+          <p:cNvPr id="12" name="TextBox 11"/>
           <p:cNvSpPr txBox="1"/>
           <p:nvPr/>
         </p:nvSpPr>
         <p:spPr>
           <a:xfrm>
-            <a:off x="9755013" y="4498848"/>
-            <a:ext cx="1830432" cy="384048"/>
+            <a:off x="9818132" y="4471416"/>
+            <a:ext cx="1767314" cy="384048"/>
           </a:xfrm>
           <a:prstGeom prst="rect">
             <a:avLst/>
@@ -9927,7 +9969,7 @@
               </a:spcAft>
             </a:pPr>
             <a:r>
-              <a:rPr sz="1300" b="1">
+              <a:rPr sz="1200" b="1">
                 <a:solidFill>
                   <a:srgbClr val="FFFFFF"/>
                 </a:solidFill>
@@ -9940,13 +9982,13 @@
       </p:sp>
       <p:sp>
         <p:nvSpPr>
-          <p:cNvPr id="12" name="Rectangle 11"/>
+          <p:cNvPr id="13" name="Rectangle 12"/>
           <p:cNvSpPr/>
           <p:nvPr/>
         </p:nvSpPr>
         <p:spPr>
           <a:xfrm>
-            <a:off x="685800" y="4818888"/>
+            <a:off x="685800" y="4791456"/>
             <a:ext cx="10789920" cy="384048"/>
           </a:xfrm>
           <a:prstGeom prst="rect">
@@ -9984,14 +10026,14 @@
       </p:sp>
       <p:sp>
         <p:nvSpPr>
-          <p:cNvPr id="13" name="TextBox 12"/>
+          <p:cNvPr id="14" name="TextBox 13"/>
           <p:cNvSpPr txBox="1"/>
           <p:nvPr/>
         </p:nvSpPr>
         <p:spPr>
           <a:xfrm>
-            <a:off x="795528" y="4882896"/>
-            <a:ext cx="2312125" cy="384048"/>
+            <a:off x="795528" y="4855464"/>
+            <a:ext cx="2790496" cy="384048"/>
           </a:xfrm>
           <a:prstGeom prst="rect">
             <a:avLst/>
@@ -10013,27 +10055,27 @@
               </a:spcAft>
             </a:pPr>
             <a:r>
-              <a:rPr sz="1300" b="0">
+              <a:rPr sz="1200" b="0">
                 <a:solidFill>
                   <a:srgbClr val="101B33"/>
                 </a:solidFill>
                 <a:latin typeface="Arial"/>
               </a:rPr>
-              <a:t>BDD100K (subset 10k)</a:t>
-            </a:r>
-          </a:p>
-        </p:txBody>
-      </p:sp>
-      <p:sp>
-        <p:nvSpPr>
-          <p:cNvPr id="14" name="TextBox 13"/>
+              <a:t>BDD100K — trời quang, ban ngày</a:t>
+            </a:r>
+          </a:p>
+        </p:txBody>
+      </p:sp>
+      <p:sp>
+        <p:nvSpPr>
+          <p:cNvPr id="15" name="TextBox 14"/>
           <p:cNvSpPr txBox="1"/>
           <p:nvPr/>
         </p:nvSpPr>
         <p:spPr>
           <a:xfrm>
-            <a:off x="3107653" y="4882896"/>
-            <a:ext cx="5009605" cy="384048"/>
+            <a:off x="3586024" y="4855464"/>
+            <a:ext cx="4650827" cy="384048"/>
           </a:xfrm>
           <a:prstGeom prst="rect">
             <a:avLst/>
@@ -10055,27 +10097,27 @@
               </a:spcAft>
             </a:pPr>
             <a:r>
-              <a:rPr sz="1300" b="0">
+              <a:rPr sz="1200" b="0">
                 <a:solidFill>
                   <a:srgbClr val="101B33"/>
                 </a:solidFill>
                 <a:latin typeface="Arial"/>
               </a:rPr>
-              <a:t>Ảnh nội dung (trời quang, ban ngày) + nhãn box</a:t>
-            </a:r>
-          </a:p>
-        </p:txBody>
-      </p:sp>
-      <p:sp>
-        <p:nvSpPr>
-          <p:cNvPr id="15" name="TextBox 14"/>
+              <a:t>Ảnh nội dung (đầu vào) + nhãn bounding box</a:t>
+            </a:r>
+          </a:p>
+        </p:txBody>
+      </p:sp>
+      <p:sp>
+        <p:nvSpPr>
+          <p:cNvPr id="16" name="TextBox 15"/>
           <p:cNvSpPr txBox="1"/>
           <p:nvPr/>
         </p:nvSpPr>
         <p:spPr>
           <a:xfrm>
-            <a:off x="8117258" y="4882896"/>
-            <a:ext cx="1637755" cy="384048"/>
+            <a:off x="8236851" y="4855464"/>
+            <a:ext cx="1581281" cy="384048"/>
           </a:xfrm>
           <a:prstGeom prst="rect">
             <a:avLst/>
@@ -10097,7 +10139,7 @@
               </a:spcAft>
             </a:pPr>
             <a:r>
-              <a:rPr sz="1300" b="0">
+              <a:rPr sz="1200" b="0">
                 <a:solidFill>
                   <a:srgbClr val="101B33"/>
                 </a:solidFill>
@@ -10110,14 +10152,14 @@
       </p:sp>
       <p:sp>
         <p:nvSpPr>
-          <p:cNvPr id="16" name="TextBox 15"/>
+          <p:cNvPr id="17" name="TextBox 16"/>
           <p:cNvSpPr txBox="1"/>
           <p:nvPr/>
         </p:nvSpPr>
         <p:spPr>
           <a:xfrm>
-            <a:off x="9755013" y="4882896"/>
-            <a:ext cx="1830432" cy="384048"/>
+            <a:off x="9818132" y="4855464"/>
+            <a:ext cx="1767314" cy="384048"/>
           </a:xfrm>
           <a:prstGeom prst="rect">
             <a:avLst/>
@@ -10139,7 +10181,7 @@
               </a:spcAft>
             </a:pPr>
             <a:r>
-              <a:rPr sz="1300" b="0">
+              <a:rPr sz="1200" b="0">
                 <a:solidFill>
                   <a:srgbClr val="101B33"/>
                 </a:solidFill>
@@ -10152,13 +10194,13 @@
       </p:sp>
       <p:sp>
         <p:nvSpPr>
-          <p:cNvPr id="17" name="Rectangle 16"/>
+          <p:cNvPr id="18" name="Rectangle 17"/>
           <p:cNvSpPr/>
           <p:nvPr/>
         </p:nvSpPr>
         <p:spPr>
           <a:xfrm>
-            <a:off x="685800" y="5202936"/>
+            <a:off x="685800" y="5175504"/>
             <a:ext cx="10789920" cy="384048"/>
           </a:xfrm>
           <a:prstGeom prst="rect">
@@ -10196,14 +10238,14 @@
       </p:sp>
       <p:sp>
         <p:nvSpPr>
-          <p:cNvPr id="18" name="TextBox 17"/>
+          <p:cNvPr id="19" name="TextBox 18"/>
           <p:cNvSpPr txBox="1"/>
           <p:nvPr/>
         </p:nvSpPr>
         <p:spPr>
           <a:xfrm>
-            <a:off x="795528" y="5266944"/>
-            <a:ext cx="2312125" cy="384048"/>
+            <a:off x="795528" y="5239512"/>
+            <a:ext cx="2790496" cy="384048"/>
           </a:xfrm>
           <a:prstGeom prst="rect">
             <a:avLst/>
@@ -10225,27 +10267,27 @@
               </a:spcAft>
             </a:pPr>
             <a:r>
-              <a:rPr sz="1300" b="0">
+              <a:rPr sz="1200" b="0">
                 <a:solidFill>
                   <a:srgbClr val="101B33"/>
                 </a:solidFill>
                 <a:latin typeface="Arial"/>
               </a:rPr>
-              <a:t>BDD100K (mưa / tuyết)</a:t>
-            </a:r>
-          </a:p>
-        </p:txBody>
-      </p:sp>
-      <p:sp>
-        <p:nvSpPr>
-          <p:cNvPr id="19" name="TextBox 18"/>
+              <a:t>BDD100K — mưa/tuyết, ban ngày</a:t>
+            </a:r>
+          </a:p>
+        </p:txBody>
+      </p:sp>
+      <p:sp>
+        <p:nvSpPr>
+          <p:cNvPr id="20" name="TextBox 19"/>
           <p:cNvSpPr txBox="1"/>
           <p:nvPr/>
         </p:nvSpPr>
         <p:spPr>
           <a:xfrm>
-            <a:off x="3107653" y="5266944"/>
-            <a:ext cx="5009605" cy="384048"/>
+            <a:off x="3586024" y="5239512"/>
+            <a:ext cx="4650827" cy="384048"/>
           </a:xfrm>
           <a:prstGeom prst="rect">
             <a:avLst/>
@@ -10267,27 +10309,27 @@
               </a:spcAft>
             </a:pPr>
             <a:r>
-              <a:rPr sz="1300" b="0">
+              <a:rPr sz="1200" b="0">
                 <a:solidFill>
                   <a:srgbClr val="101B33"/>
                 </a:solidFill>
                 <a:latin typeface="Arial"/>
               </a:rPr>
-              <a:t>Ảnh tham chiếu + tập test THẬT</a:t>
-            </a:r>
-          </a:p>
-        </p:txBody>
-      </p:sp>
-      <p:sp>
-        <p:nvSpPr>
-          <p:cNvPr id="20" name="TextBox 19"/>
+              <a:t>300 ảnh tham chiếu  +  500 ảnh tập test THẬT</a:t>
+            </a:r>
+          </a:p>
+        </p:txBody>
+      </p:sp>
+      <p:sp>
+        <p:nvSpPr>
+          <p:cNvPr id="21" name="TextBox 20"/>
           <p:cNvSpPr txBox="1"/>
           <p:nvPr/>
         </p:nvSpPr>
         <p:spPr>
           <a:xfrm>
-            <a:off x="8117258" y="5266944"/>
-            <a:ext cx="1637755" cy="384048"/>
+            <a:off x="8236851" y="5239512"/>
+            <a:ext cx="1581281" cy="384048"/>
           </a:xfrm>
           <a:prstGeom prst="rect">
             <a:avLst/>
@@ -10309,7 +10351,7 @@
               </a:spcAft>
             </a:pPr>
             <a:r>
-              <a:rPr sz="1300" b="0">
+              <a:rPr sz="1200" b="0">
                 <a:solidFill>
                   <a:srgbClr val="101B33"/>
                 </a:solidFill>
@@ -10322,14 +10364,14 @@
       </p:sp>
       <p:sp>
         <p:nvSpPr>
-          <p:cNvPr id="21" name="TextBox 20"/>
+          <p:cNvPr id="22" name="TextBox 21"/>
           <p:cNvSpPr txBox="1"/>
           <p:nvPr/>
         </p:nvSpPr>
         <p:spPr>
           <a:xfrm>
-            <a:off x="9755013" y="5266944"/>
-            <a:ext cx="1830432" cy="384048"/>
+            <a:off x="9818132" y="5239512"/>
+            <a:ext cx="1767314" cy="384048"/>
           </a:xfrm>
           <a:prstGeom prst="rect">
             <a:avLst/>
@@ -10351,7 +10393,7 @@
               </a:spcAft>
             </a:pPr>
             <a:r>
-              <a:rPr sz="1300" b="0">
+              <a:rPr sz="1200" b="0">
                 <a:solidFill>
                   <a:srgbClr val="101B33"/>
                 </a:solidFill>
@@ -10364,13 +10406,13 @@
       </p:sp>
       <p:sp>
         <p:nvSpPr>
-          <p:cNvPr id="22" name="Rectangle 21"/>
+          <p:cNvPr id="23" name="Rectangle 22"/>
           <p:cNvSpPr/>
           <p:nvPr/>
         </p:nvSpPr>
         <p:spPr>
           <a:xfrm>
-            <a:off x="685800" y="5586984"/>
+            <a:off x="685800" y="5559552"/>
             <a:ext cx="10789920" cy="384048"/>
           </a:xfrm>
           <a:prstGeom prst="rect">
@@ -10408,14 +10450,14 @@
       </p:sp>
       <p:sp>
         <p:nvSpPr>
-          <p:cNvPr id="23" name="TextBox 22"/>
+          <p:cNvPr id="24" name="TextBox 23"/>
           <p:cNvSpPr txBox="1"/>
           <p:nvPr/>
         </p:nvSpPr>
         <p:spPr>
           <a:xfrm>
-            <a:off x="795528" y="5650992"/>
-            <a:ext cx="2312125" cy="384048"/>
+            <a:off x="795528" y="5623560"/>
+            <a:ext cx="2790496" cy="384048"/>
           </a:xfrm>
           <a:prstGeom prst="rect">
             <a:avLst/>
@@ -10437,7 +10479,7 @@
               </a:spcAft>
             </a:pPr>
             <a:r>
-              <a:rPr sz="1300" b="0">
+              <a:rPr sz="1200" b="0">
                 <a:solidFill>
                   <a:srgbClr val="101B33"/>
                 </a:solidFill>
@@ -10450,14 +10492,14 @@
       </p:sp>
       <p:sp>
         <p:nvSpPr>
-          <p:cNvPr id="24" name="TextBox 23"/>
+          <p:cNvPr id="25" name="TextBox 24"/>
           <p:cNvSpPr txBox="1"/>
           <p:nvPr/>
         </p:nvSpPr>
         <p:spPr>
           <a:xfrm>
-            <a:off x="3107653" y="5650992"/>
-            <a:ext cx="5009605" cy="384048"/>
+            <a:off x="3586024" y="5623560"/>
+            <a:ext cx="4650827" cy="384048"/>
           </a:xfrm>
           <a:prstGeom prst="rect">
             <a:avLst/>
@@ -10479,7 +10521,7 @@
               </a:spcAft>
             </a:pPr>
             <a:r>
-              <a:rPr sz="1300" b="0">
+              <a:rPr sz="1200" b="0">
                 <a:solidFill>
                   <a:srgbClr val="101B33"/>
                 </a:solidFill>
@@ -10492,14 +10534,14 @@
       </p:sp>
       <p:sp>
         <p:nvSpPr>
-          <p:cNvPr id="25" name="TextBox 24"/>
+          <p:cNvPr id="26" name="TextBox 25"/>
           <p:cNvSpPr txBox="1"/>
           <p:nvPr/>
         </p:nvSpPr>
         <p:spPr>
           <a:xfrm>
-            <a:off x="8117258" y="5650992"/>
-            <a:ext cx="1637755" cy="384048"/>
+            <a:off x="8236851" y="5623560"/>
+            <a:ext cx="1581281" cy="384048"/>
           </a:xfrm>
           <a:prstGeom prst="rect">
             <a:avLst/>
@@ -10521,27 +10563,27 @@
               </a:spcAft>
             </a:pPr>
             <a:r>
-              <a:rPr sz="1300" b="0">
+              <a:rPr sz="1200" b="0">
                 <a:solidFill>
                   <a:srgbClr val="101B33"/>
                 </a:solidFill>
                 <a:latin typeface="Arial"/>
               </a:rPr>
-              <a:t>1.000 ảnh</a:t>
-            </a:r>
-          </a:p>
-        </p:txBody>
-      </p:sp>
-      <p:sp>
-        <p:nvSpPr>
-          <p:cNvPr id="26" name="TextBox 25"/>
+              <a:t>1.027 ảnh</a:t>
+            </a:r>
+          </a:p>
+        </p:txBody>
+      </p:sp>
+      <p:sp>
+        <p:nvSpPr>
+          <p:cNvPr id="27" name="TextBox 26"/>
           <p:cNvSpPr txBox="1"/>
           <p:nvPr/>
         </p:nvSpPr>
         <p:spPr>
           <a:xfrm>
-            <a:off x="9755013" y="5650992"/>
-            <a:ext cx="1830432" cy="384048"/>
+            <a:off x="9818132" y="5623560"/>
+            <a:ext cx="1767314" cy="384048"/>
           </a:xfrm>
           <a:prstGeom prst="rect">
             <a:avLst/>
@@ -10563,7 +10605,7 @@
               </a:spcAft>
             </a:pPr>
             <a:r>
-              <a:rPr sz="1300" b="0">
+              <a:rPr sz="1200" b="0">
                 <a:solidFill>
                   <a:srgbClr val="101B33"/>
                 </a:solidFill>

</xml_diff>

<commit_message>
Thêm slide và mục báo cáo về ảnh mẫu dữ liệu + định dạng nhãn
Người xem chưa hình dung được dữ liệu trông thế nào và nhãn ra sao, nên bổ sung:

- assets/fig_data_samples.jpg: 5 ảnh nội dung (ảnh đầu vẽ sẵn bounding box)
  và 5 ảnh tham chiếu kèm tên loại thời tiết.
- Slide mới "Dữ liệu — ảnh mẫu & định dạng nhãn": ảnh mẫu, 3 loại nhãn của
  BDD100K, và ví dụ file nhãn YOLO thật.
- Báo cáo mục 4: bảng mô tả 3 loại nhãn, tổng 62.468 bounding box / 10 lớp,
  kèm ví dụ định dạng file .txt.
- Bỏ slide "Điều khiển cường độ alpha" để giữ đúng giới hạn 15 trang
  (nội dung alpha vẫn còn trong báo cáo).

Co-Authored-By: Claude Opus 5 (1M context) <noreply@anthropic.com>
</commit_message>
<xml_diff>
--- a/slides/BaoCao_TangCuongDuLieuThoiTiet.pptx
+++ b/slides/BaoCao_TangCuongDuLieuThoiTiet.pptx
@@ -10759,7 +10759,7 @@
                 </a:solidFill>
                 <a:latin typeface="Arial"/>
               </a:rPr>
-              <a:t>Phương pháp — 3 khối nối tiếp</a:t>
+              <a:t>Dữ liệu — ảnh mẫu &amp; định dạng nhãn</a:t>
             </a:r>
           </a:p>
           <a:p>
@@ -10778,7 +10778,7 @@
                 </a:solidFill>
                 <a:latin typeface="Arial"/>
               </a:rPr>
-              <a:t>Mỗi khối bù đúng một điểm yếu của khối trước</a:t>
+              <a:t>Hai loại ảnh đầu vào, và nhãn đi kèm mỗi ảnh nội dung</a:t>
             </a:r>
           </a:p>
         </p:txBody>
@@ -10825,16 +10825,40 @@
           </a:p>
         </p:txBody>
       </p:sp>
-      <p:sp>
-        <p:nvSpPr>
-          <p:cNvPr id="6" name="Rectangle 5"/>
+      <p:pic>
+        <p:nvPicPr>
+          <p:cNvPr id="6" name="Picture 5" descr="fig_data_samples.jpg"/>
+          <p:cNvPicPr>
+            <a:picLocks noChangeAspect="1"/>
+          </p:cNvPicPr>
+          <p:nvPr/>
+        </p:nvPicPr>
+        <p:blipFill>
+          <a:blip r:embed="rId2"/>
+          <a:stretch>
+            <a:fillRect/>
+          </a:stretch>
+        </p:blipFill>
+        <p:spPr>
+          <a:xfrm>
+            <a:off x="823878" y="1170432"/>
+            <a:ext cx="10513763" cy="3200400"/>
+          </a:xfrm>
+          <a:prstGeom prst="rect">
+            <a:avLst/>
+          </a:prstGeom>
+        </p:spPr>
+      </p:pic>
+      <p:sp>
+        <p:nvSpPr>
+          <p:cNvPr id="7" name="Rectangle 6"/>
           <p:cNvSpPr/>
           <p:nvPr/>
         </p:nvSpPr>
         <p:spPr>
           <a:xfrm>
-            <a:off x="548640" y="1371600"/>
-            <a:ext cx="3337560" cy="3017520"/>
+            <a:off x="640080" y="4526280"/>
+            <a:ext cx="5394960" cy="1783080"/>
           </a:xfrm>
           <a:prstGeom prst="rect">
             <a:avLst/>
@@ -10871,14 +10895,14 @@
       </p:sp>
       <p:sp>
         <p:nvSpPr>
-          <p:cNvPr id="7" name="Rectangle 6"/>
+          <p:cNvPr id="8" name="Rectangle 7"/>
           <p:cNvSpPr/>
           <p:nvPr/>
         </p:nvSpPr>
         <p:spPr>
           <a:xfrm>
-            <a:off x="548640" y="1371600"/>
-            <a:ext cx="3337560" cy="82296"/>
+            <a:off x="640080" y="4526280"/>
+            <a:ext cx="64008" cy="1783080"/>
           </a:xfrm>
           <a:prstGeom prst="rect">
             <a:avLst/>
@@ -10915,14 +10939,14 @@
       </p:sp>
       <p:sp>
         <p:nvSpPr>
-          <p:cNvPr id="8" name="TextBox 7"/>
+          <p:cNvPr id="9" name="TextBox 8"/>
           <p:cNvSpPr txBox="1"/>
           <p:nvPr/>
         </p:nvSpPr>
         <p:spPr>
           <a:xfrm>
-            <a:off x="777240" y="1600200"/>
-            <a:ext cx="2926080" cy="2743200"/>
+            <a:off x="896112" y="4690872"/>
+            <a:ext cx="4937760" cy="1783080"/>
           </a:xfrm>
           <a:prstGeom prst="rect">
             <a:avLst/>
@@ -10944,13 +10968,13 @@
               </a:spcAft>
             </a:pPr>
             <a:r>
-              <a:rPr sz="1700" b="1">
+              <a:rPr sz="1600" b="1">
                 <a:solidFill>
                   <a:srgbClr val="101B33"/>
                 </a:solidFill>
                 <a:latin typeface="Arial"/>
               </a:rPr>
-              <a:t>① AdaIN  (học sâu)</a:t>
+              <a:t>MỖI ẢNH NỘI DUNG CÓ 3 LOẠI NHÃN</a:t>
             </a:r>
           </a:p>
           <a:p>
@@ -10969,28 +10993,30 @@
                 </a:solidFill>
                 <a:latin typeface="Arial"/>
               </a:rPr>
-              <a:t>Chuẩn hoá đặc trưng VGG của ảnh gốc rồi nhuộm lại bằng mean/std của ảnh thời tiết.
-→ Đổi tông màu, độ sáng, độ mù toàn cục.</a:t>
-            </a:r>
-          </a:p>
-        </p:txBody>
-      </p:sp>
-      <p:sp>
-        <p:nvSpPr>
-          <p:cNvPr id="9" name="Rectangle 8"/>
+              <a:t>· weather   — clear / overcast / rainy / snowy / foggy …
+· timeofday — daytime / night / dawn-dusk
+· bounding box — 10 lớp (car, pedestrian, traffic sign …)
+   62.468 box trên 3.200 ảnh, trung bình ~20 box/ảnh</a:t>
+            </a:r>
+          </a:p>
+        </p:txBody>
+      </p:sp>
+      <p:sp>
+        <p:nvSpPr>
+          <p:cNvPr id="10" name="Rectangle 9"/>
           <p:cNvSpPr/>
           <p:nvPr/>
         </p:nvSpPr>
         <p:spPr>
           <a:xfrm>
-            <a:off x="4434840" y="1371600"/>
-            <a:ext cx="3337560" cy="3017520"/>
+            <a:off x="6400800" y="4526280"/>
+            <a:ext cx="5120640" cy="1783080"/>
           </a:xfrm>
           <a:prstGeom prst="rect">
             <a:avLst/>
           </a:prstGeom>
           <a:solidFill>
-            <a:srgbClr val="F4F6FA"/>
+            <a:srgbClr val="101B33"/>
           </a:solidFill>
           <a:ln>
             <a:noFill/>
@@ -11021,58 +11047,14 @@
       </p:sp>
       <p:sp>
         <p:nvSpPr>
-          <p:cNvPr id="10" name="Rectangle 9"/>
-          <p:cNvSpPr/>
-          <p:nvPr/>
-        </p:nvSpPr>
-        <p:spPr>
-          <a:xfrm>
-            <a:off x="4434840" y="1371600"/>
-            <a:ext cx="3337560" cy="82296"/>
-          </a:xfrm>
-          <a:prstGeom prst="rect">
-            <a:avLst/>
-          </a:prstGeom>
-          <a:solidFill>
-            <a:srgbClr val="18A099"/>
-          </a:solidFill>
-          <a:ln>
-            <a:noFill/>
-          </a:ln>
-          <a:effectLst/>
-        </p:spPr>
-        <p:style>
-          <a:lnRef idx="1">
-            <a:schemeClr val="accent1"/>
-          </a:lnRef>
-          <a:fillRef idx="3">
-            <a:schemeClr val="accent1"/>
-          </a:fillRef>
-          <a:effectRef idx="2">
-            <a:schemeClr val="accent1"/>
-          </a:effectRef>
-          <a:fontRef idx="minor">
-            <a:schemeClr val="lt1"/>
-          </a:fontRef>
-        </p:style>
-        <p:txBody>
-          <a:bodyPr rtlCol="0" anchor="ctr"/>
-          <a:lstStyle/>
-          <a:p>
-            <a:pPr algn="ctr"/>
-          </a:p>
-        </p:txBody>
-      </p:sp>
-      <p:sp>
-        <p:nvSpPr>
           <p:cNvPr id="11" name="TextBox 10"/>
           <p:cNvSpPr txBox="1"/>
           <p:nvPr/>
         </p:nvSpPr>
         <p:spPr>
           <a:xfrm>
-            <a:off x="4663440" y="1600200"/>
-            <a:ext cx="2926080" cy="2743200"/>
+            <a:off x="6629400" y="4663440"/>
+            <a:ext cx="4754880" cy="1645920"/>
           </a:xfrm>
           <a:prstGeom prst="rect">
             <a:avLst/>
@@ -11087,26 +11069,26 @@
           <a:p>
             <a:pPr algn="l">
               <a:lnSpc>
-                <a:spcPct val="115000"/>
-              </a:lnSpc>
-              <a:spcAft>
-                <a:spcPts val="600"/>
-              </a:spcAft>
-            </a:pPr>
-            <a:r>
-              <a:rPr sz="1700" b="1">
-                <a:solidFill>
-                  <a:srgbClr val="101B33"/>
-                </a:solidFill>
-                <a:latin typeface="Arial"/>
-              </a:rPr>
-              <a:t>② Guided Filter</a:t>
-            </a:r>
-          </a:p>
-          <a:p>
-            <a:pPr algn="l">
-              <a:lnSpc>
-                <a:spcPct val="115000"/>
+                <a:spcPct val="110000"/>
+              </a:lnSpc>
+              <a:spcAft>
+                <a:spcPts val="600"/>
+              </a:spcAft>
+            </a:pPr>
+            <a:r>
+              <a:rPr sz="1500" b="1">
+                <a:solidFill>
+                  <a:srgbClr val="18A099"/>
+                </a:solidFill>
+                <a:latin typeface="Arial"/>
+              </a:rPr>
+              <a:t>ĐỊNH DẠNG NHÃN (YOLO)</a:t>
+            </a:r>
+          </a:p>
+          <a:p>
+            <a:pPr algn="l">
+              <a:lnSpc>
+                <a:spcPct val="110000"/>
               </a:lnSpc>
               <a:spcAft>
                 <a:spcPts val="600"/>
@@ -11115,149 +11097,17 @@
             <a:r>
               <a:rPr sz="1300" b="0">
                 <a:solidFill>
-                  <a:srgbClr val="5A6375"/>
-                </a:solidFill>
-                <a:latin typeface="Arial"/>
-              </a:rPr>
-              <a:t>Dùng ảnh gốc làm ảnh dẫn hướng, lọc tuyến tính cục bộ q = a·I + b.
-Bán kính lớn (32) → a, b mượt → đầu ra = ẢNH GỐC nhân trường tương phản + lệch màu.
-→ Giữ 100% chi tiết ảnh chụp, chỉ đổi tông thời tiết.</a:t>
-            </a:r>
-          </a:p>
-        </p:txBody>
-      </p:sp>
-      <p:sp>
-        <p:nvSpPr>
-          <p:cNvPr id="12" name="Rectangle 11"/>
-          <p:cNvSpPr/>
-          <p:nvPr/>
-        </p:nvSpPr>
-        <p:spPr>
-          <a:xfrm>
-            <a:off x="8321040" y="1371600"/>
-            <a:ext cx="3337560" cy="3017520"/>
-          </a:xfrm>
-          <a:prstGeom prst="rect">
-            <a:avLst/>
-          </a:prstGeom>
-          <a:solidFill>
-            <a:srgbClr val="F4F6FA"/>
-          </a:solidFill>
-          <a:ln>
-            <a:noFill/>
-          </a:ln>
-          <a:effectLst/>
-        </p:spPr>
-        <p:style>
-          <a:lnRef idx="1">
-            <a:schemeClr val="accent1"/>
-          </a:lnRef>
-          <a:fillRef idx="3">
-            <a:schemeClr val="accent1"/>
-          </a:fillRef>
-          <a:effectRef idx="2">
-            <a:schemeClr val="accent1"/>
-          </a:effectRef>
-          <a:fontRef idx="minor">
-            <a:schemeClr val="lt1"/>
-          </a:fontRef>
-        </p:style>
-        <p:txBody>
-          <a:bodyPr rtlCol="0" anchor="ctr"/>
-          <a:lstStyle/>
-          <a:p>
-            <a:pPr algn="ctr"/>
-          </a:p>
-        </p:txBody>
-      </p:sp>
-      <p:sp>
-        <p:nvSpPr>
-          <p:cNvPr id="13" name="Rectangle 12"/>
-          <p:cNvSpPr/>
-          <p:nvPr/>
-        </p:nvSpPr>
-        <p:spPr>
-          <a:xfrm>
-            <a:off x="8321040" y="1371600"/>
-            <a:ext cx="3337560" cy="82296"/>
-          </a:xfrm>
-          <a:prstGeom prst="rect">
-            <a:avLst/>
-          </a:prstGeom>
-          <a:solidFill>
-            <a:srgbClr val="E48A2E"/>
-          </a:solidFill>
-          <a:ln>
-            <a:noFill/>
-          </a:ln>
-          <a:effectLst/>
-        </p:spPr>
-        <p:style>
-          <a:lnRef idx="1">
-            <a:schemeClr val="accent1"/>
-          </a:lnRef>
-          <a:fillRef idx="3">
-            <a:schemeClr val="accent1"/>
-          </a:fillRef>
-          <a:effectRef idx="2">
-            <a:schemeClr val="accent1"/>
-          </a:effectRef>
-          <a:fontRef idx="minor">
-            <a:schemeClr val="lt1"/>
-          </a:fontRef>
-        </p:style>
-        <p:txBody>
-          <a:bodyPr rtlCol="0" anchor="ctr"/>
-          <a:lstStyle/>
-          <a:p>
-            <a:pPr algn="ctr"/>
-          </a:p>
-        </p:txBody>
-      </p:sp>
-      <p:sp>
-        <p:nvSpPr>
-          <p:cNvPr id="14" name="TextBox 13"/>
-          <p:cNvSpPr txBox="1"/>
-          <p:nvPr/>
-        </p:nvSpPr>
-        <p:spPr>
-          <a:xfrm>
-            <a:off x="8549640" y="1600200"/>
-            <a:ext cx="2926080" cy="2743200"/>
-          </a:xfrm>
-          <a:prstGeom prst="rect">
-            <a:avLst/>
-          </a:prstGeom>
-          <a:noFill/>
-        </p:spPr>
-        <p:txBody>
-          <a:bodyPr wrap="square" lIns="0" rIns="0">
-            <a:spAutoFit/>
-          </a:bodyPr>
-          <a:lstStyle/>
-          <a:p>
-            <a:pPr algn="l">
-              <a:lnSpc>
-                <a:spcPct val="115000"/>
-              </a:lnSpc>
-              <a:spcAft>
-                <a:spcPts val="600"/>
-              </a:spcAft>
-            </a:pPr>
-            <a:r>
-              <a:rPr sz="1700" b="1">
-                <a:solidFill>
-                  <a:srgbClr val="101B33"/>
-                </a:solidFill>
-                <a:latin typeface="Arial"/>
-              </a:rPr>
-              <a:t>③ Phủ hạt (vật lý)</a:t>
-            </a:r>
-          </a:p>
-          <a:p>
-            <a:pPr algn="l">
-              <a:lnSpc>
-                <a:spcPct val="115000"/>
+                  <a:srgbClr val="9FB0C8"/>
+                </a:solidFill>
+                <a:latin typeface="Arial"/>
+              </a:rPr>
+              <a:t>b1c66a42-6f7d68ca.txt</a:t>
+            </a:r>
+          </a:p>
+          <a:p>
+            <a:pPr algn="l">
+              <a:lnSpc>
+                <a:spcPct val="110000"/>
               </a:lnSpc>
               <a:spcAft>
                 <a:spcPts val="600"/>
@@ -11266,73 +11116,49 @@
             <a:r>
               <a:rPr sz="1300" b="0">
                 <a:solidFill>
-                  <a:srgbClr val="5A6375"/>
-                </a:solidFill>
-                <a:latin typeface="Arial"/>
-              </a:rPr>
-              <a:t>Sinh vệt mưa (nhiễu + motion blur) và bông tuyết (3 lớp độ sâu), phủ theo chế độ screen.
-→ Thêm chi tiết cục bộ mà AdaIN không tạo ra được.</a:t>
-            </a:r>
-          </a:p>
-        </p:txBody>
-      </p:sp>
-      <p:sp>
-        <p:nvSpPr>
-          <p:cNvPr id="15" name="TextBox 14"/>
-          <p:cNvSpPr txBox="1"/>
-          <p:nvPr/>
-        </p:nvSpPr>
-        <p:spPr>
-          <a:xfrm>
-            <a:off x="548640" y="4617720"/>
-            <a:ext cx="11064240" cy="1463040"/>
-          </a:xfrm>
-          <a:prstGeom prst="rect">
-            <a:avLst/>
-          </a:prstGeom>
-          <a:noFill/>
-        </p:spPr>
-        <p:txBody>
-          <a:bodyPr wrap="square" lIns="0" rIns="0">
-            <a:spAutoFit/>
-          </a:bodyPr>
-          <a:lstStyle/>
-          <a:p>
-            <a:pPr algn="l">
-              <a:lnSpc>
-                <a:spcPct val="115000"/>
-              </a:lnSpc>
-              <a:spcAft>
-                <a:spcPts val="600"/>
-              </a:spcAft>
-            </a:pPr>
-            <a:r>
-              <a:rPr sz="1900" b="1">
-                <a:solidFill>
-                  <a:srgbClr val="101B33"/>
-                </a:solidFill>
-                <a:latin typeface="Arial"/>
-              </a:rPr>
-              <a:t>Vì sao nhãn bounding box vẫn dùng lại được?</a:t>
-            </a:r>
-          </a:p>
-          <a:p>
-            <a:pPr algn="l">
-              <a:lnSpc>
-                <a:spcPct val="115000"/>
-              </a:lnSpc>
-              <a:spcAft>
-                <a:spcPts val="600"/>
-              </a:spcAft>
-            </a:pPr>
-            <a:r>
-              <a:rPr sz="1500" b="0">
-                <a:solidFill>
-                  <a:srgbClr val="5A6375"/>
-                </a:solidFill>
-                <a:latin typeface="Arial"/>
-              </a:rPr>
-              <a:t>Cả 3 khối chỉ thay đổi GIÁ TRỊ MÀU tại từng pixel — không dịch chuyển, không co giãn, không xoay vật thể. Vị trí chiếc xe trong ảnh đầu ra trùng khít vị trí trong ảnh gốc, nên toàn bộ nhãn cũ được sao chép nguyên vẹn. Chi phí gán nhãn cho dữ liệu mới = 0.</a:t>
+                  <a:srgbClr val="FFFFFF"/>
+                </a:solidFill>
+                <a:latin typeface="Arial"/>
+              </a:rPr>
+              <a:t>2  0.482  0.531  0.061  0.088     → car</a:t>
+            </a:r>
+          </a:p>
+          <a:p>
+            <a:pPr algn="l">
+              <a:lnSpc>
+                <a:spcPct val="110000"/>
+              </a:lnSpc>
+              <a:spcAft>
+                <a:spcPts val="600"/>
+              </a:spcAft>
+            </a:pPr>
+            <a:r>
+              <a:rPr sz="1300" b="0">
+                <a:solidFill>
+                  <a:srgbClr val="FFFFFF"/>
+                </a:solidFill>
+                <a:latin typeface="Arial"/>
+              </a:rPr>
+              <a:t>9  0.781  0.391  0.031  0.062     → traffic sign</a:t>
+            </a:r>
+          </a:p>
+          <a:p>
+            <a:pPr algn="l">
+              <a:lnSpc>
+                <a:spcPct val="110000"/>
+              </a:lnSpc>
+              <a:spcAft>
+                <a:spcPts val="600"/>
+              </a:spcAft>
+            </a:pPr>
+            <a:r>
+              <a:rPr sz="1200" b="0">
+                <a:solidFill>
+                  <a:srgbClr val="9FB0C8"/>
+                </a:solidFill>
+                <a:latin typeface="Arial"/>
+              </a:rPr>
+              <a:t>lớp   x_tâm   y_tâm   rộng   cao   (đã chuẩn hoá 0–1)</a:t>
             </a:r>
           </a:p>
         </p:txBody>
@@ -11480,7 +11306,7 @@
                 </a:solidFill>
                 <a:latin typeface="Arial"/>
               </a:rPr>
-              <a:t>① AdaIN — trái tim của phương pháp</a:t>
+              <a:t>Phương pháp — 3 khối nối tiếp</a:t>
             </a:r>
           </a:p>
           <a:p>
@@ -11499,7 +11325,7 @@
                 </a:solidFill>
                 <a:latin typeface="Arial"/>
               </a:rPr>
-              <a:t>Huang &amp; Belongie, ICCV 2017</a:t>
+              <a:t>Mỗi khối bù đúng một điểm yếu của khối trước</a:t>
             </a:r>
           </a:p>
         </p:txBody>
@@ -11554,14 +11380,14 @@
         </p:nvSpPr>
         <p:spPr>
           <a:xfrm>
-            <a:off x="640080" y="1371600"/>
-            <a:ext cx="10881360" cy="1234440"/>
+            <a:off x="548640" y="1371600"/>
+            <a:ext cx="3337560" cy="3017520"/>
           </a:xfrm>
           <a:prstGeom prst="rect">
             <a:avLst/>
           </a:prstGeom>
           <a:solidFill>
-            <a:srgbClr val="101B33"/>
+            <a:srgbClr val="F4F6FA"/>
           </a:solidFill>
           <a:ln>
             <a:noFill/>
@@ -11592,14 +11418,58 @@
       </p:sp>
       <p:sp>
         <p:nvSpPr>
-          <p:cNvPr id="7" name="TextBox 6"/>
+          <p:cNvPr id="7" name="Rectangle 6"/>
+          <p:cNvSpPr/>
+          <p:nvPr/>
+        </p:nvSpPr>
+        <p:spPr>
+          <a:xfrm>
+            <a:off x="548640" y="1371600"/>
+            <a:ext cx="3337560" cy="82296"/>
+          </a:xfrm>
+          <a:prstGeom prst="rect">
+            <a:avLst/>
+          </a:prstGeom>
+          <a:solidFill>
+            <a:srgbClr val="2E6FD9"/>
+          </a:solidFill>
+          <a:ln>
+            <a:noFill/>
+          </a:ln>
+          <a:effectLst/>
+        </p:spPr>
+        <p:style>
+          <a:lnRef idx="1">
+            <a:schemeClr val="accent1"/>
+          </a:lnRef>
+          <a:fillRef idx="3">
+            <a:schemeClr val="accent1"/>
+          </a:fillRef>
+          <a:effectRef idx="2">
+            <a:schemeClr val="accent1"/>
+          </a:effectRef>
+          <a:fontRef idx="minor">
+            <a:schemeClr val="lt1"/>
+          </a:fontRef>
+        </p:style>
+        <p:txBody>
+          <a:bodyPr rtlCol="0" anchor="ctr"/>
+          <a:lstStyle/>
+          <a:p>
+            <a:pPr algn="ctr"/>
+          </a:p>
+        </p:txBody>
+      </p:sp>
+      <p:sp>
+        <p:nvSpPr>
+          <p:cNvPr id="8" name="TextBox 7"/>
           <p:cNvSpPr txBox="1"/>
           <p:nvPr/>
         </p:nvSpPr>
         <p:spPr>
           <a:xfrm>
-            <a:off x="640080" y="1627632"/>
-            <a:ext cx="10881360" cy="914400"/>
+            <a:off x="777240" y="1600200"/>
+            <a:ext cx="2926080" cy="2743200"/>
           </a:xfrm>
           <a:prstGeom prst="rect">
             <a:avLst/>
@@ -11612,36 +11482,100 @@
           </a:bodyPr>
           <a:lstStyle/>
           <a:p>
-            <a:pPr algn="ctr">
-              <a:lnSpc>
-                <a:spcPct val="115000"/>
-              </a:lnSpc>
-              <a:spcAft>
-                <a:spcPts val="600"/>
-              </a:spcAft>
-            </a:pPr>
-            <a:r>
-              <a:rPr sz="3000" b="1">
-                <a:solidFill>
-                  <a:srgbClr val="18A099"/>
-                </a:solidFill>
-                <a:latin typeface="Arial"/>
-              </a:rPr>
-              <a:t>AdaIN(c, s)  =  σ(s) · ( c − μ(c) ) / σ(c)  +  μ(s)</a:t>
-            </a:r>
-          </a:p>
-        </p:txBody>
-      </p:sp>
-      <p:sp>
-        <p:nvSpPr>
-          <p:cNvPr id="8" name="Rectangle 7"/>
+            <a:pPr algn="l">
+              <a:lnSpc>
+                <a:spcPct val="115000"/>
+              </a:lnSpc>
+              <a:spcAft>
+                <a:spcPts val="600"/>
+              </a:spcAft>
+            </a:pPr>
+            <a:r>
+              <a:rPr sz="1700" b="1">
+                <a:solidFill>
+                  <a:srgbClr val="101B33"/>
+                </a:solidFill>
+                <a:latin typeface="Arial"/>
+              </a:rPr>
+              <a:t>① AdaIN  (học sâu)</a:t>
+            </a:r>
+          </a:p>
+          <a:p>
+            <a:pPr algn="l">
+              <a:lnSpc>
+                <a:spcPct val="115000"/>
+              </a:lnSpc>
+              <a:spcAft>
+                <a:spcPts val="600"/>
+              </a:spcAft>
+            </a:pPr>
+            <a:r>
+              <a:rPr sz="1300" b="0">
+                <a:solidFill>
+                  <a:srgbClr val="5A6375"/>
+                </a:solidFill>
+                <a:latin typeface="Arial"/>
+              </a:rPr>
+              <a:t>Chuẩn hoá đặc trưng VGG của ảnh gốc rồi nhuộm lại bằng mean/std của ảnh thời tiết.
+→ Đổi tông màu, độ sáng, độ mù toàn cục.</a:t>
+            </a:r>
+          </a:p>
+        </p:txBody>
+      </p:sp>
+      <p:sp>
+        <p:nvSpPr>
+          <p:cNvPr id="9" name="Rectangle 8"/>
           <p:cNvSpPr/>
           <p:nvPr/>
         </p:nvSpPr>
         <p:spPr>
           <a:xfrm>
-            <a:off x="640080" y="3026664"/>
-            <a:ext cx="100584" cy="100584"/>
+            <a:off x="4434840" y="1371600"/>
+            <a:ext cx="3337560" cy="3017520"/>
+          </a:xfrm>
+          <a:prstGeom prst="rect">
+            <a:avLst/>
+          </a:prstGeom>
+          <a:solidFill>
+            <a:srgbClr val="F4F6FA"/>
+          </a:solidFill>
+          <a:ln>
+            <a:noFill/>
+          </a:ln>
+          <a:effectLst/>
+        </p:spPr>
+        <p:style>
+          <a:lnRef idx="1">
+            <a:schemeClr val="accent1"/>
+          </a:lnRef>
+          <a:fillRef idx="3">
+            <a:schemeClr val="accent1"/>
+          </a:fillRef>
+          <a:effectRef idx="2">
+            <a:schemeClr val="accent1"/>
+          </a:effectRef>
+          <a:fontRef idx="minor">
+            <a:schemeClr val="lt1"/>
+          </a:fontRef>
+        </p:style>
+        <p:txBody>
+          <a:bodyPr rtlCol="0" anchor="ctr"/>
+          <a:lstStyle/>
+          <a:p>
+            <a:pPr algn="ctr"/>
+          </a:p>
+        </p:txBody>
+      </p:sp>
+      <p:sp>
+        <p:nvSpPr>
+          <p:cNvPr id="10" name="Rectangle 9"/>
+          <p:cNvSpPr/>
+          <p:nvPr/>
+        </p:nvSpPr>
+        <p:spPr>
+          <a:xfrm>
+            <a:off x="4434840" y="1371600"/>
+            <a:ext cx="3337560" cy="82296"/>
           </a:xfrm>
           <a:prstGeom prst="rect">
             <a:avLst/>
@@ -11678,14 +11612,14 @@
       </p:sp>
       <p:sp>
         <p:nvSpPr>
-          <p:cNvPr id="9" name="TextBox 8"/>
+          <p:cNvPr id="11" name="TextBox 10"/>
           <p:cNvSpPr txBox="1"/>
           <p:nvPr/>
         </p:nvSpPr>
         <p:spPr>
           <a:xfrm>
-            <a:off x="914400" y="2926080"/>
-            <a:ext cx="10607040" cy="548640"/>
+            <a:off x="4663440" y="1600200"/>
+            <a:ext cx="2926080" cy="2743200"/>
           </a:xfrm>
           <a:prstGeom prst="rect">
             <a:avLst/>
@@ -11707,33 +11641,54 @@
               </a:spcAft>
             </a:pPr>
             <a:r>
-              <a:rPr sz="1600" b="1">
+              <a:rPr sz="1700" b="1">
                 <a:solidFill>
                   <a:srgbClr val="101B33"/>
                 </a:solidFill>
                 <a:latin typeface="Arial"/>
               </a:rPr>
-              <a:t>c = đặc trưng VGG của ảnh giao thông,  s = đặc trưng VGG của ảnh thời tiết.</a:t>
-            </a:r>
-          </a:p>
-        </p:txBody>
-      </p:sp>
-      <p:sp>
-        <p:nvSpPr>
-          <p:cNvPr id="10" name="Rectangle 9"/>
+              <a:t>② Guided Filter</a:t>
+            </a:r>
+          </a:p>
+          <a:p>
+            <a:pPr algn="l">
+              <a:lnSpc>
+                <a:spcPct val="115000"/>
+              </a:lnSpc>
+              <a:spcAft>
+                <a:spcPts val="600"/>
+              </a:spcAft>
+            </a:pPr>
+            <a:r>
+              <a:rPr sz="1300" b="0">
+                <a:solidFill>
+                  <a:srgbClr val="5A6375"/>
+                </a:solidFill>
+                <a:latin typeface="Arial"/>
+              </a:rPr>
+              <a:t>Dùng ảnh gốc làm ảnh dẫn hướng, lọc tuyến tính cục bộ q = a·I + b.
+Bán kính lớn (32) → a, b mượt → đầu ra = ẢNH GỐC nhân trường tương phản + lệch màu.
+→ Giữ 100% chi tiết ảnh chụp, chỉ đổi tông thời tiết.</a:t>
+            </a:r>
+          </a:p>
+        </p:txBody>
+      </p:sp>
+      <p:sp>
+        <p:nvSpPr>
+          <p:cNvPr id="12" name="Rectangle 11"/>
           <p:cNvSpPr/>
           <p:nvPr/>
         </p:nvSpPr>
         <p:spPr>
           <a:xfrm>
-            <a:off x="640080" y="3575304"/>
-            <a:ext cx="100584" cy="100584"/>
+            <a:off x="8321040" y="1371600"/>
+            <a:ext cx="3337560" cy="3017520"/>
           </a:xfrm>
           <a:prstGeom prst="rect">
             <a:avLst/>
           </a:prstGeom>
           <a:solidFill>
-            <a:srgbClr val="18A099"/>
+            <a:srgbClr val="F4F6FA"/>
           </a:solidFill>
           <a:ln>
             <a:noFill/>
@@ -11764,62 +11719,20 @@
       </p:sp>
       <p:sp>
         <p:nvSpPr>
-          <p:cNvPr id="11" name="TextBox 10"/>
-          <p:cNvSpPr txBox="1"/>
-          <p:nvPr/>
-        </p:nvSpPr>
-        <p:spPr>
-          <a:xfrm>
-            <a:off x="914400" y="3474720"/>
-            <a:ext cx="10607040" cy="548640"/>
-          </a:xfrm>
-          <a:prstGeom prst="rect">
-            <a:avLst/>
-          </a:prstGeom>
-          <a:noFill/>
-        </p:spPr>
-        <p:txBody>
-          <a:bodyPr wrap="square" lIns="0" rIns="0">
-            <a:spAutoFit/>
-          </a:bodyPr>
-          <a:lstStyle/>
-          <a:p>
-            <a:pPr algn="l">
-              <a:lnSpc>
-                <a:spcPct val="115000"/>
-              </a:lnSpc>
-              <a:spcAft>
-                <a:spcPts val="600"/>
-              </a:spcAft>
-            </a:pPr>
-            <a:r>
-              <a:rPr sz="1600" b="0">
-                <a:solidFill>
-                  <a:srgbClr val="101B33"/>
-                </a:solidFill>
-                <a:latin typeface="Arial"/>
-              </a:rPr>
-              <a:t>Bước 1 — ( c − μ(c) ) / σ(c): xoá phong cách gốc (trời quang), giữ lại cấu trúc không gian.</a:t>
-            </a:r>
-          </a:p>
-        </p:txBody>
-      </p:sp>
-      <p:sp>
-        <p:nvSpPr>
-          <p:cNvPr id="12" name="Rectangle 11"/>
+          <p:cNvPr id="13" name="Rectangle 12"/>
           <p:cNvSpPr/>
           <p:nvPr/>
         </p:nvSpPr>
         <p:spPr>
           <a:xfrm>
-            <a:off x="640080" y="4123944"/>
-            <a:ext cx="100584" cy="100584"/>
+            <a:off x="8321040" y="1371600"/>
+            <a:ext cx="3337560" cy="82296"/>
           </a:xfrm>
           <a:prstGeom prst="rect">
             <a:avLst/>
           </a:prstGeom>
           <a:solidFill>
-            <a:srgbClr val="18A099"/>
+            <a:srgbClr val="E48A2E"/>
           </a:solidFill>
           <a:ln>
             <a:noFill/>
@@ -11850,14 +11763,14 @@
       </p:sp>
       <p:sp>
         <p:nvSpPr>
-          <p:cNvPr id="13" name="TextBox 12"/>
+          <p:cNvPr id="14" name="TextBox 13"/>
           <p:cNvSpPr txBox="1"/>
           <p:nvPr/>
         </p:nvSpPr>
         <p:spPr>
           <a:xfrm>
-            <a:off x="914400" y="4023360"/>
-            <a:ext cx="10607040" cy="548640"/>
+            <a:off x="8549640" y="1600200"/>
+            <a:ext cx="2926080" cy="2743200"/>
           </a:xfrm>
           <a:prstGeom prst="rect">
             <a:avLst/>
@@ -11879,58 +11792,34 @@
               </a:spcAft>
             </a:pPr>
             <a:r>
-              <a:rPr sz="1600" b="0">
+              <a:rPr sz="1700" b="1">
                 <a:solidFill>
                   <a:srgbClr val="101B33"/>
                 </a:solidFill>
                 <a:latin typeface="Arial"/>
               </a:rPr>
-              <a:t>Bước 2 — nhân σ(s), cộng μ(s): 'nhuộm' bằng thống kê của ảnh thời tiết.</a:t>
-            </a:r>
-          </a:p>
-        </p:txBody>
-      </p:sp>
-      <p:sp>
-        <p:nvSpPr>
-          <p:cNvPr id="14" name="Rectangle 13"/>
-          <p:cNvSpPr/>
-          <p:nvPr/>
-        </p:nvSpPr>
-        <p:spPr>
-          <a:xfrm>
-            <a:off x="640080" y="4672584"/>
-            <a:ext cx="100584" cy="100584"/>
-          </a:xfrm>
-          <a:prstGeom prst="rect">
-            <a:avLst/>
-          </a:prstGeom>
-          <a:solidFill>
-            <a:srgbClr val="18A099"/>
-          </a:solidFill>
-          <a:ln>
-            <a:noFill/>
-          </a:ln>
-          <a:effectLst/>
-        </p:spPr>
-        <p:style>
-          <a:lnRef idx="1">
-            <a:schemeClr val="accent1"/>
-          </a:lnRef>
-          <a:fillRef idx="3">
-            <a:schemeClr val="accent1"/>
-          </a:fillRef>
-          <a:effectRef idx="2">
-            <a:schemeClr val="accent1"/>
-          </a:effectRef>
-          <a:fontRef idx="minor">
-            <a:schemeClr val="lt1"/>
-          </a:fontRef>
-        </p:style>
-        <p:txBody>
-          <a:bodyPr rtlCol="0" anchor="ctr"/>
-          <a:lstStyle/>
-          <a:p>
-            <a:pPr algn="ctr"/>
+              <a:t>③ Phủ hạt (vật lý)</a:t>
+            </a:r>
+          </a:p>
+          <a:p>
+            <a:pPr algn="l">
+              <a:lnSpc>
+                <a:spcPct val="115000"/>
+              </a:lnSpc>
+              <a:spcAft>
+                <a:spcPts val="600"/>
+              </a:spcAft>
+            </a:pPr>
+            <a:r>
+              <a:rPr sz="1300" b="0">
+                <a:solidFill>
+                  <a:srgbClr val="5A6375"/>
+                </a:solidFill>
+                <a:latin typeface="Arial"/>
+              </a:rPr>
+              <a:t>Sinh vệt mưa (nhiễu + motion blur) và bông tuyết (3 lớp độ sâu), phủ theo chế độ screen.
+→ Thêm chi tiết cục bộ mà AdaIN không tạo ra được.</a:t>
+            </a:r>
           </a:p>
         </p:txBody>
       </p:sp>
@@ -11942,8 +11831,8 @@
         </p:nvSpPr>
         <p:spPr>
           <a:xfrm>
-            <a:off x="914400" y="4572000"/>
-            <a:ext cx="10607040" cy="548640"/>
+            <a:off x="548640" y="4617720"/>
+            <a:ext cx="11064240" cy="1463040"/>
           </a:xfrm>
           <a:prstGeom prst="rect">
             <a:avLst/>
@@ -11965,185 +11854,32 @@
               </a:spcAft>
             </a:pPr>
             <a:r>
-              <a:rPr sz="1600" b="1">
+              <a:rPr sz="1900" b="1">
                 <a:solidFill>
                   <a:srgbClr val="101B33"/>
                 </a:solidFill>
                 <a:latin typeface="Arial"/>
               </a:rPr>
-              <a:t>Chỉ đổi thống kê THEO KÊNH ⇒ bản đồ đặc trưng không bị dịch chuyển ⇒ giữ bố cục.</a:t>
-            </a:r>
-          </a:p>
-        </p:txBody>
-      </p:sp>
-      <p:sp>
-        <p:nvSpPr>
-          <p:cNvPr id="16" name="Rectangle 15"/>
-          <p:cNvSpPr/>
-          <p:nvPr/>
-        </p:nvSpPr>
-        <p:spPr>
-          <a:xfrm>
-            <a:off x="640080" y="5221224"/>
-            <a:ext cx="100584" cy="100584"/>
-          </a:xfrm>
-          <a:prstGeom prst="rect">
-            <a:avLst/>
-          </a:prstGeom>
-          <a:solidFill>
-            <a:srgbClr val="18A099"/>
-          </a:solidFill>
-          <a:ln>
-            <a:noFill/>
-          </a:ln>
-          <a:effectLst/>
-        </p:spPr>
-        <p:style>
-          <a:lnRef idx="1">
-            <a:schemeClr val="accent1"/>
-          </a:lnRef>
-          <a:fillRef idx="3">
-            <a:schemeClr val="accent1"/>
-          </a:fillRef>
-          <a:effectRef idx="2">
-            <a:schemeClr val="accent1"/>
-          </a:effectRef>
-          <a:fontRef idx="minor">
-            <a:schemeClr val="lt1"/>
-          </a:fontRef>
-        </p:style>
-        <p:txBody>
-          <a:bodyPr rtlCol="0" anchor="ctr"/>
-          <a:lstStyle/>
-          <a:p>
-            <a:pPr algn="ctr"/>
-          </a:p>
-        </p:txBody>
-      </p:sp>
-      <p:sp>
-        <p:nvSpPr>
-          <p:cNvPr id="17" name="TextBox 16"/>
-          <p:cNvSpPr txBox="1"/>
-          <p:nvPr/>
-        </p:nvSpPr>
-        <p:spPr>
-          <a:xfrm>
-            <a:off x="914400" y="5120640"/>
-            <a:ext cx="10607040" cy="548640"/>
-          </a:xfrm>
-          <a:prstGeom prst="rect">
-            <a:avLst/>
-          </a:prstGeom>
-          <a:noFill/>
-        </p:spPr>
-        <p:txBody>
-          <a:bodyPr wrap="square" lIns="0" rIns="0">
-            <a:spAutoFit/>
-          </a:bodyPr>
-          <a:lstStyle/>
-          <a:p>
-            <a:pPr algn="l">
-              <a:lnSpc>
-                <a:spcPct val="115000"/>
-              </a:lnSpc>
-              <a:spcAft>
-                <a:spcPts val="600"/>
-              </a:spcAft>
-            </a:pPr>
-            <a:r>
-              <a:rPr sz="1600" b="0">
-                <a:solidFill>
-                  <a:srgbClr val="101B33"/>
-                </a:solidFill>
-                <a:latin typeface="Arial"/>
-              </a:rPr>
-              <a:t>Không có tham số học nào trong AdaIN — chỉ Decoder (3,51 triệu tham số) được huấn luyện.</a:t>
-            </a:r>
-          </a:p>
-        </p:txBody>
-      </p:sp>
-      <p:sp>
-        <p:nvSpPr>
-          <p:cNvPr id="18" name="Rectangle 17"/>
-          <p:cNvSpPr/>
-          <p:nvPr/>
-        </p:nvSpPr>
-        <p:spPr>
-          <a:xfrm>
-            <a:off x="640080" y="5769864"/>
-            <a:ext cx="100584" cy="100584"/>
-          </a:xfrm>
-          <a:prstGeom prst="rect">
-            <a:avLst/>
-          </a:prstGeom>
-          <a:solidFill>
-            <a:srgbClr val="18A099"/>
-          </a:solidFill>
-          <a:ln>
-            <a:noFill/>
-          </a:ln>
-          <a:effectLst/>
-        </p:spPr>
-        <p:style>
-          <a:lnRef idx="1">
-            <a:schemeClr val="accent1"/>
-          </a:lnRef>
-          <a:fillRef idx="3">
-            <a:schemeClr val="accent1"/>
-          </a:fillRef>
-          <a:effectRef idx="2">
-            <a:schemeClr val="accent1"/>
-          </a:effectRef>
-          <a:fontRef idx="minor">
-            <a:schemeClr val="lt1"/>
-          </a:fontRef>
-        </p:style>
-        <p:txBody>
-          <a:bodyPr rtlCol="0" anchor="ctr"/>
-          <a:lstStyle/>
-          <a:p>
-            <a:pPr algn="ctr"/>
-          </a:p>
-        </p:txBody>
-      </p:sp>
-      <p:sp>
-        <p:nvSpPr>
-          <p:cNvPr id="19" name="TextBox 18"/>
-          <p:cNvSpPr txBox="1"/>
-          <p:nvPr/>
-        </p:nvSpPr>
-        <p:spPr>
-          <a:xfrm>
-            <a:off x="914400" y="5669280"/>
-            <a:ext cx="10607040" cy="548640"/>
-          </a:xfrm>
-          <a:prstGeom prst="rect">
-            <a:avLst/>
-          </a:prstGeom>
-          <a:noFill/>
-        </p:spPr>
-        <p:txBody>
-          <a:bodyPr wrap="square" lIns="0" rIns="0">
-            <a:spAutoFit/>
-          </a:bodyPr>
-          <a:lstStyle/>
-          <a:p>
-            <a:pPr algn="l">
-              <a:lnSpc>
-                <a:spcPct val="115000"/>
-              </a:lnSpc>
-              <a:spcAft>
-                <a:spcPts val="600"/>
-              </a:spcAft>
-            </a:pPr>
-            <a:r>
-              <a:rPr sz="1600" b="1">
-                <a:solidFill>
-                  <a:srgbClr val="101B33"/>
-                </a:solidFill>
-                <a:latin typeface="Arial"/>
-              </a:rPr>
-              <a:t>Hệ quả: thời tiết mới chỉ cần đưa ảnh tham chiếu vào, KHÔNG huấn luyện lại.</a:t>
+              <a:t>Vì sao nhãn bounding box vẫn dùng lại được?</a:t>
+            </a:r>
+          </a:p>
+          <a:p>
+            <a:pPr algn="l">
+              <a:lnSpc>
+                <a:spcPct val="115000"/>
+              </a:lnSpc>
+              <a:spcAft>
+                <a:spcPts val="600"/>
+              </a:spcAft>
+            </a:pPr>
+            <a:r>
+              <a:rPr sz="1500" b="0">
+                <a:solidFill>
+                  <a:srgbClr val="5A6375"/>
+                </a:solidFill>
+                <a:latin typeface="Arial"/>
+              </a:rPr>
+              <a:t>Cả 3 khối chỉ thay đổi GIÁ TRỊ MÀU tại từng pixel — không dịch chuyển, không co giãn, không xoay vật thể. Vị trí chiếc xe trong ảnh đầu ra trùng khít vị trí trong ảnh gốc, nên toàn bộ nhãn cũ được sao chép nguyên vẹn. Chi phí gán nhãn cho dữ liệu mới = 0.</a:t>
             </a:r>
           </a:p>
         </p:txBody>
@@ -12291,7 +12027,7 @@
                 </a:solidFill>
                 <a:latin typeface="Arial"/>
               </a:rPr>
-              <a:t>Huấn luyện</a:t>
+              <a:t>① AdaIN — trái tim của phương pháp</a:t>
             </a:r>
           </a:p>
           <a:p>
@@ -12310,7 +12046,7 @@
                 </a:solidFill>
                 <a:latin typeface="Arial"/>
               </a:rPr>
-              <a:t>Chỉ Decoder được học — VGG-19 đóng băng hoàn toàn</a:t>
+              <a:t>Huang &amp; Belongie, ICCV 2017</a:t>
             </a:r>
           </a:p>
         </p:txBody>
@@ -12365,8 +12101,8 @@
         </p:nvSpPr>
         <p:spPr>
           <a:xfrm>
-            <a:off x="640080" y="1280160"/>
-            <a:ext cx="5120640" cy="329184"/>
+            <a:off x="640080" y="1371600"/>
+            <a:ext cx="10881360" cy="1234440"/>
           </a:xfrm>
           <a:prstGeom prst="rect">
             <a:avLst/>
@@ -12409,8 +12145,8 @@
         </p:nvSpPr>
         <p:spPr>
           <a:xfrm>
-            <a:off x="749808" y="1344168"/>
-            <a:ext cx="1920240" cy="329184"/>
+            <a:off x="640080" y="1627632"/>
+            <a:ext cx="10881360" cy="914400"/>
           </a:xfrm>
           <a:prstGeom prst="rect">
             <a:avLst/>
@@ -12423,84 +12159,42 @@
           </a:bodyPr>
           <a:lstStyle/>
           <a:p>
-            <a:pPr algn="l">
-              <a:lnSpc>
-                <a:spcPct val="115000"/>
-              </a:lnSpc>
-              <a:spcAft>
-                <a:spcPts val="600"/>
-              </a:spcAft>
-            </a:pPr>
-            <a:r>
-              <a:rPr sz="1300" b="1">
-                <a:solidFill>
-                  <a:srgbClr val="FFFFFF"/>
-                </a:solidFill>
-                <a:latin typeface="Arial"/>
-              </a:rPr>
-              <a:t>Thành phần</a:t>
-            </a:r>
-          </a:p>
-        </p:txBody>
-      </p:sp>
-      <p:sp>
-        <p:nvSpPr>
-          <p:cNvPr id="8" name="TextBox 7"/>
-          <p:cNvSpPr txBox="1"/>
-          <p:nvPr/>
-        </p:nvSpPr>
-        <p:spPr>
-          <a:xfrm>
-            <a:off x="2670048" y="1344168"/>
-            <a:ext cx="3200400" cy="329184"/>
-          </a:xfrm>
-          <a:prstGeom prst="rect">
-            <a:avLst/>
-          </a:prstGeom>
-          <a:noFill/>
-        </p:spPr>
-        <p:txBody>
-          <a:bodyPr wrap="square" lIns="0" rIns="0">
-            <a:spAutoFit/>
-          </a:bodyPr>
-          <a:lstStyle/>
-          <a:p>
-            <a:pPr algn="l">
-              <a:lnSpc>
-                <a:spcPct val="115000"/>
-              </a:lnSpc>
-              <a:spcAft>
-                <a:spcPts val="600"/>
-              </a:spcAft>
-            </a:pPr>
-            <a:r>
-              <a:rPr sz="1300" b="1">
-                <a:solidFill>
-                  <a:srgbClr val="FFFFFF"/>
-                </a:solidFill>
-                <a:latin typeface="Arial"/>
-              </a:rPr>
-              <a:t>Giá trị</a:t>
-            </a:r>
-          </a:p>
-        </p:txBody>
-      </p:sp>
-      <p:sp>
-        <p:nvSpPr>
-          <p:cNvPr id="9" name="Rectangle 8"/>
+            <a:pPr algn="ctr">
+              <a:lnSpc>
+                <a:spcPct val="115000"/>
+              </a:lnSpc>
+              <a:spcAft>
+                <a:spcPts val="600"/>
+              </a:spcAft>
+            </a:pPr>
+            <a:r>
+              <a:rPr sz="3000" b="1">
+                <a:solidFill>
+                  <a:srgbClr val="18A099"/>
+                </a:solidFill>
+                <a:latin typeface="Arial"/>
+              </a:rPr>
+              <a:t>AdaIN(c, s)  =  σ(s) · ( c − μ(c) ) / σ(c)  +  μ(s)</a:t>
+            </a:r>
+          </a:p>
+        </p:txBody>
+      </p:sp>
+      <p:sp>
+        <p:nvSpPr>
+          <p:cNvPr id="8" name="Rectangle 7"/>
           <p:cNvSpPr/>
           <p:nvPr/>
         </p:nvSpPr>
         <p:spPr>
           <a:xfrm>
-            <a:off x="640080" y="1609344"/>
-            <a:ext cx="5120640" cy="329184"/>
+            <a:off x="640080" y="3026664"/>
+            <a:ext cx="100584" cy="100584"/>
           </a:xfrm>
           <a:prstGeom prst="rect">
             <a:avLst/>
           </a:prstGeom>
           <a:solidFill>
-            <a:srgbClr val="F4F6FA"/>
+            <a:srgbClr val="18A099"/>
           </a:solidFill>
           <a:ln>
             <a:noFill/>
@@ -12531,14 +12225,14 @@
       </p:sp>
       <p:sp>
         <p:nvSpPr>
-          <p:cNvPr id="10" name="TextBox 9"/>
+          <p:cNvPr id="9" name="TextBox 8"/>
           <p:cNvSpPr txBox="1"/>
           <p:nvPr/>
         </p:nvSpPr>
         <p:spPr>
           <a:xfrm>
-            <a:off x="749808" y="1673352"/>
-            <a:ext cx="1920240" cy="329184"/>
+            <a:off x="914400" y="2926080"/>
+            <a:ext cx="10607040" cy="548640"/>
           </a:xfrm>
           <a:prstGeom prst="rect">
             <a:avLst/>
@@ -12560,75 +12254,33 @@
               </a:spcAft>
             </a:pPr>
             <a:r>
-              <a:rPr sz="1300" b="0">
+              <a:rPr sz="1600" b="1">
                 <a:solidFill>
                   <a:srgbClr val="101B33"/>
                 </a:solidFill>
                 <a:latin typeface="Arial"/>
               </a:rPr>
-              <a:t>Encoder</a:t>
-            </a:r>
-          </a:p>
-        </p:txBody>
-      </p:sp>
-      <p:sp>
-        <p:nvSpPr>
-          <p:cNvPr id="11" name="TextBox 10"/>
-          <p:cNvSpPr txBox="1"/>
-          <p:nvPr/>
-        </p:nvSpPr>
-        <p:spPr>
-          <a:xfrm>
-            <a:off x="2670048" y="1673352"/>
-            <a:ext cx="3200400" cy="329184"/>
-          </a:xfrm>
-          <a:prstGeom prst="rect">
-            <a:avLst/>
-          </a:prstGeom>
-          <a:noFill/>
-        </p:spPr>
-        <p:txBody>
-          <a:bodyPr wrap="square" lIns="0" rIns="0">
-            <a:spAutoFit/>
-          </a:bodyPr>
-          <a:lstStyle/>
-          <a:p>
-            <a:pPr algn="l">
-              <a:lnSpc>
-                <a:spcPct val="115000"/>
-              </a:lnSpc>
-              <a:spcAft>
-                <a:spcPts val="600"/>
-              </a:spcAft>
-            </a:pPr>
-            <a:r>
-              <a:rPr sz="1300" b="0">
-                <a:solidFill>
-                  <a:srgbClr val="101B33"/>
-                </a:solidFill>
-                <a:latin typeface="Arial"/>
-              </a:rPr>
-              <a:t>VGG-19 (ImageNet), đóng băng</a:t>
-            </a:r>
-          </a:p>
-        </p:txBody>
-      </p:sp>
-      <p:sp>
-        <p:nvSpPr>
-          <p:cNvPr id="12" name="Rectangle 11"/>
+              <a:t>c = đặc trưng VGG của ảnh giao thông,  s = đặc trưng VGG của ảnh thời tiết.</a:t>
+            </a:r>
+          </a:p>
+        </p:txBody>
+      </p:sp>
+      <p:sp>
+        <p:nvSpPr>
+          <p:cNvPr id="10" name="Rectangle 9"/>
           <p:cNvSpPr/>
           <p:nvPr/>
         </p:nvSpPr>
         <p:spPr>
           <a:xfrm>
-            <a:off x="640080" y="1938528"/>
-            <a:ext cx="5120640" cy="329184"/>
+            <a:off x="640080" y="3575304"/>
+            <a:ext cx="100584" cy="100584"/>
           </a:xfrm>
           <a:prstGeom prst="rect">
             <a:avLst/>
           </a:prstGeom>
           <a:solidFill>
-            <a:srgbClr val="FFFFFF"/>
+            <a:srgbClr val="18A099"/>
           </a:solidFill>
           <a:ln>
             <a:noFill/>
@@ -12659,14 +12311,14 @@
       </p:sp>
       <p:sp>
         <p:nvSpPr>
-          <p:cNvPr id="13" name="TextBox 12"/>
+          <p:cNvPr id="11" name="TextBox 10"/>
           <p:cNvSpPr txBox="1"/>
           <p:nvPr/>
         </p:nvSpPr>
         <p:spPr>
           <a:xfrm>
-            <a:off x="749808" y="2002536"/>
-            <a:ext cx="1920240" cy="329184"/>
+            <a:off x="914400" y="3474720"/>
+            <a:ext cx="10607040" cy="548640"/>
           </a:xfrm>
           <a:prstGeom prst="rect">
             <a:avLst/>
@@ -12688,75 +12340,33 @@
               </a:spcAft>
             </a:pPr>
             <a:r>
-              <a:rPr sz="1300" b="0">
+              <a:rPr sz="1600" b="0">
                 <a:solidFill>
                   <a:srgbClr val="101B33"/>
                 </a:solidFill>
                 <a:latin typeface="Arial"/>
               </a:rPr>
-              <a:t>Decoder</a:t>
-            </a:r>
-          </a:p>
-        </p:txBody>
-      </p:sp>
-      <p:sp>
-        <p:nvSpPr>
-          <p:cNvPr id="14" name="TextBox 13"/>
-          <p:cNvSpPr txBox="1"/>
-          <p:nvPr/>
-        </p:nvSpPr>
-        <p:spPr>
-          <a:xfrm>
-            <a:off x="2670048" y="2002536"/>
-            <a:ext cx="3200400" cy="329184"/>
-          </a:xfrm>
-          <a:prstGeom prst="rect">
-            <a:avLst/>
-          </a:prstGeom>
-          <a:noFill/>
-        </p:spPr>
-        <p:txBody>
-          <a:bodyPr wrap="square" lIns="0" rIns="0">
-            <a:spAutoFit/>
-          </a:bodyPr>
-          <a:lstStyle/>
-          <a:p>
-            <a:pPr algn="l">
-              <a:lnSpc>
-                <a:spcPct val="115000"/>
-              </a:lnSpc>
-              <a:spcAft>
-                <a:spcPts val="600"/>
-              </a:spcAft>
-            </a:pPr>
-            <a:r>
-              <a:rPr sz="1300" b="0">
-                <a:solidFill>
-                  <a:srgbClr val="101B33"/>
-                </a:solidFill>
-                <a:latin typeface="Arial"/>
-              </a:rPr>
-              <a:t>3,51 M tham số</a:t>
-            </a:r>
-          </a:p>
-        </p:txBody>
-      </p:sp>
-      <p:sp>
-        <p:nvSpPr>
-          <p:cNvPr id="15" name="Rectangle 14"/>
+              <a:t>Bước 1 — ( c − μ(c) ) / σ(c): xoá phong cách gốc (trời quang), giữ lại cấu trúc không gian.</a:t>
+            </a:r>
+          </a:p>
+        </p:txBody>
+      </p:sp>
+      <p:sp>
+        <p:nvSpPr>
+          <p:cNvPr id="12" name="Rectangle 11"/>
           <p:cNvSpPr/>
           <p:nvPr/>
         </p:nvSpPr>
         <p:spPr>
           <a:xfrm>
-            <a:off x="640080" y="2267712"/>
-            <a:ext cx="5120640" cy="329184"/>
+            <a:off x="640080" y="4123944"/>
+            <a:ext cx="100584" cy="100584"/>
           </a:xfrm>
           <a:prstGeom prst="rect">
             <a:avLst/>
           </a:prstGeom>
           <a:solidFill>
-            <a:srgbClr val="F4F6FA"/>
+            <a:srgbClr val="18A099"/>
           </a:solidFill>
           <a:ln>
             <a:noFill/>
@@ -12787,14 +12397,14 @@
       </p:sp>
       <p:sp>
         <p:nvSpPr>
-          <p:cNvPr id="16" name="TextBox 15"/>
+          <p:cNvPr id="13" name="TextBox 12"/>
           <p:cNvSpPr txBox="1"/>
           <p:nvPr/>
         </p:nvSpPr>
         <p:spPr>
           <a:xfrm>
-            <a:off x="749808" y="2331720"/>
-            <a:ext cx="1920240" cy="329184"/>
+            <a:off x="914400" y="4023360"/>
+            <a:ext cx="10607040" cy="548640"/>
           </a:xfrm>
           <a:prstGeom prst="rect">
             <a:avLst/>
@@ -12816,75 +12426,33 @@
               </a:spcAft>
             </a:pPr>
             <a:r>
-              <a:rPr sz="1300" b="0">
+              <a:rPr sz="1600" b="0">
                 <a:solidFill>
                   <a:srgbClr val="101B33"/>
                 </a:solidFill>
                 <a:latin typeface="Arial"/>
               </a:rPr>
-              <a:t>Ảnh huấn luyện</a:t>
-            </a:r>
-          </a:p>
-        </p:txBody>
-      </p:sp>
-      <p:sp>
-        <p:nvSpPr>
-          <p:cNvPr id="17" name="TextBox 16"/>
-          <p:cNvSpPr txBox="1"/>
-          <p:nvPr/>
-        </p:nvSpPr>
-        <p:spPr>
-          <a:xfrm>
-            <a:off x="2670048" y="2331720"/>
-            <a:ext cx="3200400" cy="329184"/>
-          </a:xfrm>
-          <a:prstGeom prst="rect">
-            <a:avLst/>
-          </a:prstGeom>
-          <a:noFill/>
-        </p:spPr>
-        <p:txBody>
-          <a:bodyPr wrap="square" lIns="0" rIns="0">
-            <a:spAutoFit/>
-          </a:bodyPr>
-          <a:lstStyle/>
-          <a:p>
-            <a:pPr algn="l">
-              <a:lnSpc>
-                <a:spcPct val="115000"/>
-              </a:lnSpc>
-              <a:spcAft>
-                <a:spcPts val="600"/>
-              </a:spcAft>
-            </a:pPr>
-            <a:r>
-              <a:rPr sz="1300" b="0">
-                <a:solidFill>
-                  <a:srgbClr val="101B33"/>
-                </a:solidFill>
-                <a:latin typeface="Arial"/>
-              </a:rPr>
-              <a:t>2.160 nội dung × 1.327 style</a:t>
-            </a:r>
-          </a:p>
-        </p:txBody>
-      </p:sp>
-      <p:sp>
-        <p:nvSpPr>
-          <p:cNvPr id="18" name="Rectangle 17"/>
+              <a:t>Bước 2 — nhân σ(s), cộng μ(s): 'nhuộm' bằng thống kê của ảnh thời tiết.</a:t>
+            </a:r>
+          </a:p>
+        </p:txBody>
+      </p:sp>
+      <p:sp>
+        <p:nvSpPr>
+          <p:cNvPr id="14" name="Rectangle 13"/>
           <p:cNvSpPr/>
           <p:nvPr/>
         </p:nvSpPr>
         <p:spPr>
           <a:xfrm>
-            <a:off x="640080" y="2596896"/>
-            <a:ext cx="5120640" cy="329184"/>
+            <a:off x="640080" y="4672584"/>
+            <a:ext cx="100584" cy="100584"/>
           </a:xfrm>
           <a:prstGeom prst="rect">
             <a:avLst/>
           </a:prstGeom>
           <a:solidFill>
-            <a:srgbClr val="FFFFFF"/>
+            <a:srgbClr val="18A099"/>
           </a:solidFill>
           <a:ln>
             <a:noFill/>
@@ -12915,14 +12483,14 @@
       </p:sp>
       <p:sp>
         <p:nvSpPr>
-          <p:cNvPr id="19" name="TextBox 18"/>
+          <p:cNvPr id="15" name="TextBox 14"/>
           <p:cNvSpPr txBox="1"/>
           <p:nvPr/>
         </p:nvSpPr>
         <p:spPr>
           <a:xfrm>
-            <a:off x="749808" y="2660904"/>
-            <a:ext cx="1920240" cy="329184"/>
+            <a:off x="914400" y="4572000"/>
+            <a:ext cx="10607040" cy="548640"/>
           </a:xfrm>
           <a:prstGeom prst="rect">
             <a:avLst/>
@@ -12944,75 +12512,33 @@
               </a:spcAft>
             </a:pPr>
             <a:r>
-              <a:rPr sz="1300" b="0">
+              <a:rPr sz="1600" b="1">
                 <a:solidFill>
                   <a:srgbClr val="101B33"/>
                 </a:solidFill>
                 <a:latin typeface="Arial"/>
               </a:rPr>
-              <a:t>Kích thước</a:t>
-            </a:r>
-          </a:p>
-        </p:txBody>
-      </p:sp>
-      <p:sp>
-        <p:nvSpPr>
-          <p:cNvPr id="20" name="TextBox 19"/>
-          <p:cNvSpPr txBox="1"/>
-          <p:nvPr/>
-        </p:nvSpPr>
-        <p:spPr>
-          <a:xfrm>
-            <a:off x="2670048" y="2660904"/>
-            <a:ext cx="3200400" cy="329184"/>
-          </a:xfrm>
-          <a:prstGeom prst="rect">
-            <a:avLst/>
-          </a:prstGeom>
-          <a:noFill/>
-        </p:spPr>
-        <p:txBody>
-          <a:bodyPr wrap="square" lIns="0" rIns="0">
-            <a:spAutoFit/>
-          </a:bodyPr>
-          <a:lstStyle/>
-          <a:p>
-            <a:pPr algn="l">
-              <a:lnSpc>
-                <a:spcPct val="115000"/>
-              </a:lnSpc>
-              <a:spcAft>
-                <a:spcPts val="600"/>
-              </a:spcAft>
-            </a:pPr>
-            <a:r>
-              <a:rPr sz="1300" b="0">
-                <a:solidFill>
-                  <a:srgbClr val="101B33"/>
-                </a:solidFill>
-                <a:latin typeface="Arial"/>
-              </a:rPr>
-              <a:t>resize 320 → crop 256</a:t>
-            </a:r>
-          </a:p>
-        </p:txBody>
-      </p:sp>
-      <p:sp>
-        <p:nvSpPr>
-          <p:cNvPr id="21" name="Rectangle 20"/>
+              <a:t>Chỉ đổi thống kê THEO KÊNH ⇒ bản đồ đặc trưng không bị dịch chuyển ⇒ giữ bố cục.</a:t>
+            </a:r>
+          </a:p>
+        </p:txBody>
+      </p:sp>
+      <p:sp>
+        <p:nvSpPr>
+          <p:cNvPr id="16" name="Rectangle 15"/>
           <p:cNvSpPr/>
           <p:nvPr/>
         </p:nvSpPr>
         <p:spPr>
           <a:xfrm>
-            <a:off x="640080" y="2926080"/>
-            <a:ext cx="5120640" cy="329184"/>
+            <a:off x="640080" y="5221224"/>
+            <a:ext cx="100584" cy="100584"/>
           </a:xfrm>
           <a:prstGeom prst="rect">
             <a:avLst/>
           </a:prstGeom>
           <a:solidFill>
-            <a:srgbClr val="F4F6FA"/>
+            <a:srgbClr val="18A099"/>
           </a:solidFill>
           <a:ln>
             <a:noFill/>
@@ -13043,14 +12569,14 @@
       </p:sp>
       <p:sp>
         <p:nvSpPr>
-          <p:cNvPr id="22" name="TextBox 21"/>
+          <p:cNvPr id="17" name="TextBox 16"/>
           <p:cNvSpPr txBox="1"/>
           <p:nvPr/>
         </p:nvSpPr>
         <p:spPr>
           <a:xfrm>
-            <a:off x="749808" y="2990088"/>
-            <a:ext cx="1920240" cy="329184"/>
+            <a:off x="914400" y="5120640"/>
+            <a:ext cx="10607040" cy="548640"/>
           </a:xfrm>
           <a:prstGeom prst="rect">
             <a:avLst/>
@@ -13072,75 +12598,33 @@
               </a:spcAft>
             </a:pPr>
             <a:r>
-              <a:rPr sz="1300" b="0">
+              <a:rPr sz="1600" b="0">
                 <a:solidFill>
                   <a:srgbClr val="101B33"/>
                 </a:solidFill>
                 <a:latin typeface="Arial"/>
               </a:rPr>
-              <a:t>Batch / bước</a:t>
-            </a:r>
-          </a:p>
-        </p:txBody>
-      </p:sp>
-      <p:sp>
-        <p:nvSpPr>
-          <p:cNvPr id="23" name="TextBox 22"/>
-          <p:cNvSpPr txBox="1"/>
-          <p:nvPr/>
-        </p:nvSpPr>
-        <p:spPr>
-          <a:xfrm>
-            <a:off x="2670048" y="2990088"/>
-            <a:ext cx="3200400" cy="329184"/>
-          </a:xfrm>
-          <a:prstGeom prst="rect">
-            <a:avLst/>
-          </a:prstGeom>
-          <a:noFill/>
-        </p:spPr>
-        <p:txBody>
-          <a:bodyPr wrap="square" lIns="0" rIns="0">
-            <a:spAutoFit/>
-          </a:bodyPr>
-          <a:lstStyle/>
-          <a:p>
-            <a:pPr algn="l">
-              <a:lnSpc>
-                <a:spcPct val="115000"/>
-              </a:lnSpc>
-              <a:spcAft>
-                <a:spcPts val="600"/>
-              </a:spcAft>
-            </a:pPr>
-            <a:r>
-              <a:rPr sz="1300" b="0">
-                <a:solidFill>
-                  <a:srgbClr val="101B33"/>
-                </a:solidFill>
-                <a:latin typeface="Arial"/>
-              </a:rPr>
-              <a:t>8 / 12.000</a:t>
-            </a:r>
-          </a:p>
-        </p:txBody>
-      </p:sp>
-      <p:sp>
-        <p:nvSpPr>
-          <p:cNvPr id="24" name="Rectangle 23"/>
+              <a:t>Không có tham số học nào trong AdaIN — chỉ Decoder (3,51 triệu tham số) được huấn luyện.</a:t>
+            </a:r>
+          </a:p>
+        </p:txBody>
+      </p:sp>
+      <p:sp>
+        <p:nvSpPr>
+          <p:cNvPr id="18" name="Rectangle 17"/>
           <p:cNvSpPr/>
           <p:nvPr/>
         </p:nvSpPr>
         <p:spPr>
           <a:xfrm>
-            <a:off x="640080" y="3255264"/>
-            <a:ext cx="5120640" cy="329184"/>
+            <a:off x="640080" y="5769864"/>
+            <a:ext cx="100584" cy="100584"/>
           </a:xfrm>
           <a:prstGeom prst="rect">
             <a:avLst/>
           </a:prstGeom>
           <a:solidFill>
-            <a:srgbClr val="FFFFFF"/>
+            <a:srgbClr val="18A099"/>
           </a:solidFill>
           <a:ln>
             <a:noFill/>
@@ -13171,14 +12655,14 @@
       </p:sp>
       <p:sp>
         <p:nvSpPr>
-          <p:cNvPr id="25" name="TextBox 24"/>
+          <p:cNvPr id="19" name="TextBox 18"/>
           <p:cNvSpPr txBox="1"/>
           <p:nvPr/>
         </p:nvSpPr>
         <p:spPr>
           <a:xfrm>
-            <a:off x="749808" y="3319272"/>
-            <a:ext cx="1920240" cy="329184"/>
+            <a:off x="914400" y="5669280"/>
+            <a:ext cx="10607040" cy="548640"/>
           </a:xfrm>
           <a:prstGeom prst="rect">
             <a:avLst/>
@@ -13200,495 +12684,17 @@
               </a:spcAft>
             </a:pPr>
             <a:r>
-              <a:rPr sz="1300" b="0">
+              <a:rPr sz="1600" b="1">
                 <a:solidFill>
                   <a:srgbClr val="101B33"/>
                 </a:solidFill>
                 <a:latin typeface="Arial"/>
               </a:rPr>
-              <a:t>Optimizer</a:t>
-            </a:r>
-          </a:p>
-        </p:txBody>
-      </p:sp>
-      <p:sp>
-        <p:nvSpPr>
-          <p:cNvPr id="26" name="TextBox 25"/>
-          <p:cNvSpPr txBox="1"/>
-          <p:nvPr/>
-        </p:nvSpPr>
-        <p:spPr>
-          <a:xfrm>
-            <a:off x="2670048" y="3319272"/>
-            <a:ext cx="3200400" cy="329184"/>
-          </a:xfrm>
-          <a:prstGeom prst="rect">
-            <a:avLst/>
-          </a:prstGeom>
-          <a:noFill/>
-        </p:spPr>
-        <p:txBody>
-          <a:bodyPr wrap="square" lIns="0" rIns="0">
-            <a:spAutoFit/>
-          </a:bodyPr>
-          <a:lstStyle/>
-          <a:p>
-            <a:pPr algn="l">
-              <a:lnSpc>
-                <a:spcPct val="115000"/>
-              </a:lnSpc>
-              <a:spcAft>
-                <a:spcPts val="600"/>
-              </a:spcAft>
-            </a:pPr>
-            <a:r>
-              <a:rPr sz="1300" b="0">
-                <a:solidFill>
-                  <a:srgbClr val="101B33"/>
-                </a:solidFill>
-                <a:latin typeface="Arial"/>
-              </a:rPr>
-              <a:t>Adam, lr 1e-4, decay 5e-5</a:t>
-            </a:r>
-          </a:p>
-        </p:txBody>
-      </p:sp>
-      <p:sp>
-        <p:nvSpPr>
-          <p:cNvPr id="27" name="Rectangle 26"/>
-          <p:cNvSpPr/>
-          <p:nvPr/>
-        </p:nvSpPr>
-        <p:spPr>
-          <a:xfrm>
-            <a:off x="640080" y="3584448"/>
-            <a:ext cx="5120640" cy="329184"/>
-          </a:xfrm>
-          <a:prstGeom prst="rect">
-            <a:avLst/>
-          </a:prstGeom>
-          <a:solidFill>
-            <a:srgbClr val="F4F6FA"/>
-          </a:solidFill>
-          <a:ln>
-            <a:noFill/>
-          </a:ln>
-          <a:effectLst/>
-        </p:spPr>
-        <p:style>
-          <a:lnRef idx="1">
-            <a:schemeClr val="accent1"/>
-          </a:lnRef>
-          <a:fillRef idx="3">
-            <a:schemeClr val="accent1"/>
-          </a:fillRef>
-          <a:effectRef idx="2">
-            <a:schemeClr val="accent1"/>
-          </a:effectRef>
-          <a:fontRef idx="minor">
-            <a:schemeClr val="lt1"/>
-          </a:fontRef>
-        </p:style>
-        <p:txBody>
-          <a:bodyPr rtlCol="0" anchor="ctr"/>
-          <a:lstStyle/>
-          <a:p>
-            <a:pPr algn="ctr"/>
-          </a:p>
-        </p:txBody>
-      </p:sp>
-      <p:sp>
-        <p:nvSpPr>
-          <p:cNvPr id="28" name="TextBox 27"/>
-          <p:cNvSpPr txBox="1"/>
-          <p:nvPr/>
-        </p:nvSpPr>
-        <p:spPr>
-          <a:xfrm>
-            <a:off x="749808" y="3648456"/>
-            <a:ext cx="1920240" cy="329184"/>
-          </a:xfrm>
-          <a:prstGeom prst="rect">
-            <a:avLst/>
-          </a:prstGeom>
-          <a:noFill/>
-        </p:spPr>
-        <p:txBody>
-          <a:bodyPr wrap="square" lIns="0" rIns="0">
-            <a:spAutoFit/>
-          </a:bodyPr>
-          <a:lstStyle/>
-          <a:p>
-            <a:pPr algn="l">
-              <a:lnSpc>
-                <a:spcPct val="115000"/>
-              </a:lnSpc>
-              <a:spcAft>
-                <a:spcPts val="600"/>
-              </a:spcAft>
-            </a:pPr>
-            <a:r>
-              <a:rPr sz="1300" b="0">
-                <a:solidFill>
-                  <a:srgbClr val="101B33"/>
-                </a:solidFill>
-                <a:latin typeface="Arial"/>
-              </a:rPr>
-              <a:t>Mixed precision</a:t>
-            </a:r>
-          </a:p>
-        </p:txBody>
-      </p:sp>
-      <p:sp>
-        <p:nvSpPr>
-          <p:cNvPr id="29" name="TextBox 28"/>
-          <p:cNvSpPr txBox="1"/>
-          <p:nvPr/>
-        </p:nvSpPr>
-        <p:spPr>
-          <a:xfrm>
-            <a:off x="2670048" y="3648456"/>
-            <a:ext cx="3200400" cy="329184"/>
-          </a:xfrm>
-          <a:prstGeom prst="rect">
-            <a:avLst/>
-          </a:prstGeom>
-          <a:noFill/>
-        </p:spPr>
-        <p:txBody>
-          <a:bodyPr wrap="square" lIns="0" rIns="0">
-            <a:spAutoFit/>
-          </a:bodyPr>
-          <a:lstStyle/>
-          <a:p>
-            <a:pPr algn="l">
-              <a:lnSpc>
-                <a:spcPct val="115000"/>
-              </a:lnSpc>
-              <a:spcAft>
-                <a:spcPts val="600"/>
-              </a:spcAft>
-            </a:pPr>
-            <a:r>
-              <a:rPr sz="1300" b="0">
-                <a:solidFill>
-                  <a:srgbClr val="101B33"/>
-                </a:solidFill>
-                <a:latin typeface="Arial"/>
-              </a:rPr>
-              <a:t>bfloat16</a:t>
-            </a:r>
-          </a:p>
-        </p:txBody>
-      </p:sp>
-      <p:sp>
-        <p:nvSpPr>
-          <p:cNvPr id="30" name="Rectangle 29"/>
-          <p:cNvSpPr/>
-          <p:nvPr/>
-        </p:nvSpPr>
-        <p:spPr>
-          <a:xfrm>
-            <a:off x="640080" y="3913632"/>
-            <a:ext cx="5120640" cy="329184"/>
-          </a:xfrm>
-          <a:prstGeom prst="rect">
-            <a:avLst/>
-          </a:prstGeom>
-          <a:solidFill>
-            <a:srgbClr val="FFFFFF"/>
-          </a:solidFill>
-          <a:ln>
-            <a:noFill/>
-          </a:ln>
-          <a:effectLst/>
-        </p:spPr>
-        <p:style>
-          <a:lnRef idx="1">
-            <a:schemeClr val="accent1"/>
-          </a:lnRef>
-          <a:fillRef idx="3">
-            <a:schemeClr val="accent1"/>
-          </a:fillRef>
-          <a:effectRef idx="2">
-            <a:schemeClr val="accent1"/>
-          </a:effectRef>
-          <a:fontRef idx="minor">
-            <a:schemeClr val="lt1"/>
-          </a:fontRef>
-        </p:style>
-        <p:txBody>
-          <a:bodyPr rtlCol="0" anchor="ctr"/>
-          <a:lstStyle/>
-          <a:p>
-            <a:pPr algn="ctr"/>
-          </a:p>
-        </p:txBody>
-      </p:sp>
-      <p:sp>
-        <p:nvSpPr>
-          <p:cNvPr id="31" name="TextBox 30"/>
-          <p:cNvSpPr txBox="1"/>
-          <p:nvPr/>
-        </p:nvSpPr>
-        <p:spPr>
-          <a:xfrm>
-            <a:off x="749808" y="3977640"/>
-            <a:ext cx="1920240" cy="329184"/>
-          </a:xfrm>
-          <a:prstGeom prst="rect">
-            <a:avLst/>
-          </a:prstGeom>
-          <a:noFill/>
-        </p:spPr>
-        <p:txBody>
-          <a:bodyPr wrap="square" lIns="0" rIns="0">
-            <a:spAutoFit/>
-          </a:bodyPr>
-          <a:lstStyle/>
-          <a:p>
-            <a:pPr algn="l">
-              <a:lnSpc>
-                <a:spcPct val="115000"/>
-              </a:lnSpc>
-              <a:spcAft>
-                <a:spcPts val="600"/>
-              </a:spcAft>
-            </a:pPr>
-            <a:r>
-              <a:rPr sz="1300" b="0">
-                <a:solidFill>
-                  <a:srgbClr val="101B33"/>
-                </a:solidFill>
-                <a:latin typeface="Arial"/>
-              </a:rPr>
-              <a:t>Thời gian</a:t>
-            </a:r>
-          </a:p>
-        </p:txBody>
-      </p:sp>
-      <p:sp>
-        <p:nvSpPr>
-          <p:cNvPr id="32" name="TextBox 31"/>
-          <p:cNvSpPr txBox="1"/>
-          <p:nvPr/>
-        </p:nvSpPr>
-        <p:spPr>
-          <a:xfrm>
-            <a:off x="2670048" y="3977640"/>
-            <a:ext cx="3200400" cy="329184"/>
-          </a:xfrm>
-          <a:prstGeom prst="rect">
-            <a:avLst/>
-          </a:prstGeom>
-          <a:noFill/>
-        </p:spPr>
-        <p:txBody>
-          <a:bodyPr wrap="square" lIns="0" rIns="0">
-            <a:spAutoFit/>
-          </a:bodyPr>
-          <a:lstStyle/>
-          <a:p>
-            <a:pPr algn="l">
-              <a:lnSpc>
-                <a:spcPct val="115000"/>
-              </a:lnSpc>
-              <a:spcAft>
-                <a:spcPts val="600"/>
-              </a:spcAft>
-            </a:pPr>
-            <a:r>
-              <a:rPr sz="1300" b="0">
-                <a:solidFill>
-                  <a:srgbClr val="101B33"/>
-                </a:solidFill>
-                <a:latin typeface="Arial"/>
-              </a:rPr>
-              <a:t>37 phút (RTX 5060 Ti)</a:t>
-            </a:r>
-          </a:p>
-        </p:txBody>
-      </p:sp>
-      <p:sp>
-        <p:nvSpPr>
-          <p:cNvPr id="33" name="TextBox 32"/>
-          <p:cNvSpPr txBox="1"/>
-          <p:nvPr/>
-        </p:nvSpPr>
-        <p:spPr>
-          <a:xfrm>
-            <a:off x="6126480" y="1280160"/>
-            <a:ext cx="5394960" cy="2194560"/>
-          </a:xfrm>
-          <a:prstGeom prst="rect">
-            <a:avLst/>
-          </a:prstGeom>
-          <a:noFill/>
-        </p:spPr>
-        <p:txBody>
-          <a:bodyPr wrap="square" lIns="0" rIns="0">
-            <a:spAutoFit/>
-          </a:bodyPr>
-          <a:lstStyle/>
-          <a:p>
-            <a:pPr algn="l">
-              <a:lnSpc>
-                <a:spcPct val="115000"/>
-              </a:lnSpc>
-              <a:spcAft>
-                <a:spcPts val="600"/>
-              </a:spcAft>
-            </a:pPr>
-            <a:r>
-              <a:rPr sz="1900" b="1">
-                <a:solidFill>
-                  <a:srgbClr val="101B33"/>
-                </a:solidFill>
-                <a:latin typeface="Arial"/>
-              </a:rPr>
-              <a:t>Hàm mất mát</a:t>
-            </a:r>
-          </a:p>
-          <a:p>
-            <a:pPr algn="l">
-              <a:lnSpc>
-                <a:spcPct val="115000"/>
-              </a:lnSpc>
-              <a:spcAft>
-                <a:spcPts val="600"/>
-              </a:spcAft>
-            </a:pPr>
-            <a:r>
-              <a:rPr sz="1500" b="1">
-                <a:solidFill>
-                  <a:srgbClr val="2E6FD9"/>
-                </a:solidFill>
-                <a:latin typeface="Arial"/>
-              </a:rPr>
-              <a:t>L  =  L_content  +  10 · L_style  +  1 · L_identity</a:t>
-            </a:r>
-          </a:p>
-          <a:p>
-            <a:pPr algn="l">
-              <a:lnSpc>
-                <a:spcPct val="115000"/>
-              </a:lnSpc>
-              <a:spcAft>
-                <a:spcPts val="600"/>
-              </a:spcAft>
-            </a:pPr>
-            <a:r>
-              <a:rPr sz="1400" b="0">
-                <a:solidFill>
-                  <a:srgbClr val="5A6375"/>
-                </a:solidFill>
-                <a:latin typeface="Arial"/>
-              </a:rPr>
-              <a:t>· L_content — khớp đặc trưng đầu ra với đặc trưng AdaIN → giữ bố cục.</a:t>
-            </a:r>
-          </a:p>
-          <a:p>
-            <a:pPr algn="l">
-              <a:lnSpc>
-                <a:spcPct val="115000"/>
-              </a:lnSpc>
-              <a:spcAft>
-                <a:spcPts val="600"/>
-              </a:spcAft>
-            </a:pPr>
-            <a:r>
-              <a:rPr sz="1400" b="0">
-                <a:solidFill>
-                  <a:srgbClr val="5A6375"/>
-                </a:solidFill>
-                <a:latin typeface="Arial"/>
-              </a:rPr>
-              <a:t>· L_style — khớp mean/std ở 4 tầng VGG → giống tông thời tiết.</a:t>
-            </a:r>
-          </a:p>
-          <a:p>
-            <a:pPr algn="l">
-              <a:lnSpc>
-                <a:spcPct val="115000"/>
-              </a:lnSpc>
-              <a:spcAft>
-                <a:spcPts val="600"/>
-              </a:spcAft>
-            </a:pPr>
-            <a:r>
-              <a:rPr sz="1400" b="0">
-                <a:solidFill>
-                  <a:srgbClr val="5A6375"/>
-                </a:solidFill>
-                <a:latin typeface="Arial"/>
-              </a:rPr>
-              <a:t>· L_identity — khi style = content thì đầu ra phải bằng ảnh gốc.</a:t>
-            </a:r>
-          </a:p>
-          <a:p>
-            <a:pPr algn="l">
-              <a:lnSpc>
-                <a:spcPct val="115000"/>
-              </a:lnSpc>
-              <a:spcAft>
-                <a:spcPts val="600"/>
-              </a:spcAft>
-            </a:pPr>
-            <a:r>
-              <a:rPr sz="1400" b="0">
-                <a:solidFill>
-                  <a:srgbClr val="5A6375"/>
-                </a:solidFill>
-                <a:latin typeface="Arial"/>
-              </a:rPr>
-              <a:t>   Đây là điểm bổ sung so với AdaIN gốc: ép decoder trung thực,</a:t>
-            </a:r>
-          </a:p>
-          <a:p>
-            <a:pPr algn="l">
-              <a:lnSpc>
-                <a:spcPct val="115000"/>
-              </a:lnSpc>
-              <a:spcAft>
-                <a:spcPts val="600"/>
-              </a:spcAft>
-            </a:pPr>
-            <a:r>
-              <a:rPr sz="1400" b="0">
-                <a:solidFill>
-                  <a:srgbClr val="5A6375"/>
-                </a:solidFill>
-                <a:latin typeface="Arial"/>
-              </a:rPr>
-              <a:t>   giảm méo cấu trúc — điều kiện sống còn để nhãn còn dùng được.</a:t>
-            </a:r>
-          </a:p>
-        </p:txBody>
-      </p:sp>
-      <p:pic>
-        <p:nvPicPr>
-          <p:cNvPr id="34" name="Picture 33" descr="fig_loss.png"/>
-          <p:cNvPicPr>
-            <a:picLocks noChangeAspect="1"/>
-          </p:cNvPicPr>
-          <p:nvPr/>
-        </p:nvPicPr>
-        <p:blipFill>
-          <a:blip r:embed="rId2"/>
-          <a:stretch>
-            <a:fillRect/>
-          </a:stretch>
-        </p:blipFill>
-        <p:spPr>
-          <a:xfrm>
-            <a:off x="2123667" y="4434840"/>
-            <a:ext cx="7914185" cy="2011680"/>
-          </a:xfrm>
-          <a:prstGeom prst="rect">
-            <a:avLst/>
-          </a:prstGeom>
-        </p:spPr>
-      </p:pic>
+              <a:t>Hệ quả: thời tiết mới chỉ cần đưa ảnh tham chiếu vào, KHÔNG huấn luyện lại.</a:t>
+            </a:r>
+          </a:p>
+        </p:txBody>
+      </p:sp>
     </p:spTree>
   </p:cSld>
   <p:clrMapOvr>
@@ -13832,7 +12838,7 @@
                 </a:solidFill>
                 <a:latin typeface="Arial"/>
               </a:rPr>
-              <a:t>Kết quả — 5 loại thời tiết</a:t>
+              <a:t>Huấn luyện</a:t>
             </a:r>
           </a:p>
           <a:p>
@@ -13851,7 +12857,7 @@
                 </a:solidFill>
                 <a:latin typeface="Arial"/>
               </a:rPr>
-              <a:t>Cùng một ảnh gốc, đổi ảnh tham chiếu là đổi thời tiết</a:t>
+              <a:t>Chỉ Decoder được học — VGG-19 đóng băng hoàn toàn</a:t>
             </a:r>
           </a:p>
         </p:txBody>
@@ -13898,9 +12904,1317 @@
           </a:p>
         </p:txBody>
       </p:sp>
+      <p:sp>
+        <p:nvSpPr>
+          <p:cNvPr id="6" name="Rectangle 5"/>
+          <p:cNvSpPr/>
+          <p:nvPr/>
+        </p:nvSpPr>
+        <p:spPr>
+          <a:xfrm>
+            <a:off x="640080" y="1280160"/>
+            <a:ext cx="5120640" cy="329184"/>
+          </a:xfrm>
+          <a:prstGeom prst="rect">
+            <a:avLst/>
+          </a:prstGeom>
+          <a:solidFill>
+            <a:srgbClr val="101B33"/>
+          </a:solidFill>
+          <a:ln>
+            <a:noFill/>
+          </a:ln>
+          <a:effectLst/>
+        </p:spPr>
+        <p:style>
+          <a:lnRef idx="1">
+            <a:schemeClr val="accent1"/>
+          </a:lnRef>
+          <a:fillRef idx="3">
+            <a:schemeClr val="accent1"/>
+          </a:fillRef>
+          <a:effectRef idx="2">
+            <a:schemeClr val="accent1"/>
+          </a:effectRef>
+          <a:fontRef idx="minor">
+            <a:schemeClr val="lt1"/>
+          </a:fontRef>
+        </p:style>
+        <p:txBody>
+          <a:bodyPr rtlCol="0" anchor="ctr"/>
+          <a:lstStyle/>
+          <a:p>
+            <a:pPr algn="ctr"/>
+          </a:p>
+        </p:txBody>
+      </p:sp>
+      <p:sp>
+        <p:nvSpPr>
+          <p:cNvPr id="7" name="TextBox 6"/>
+          <p:cNvSpPr txBox="1"/>
+          <p:nvPr/>
+        </p:nvSpPr>
+        <p:spPr>
+          <a:xfrm>
+            <a:off x="749808" y="1344168"/>
+            <a:ext cx="1920240" cy="329184"/>
+          </a:xfrm>
+          <a:prstGeom prst="rect">
+            <a:avLst/>
+          </a:prstGeom>
+          <a:noFill/>
+        </p:spPr>
+        <p:txBody>
+          <a:bodyPr wrap="square" lIns="0" rIns="0">
+            <a:spAutoFit/>
+          </a:bodyPr>
+          <a:lstStyle/>
+          <a:p>
+            <a:pPr algn="l">
+              <a:lnSpc>
+                <a:spcPct val="115000"/>
+              </a:lnSpc>
+              <a:spcAft>
+                <a:spcPts val="600"/>
+              </a:spcAft>
+            </a:pPr>
+            <a:r>
+              <a:rPr sz="1300" b="1">
+                <a:solidFill>
+                  <a:srgbClr val="FFFFFF"/>
+                </a:solidFill>
+                <a:latin typeface="Arial"/>
+              </a:rPr>
+              <a:t>Thành phần</a:t>
+            </a:r>
+          </a:p>
+        </p:txBody>
+      </p:sp>
+      <p:sp>
+        <p:nvSpPr>
+          <p:cNvPr id="8" name="TextBox 7"/>
+          <p:cNvSpPr txBox="1"/>
+          <p:nvPr/>
+        </p:nvSpPr>
+        <p:spPr>
+          <a:xfrm>
+            <a:off x="2670048" y="1344168"/>
+            <a:ext cx="3200400" cy="329184"/>
+          </a:xfrm>
+          <a:prstGeom prst="rect">
+            <a:avLst/>
+          </a:prstGeom>
+          <a:noFill/>
+        </p:spPr>
+        <p:txBody>
+          <a:bodyPr wrap="square" lIns="0" rIns="0">
+            <a:spAutoFit/>
+          </a:bodyPr>
+          <a:lstStyle/>
+          <a:p>
+            <a:pPr algn="l">
+              <a:lnSpc>
+                <a:spcPct val="115000"/>
+              </a:lnSpc>
+              <a:spcAft>
+                <a:spcPts val="600"/>
+              </a:spcAft>
+            </a:pPr>
+            <a:r>
+              <a:rPr sz="1300" b="1">
+                <a:solidFill>
+                  <a:srgbClr val="FFFFFF"/>
+                </a:solidFill>
+                <a:latin typeface="Arial"/>
+              </a:rPr>
+              <a:t>Giá trị</a:t>
+            </a:r>
+          </a:p>
+        </p:txBody>
+      </p:sp>
+      <p:sp>
+        <p:nvSpPr>
+          <p:cNvPr id="9" name="Rectangle 8"/>
+          <p:cNvSpPr/>
+          <p:nvPr/>
+        </p:nvSpPr>
+        <p:spPr>
+          <a:xfrm>
+            <a:off x="640080" y="1609344"/>
+            <a:ext cx="5120640" cy="329184"/>
+          </a:xfrm>
+          <a:prstGeom prst="rect">
+            <a:avLst/>
+          </a:prstGeom>
+          <a:solidFill>
+            <a:srgbClr val="F4F6FA"/>
+          </a:solidFill>
+          <a:ln>
+            <a:noFill/>
+          </a:ln>
+          <a:effectLst/>
+        </p:spPr>
+        <p:style>
+          <a:lnRef idx="1">
+            <a:schemeClr val="accent1"/>
+          </a:lnRef>
+          <a:fillRef idx="3">
+            <a:schemeClr val="accent1"/>
+          </a:fillRef>
+          <a:effectRef idx="2">
+            <a:schemeClr val="accent1"/>
+          </a:effectRef>
+          <a:fontRef idx="minor">
+            <a:schemeClr val="lt1"/>
+          </a:fontRef>
+        </p:style>
+        <p:txBody>
+          <a:bodyPr rtlCol="0" anchor="ctr"/>
+          <a:lstStyle/>
+          <a:p>
+            <a:pPr algn="ctr"/>
+          </a:p>
+        </p:txBody>
+      </p:sp>
+      <p:sp>
+        <p:nvSpPr>
+          <p:cNvPr id="10" name="TextBox 9"/>
+          <p:cNvSpPr txBox="1"/>
+          <p:nvPr/>
+        </p:nvSpPr>
+        <p:spPr>
+          <a:xfrm>
+            <a:off x="749808" y="1673352"/>
+            <a:ext cx="1920240" cy="329184"/>
+          </a:xfrm>
+          <a:prstGeom prst="rect">
+            <a:avLst/>
+          </a:prstGeom>
+          <a:noFill/>
+        </p:spPr>
+        <p:txBody>
+          <a:bodyPr wrap="square" lIns="0" rIns="0">
+            <a:spAutoFit/>
+          </a:bodyPr>
+          <a:lstStyle/>
+          <a:p>
+            <a:pPr algn="l">
+              <a:lnSpc>
+                <a:spcPct val="115000"/>
+              </a:lnSpc>
+              <a:spcAft>
+                <a:spcPts val="600"/>
+              </a:spcAft>
+            </a:pPr>
+            <a:r>
+              <a:rPr sz="1300" b="0">
+                <a:solidFill>
+                  <a:srgbClr val="101B33"/>
+                </a:solidFill>
+                <a:latin typeface="Arial"/>
+              </a:rPr>
+              <a:t>Encoder</a:t>
+            </a:r>
+          </a:p>
+        </p:txBody>
+      </p:sp>
+      <p:sp>
+        <p:nvSpPr>
+          <p:cNvPr id="11" name="TextBox 10"/>
+          <p:cNvSpPr txBox="1"/>
+          <p:nvPr/>
+        </p:nvSpPr>
+        <p:spPr>
+          <a:xfrm>
+            <a:off x="2670048" y="1673352"/>
+            <a:ext cx="3200400" cy="329184"/>
+          </a:xfrm>
+          <a:prstGeom prst="rect">
+            <a:avLst/>
+          </a:prstGeom>
+          <a:noFill/>
+        </p:spPr>
+        <p:txBody>
+          <a:bodyPr wrap="square" lIns="0" rIns="0">
+            <a:spAutoFit/>
+          </a:bodyPr>
+          <a:lstStyle/>
+          <a:p>
+            <a:pPr algn="l">
+              <a:lnSpc>
+                <a:spcPct val="115000"/>
+              </a:lnSpc>
+              <a:spcAft>
+                <a:spcPts val="600"/>
+              </a:spcAft>
+            </a:pPr>
+            <a:r>
+              <a:rPr sz="1300" b="0">
+                <a:solidFill>
+                  <a:srgbClr val="101B33"/>
+                </a:solidFill>
+                <a:latin typeface="Arial"/>
+              </a:rPr>
+              <a:t>VGG-19 (ImageNet), đóng băng</a:t>
+            </a:r>
+          </a:p>
+        </p:txBody>
+      </p:sp>
+      <p:sp>
+        <p:nvSpPr>
+          <p:cNvPr id="12" name="Rectangle 11"/>
+          <p:cNvSpPr/>
+          <p:nvPr/>
+        </p:nvSpPr>
+        <p:spPr>
+          <a:xfrm>
+            <a:off x="640080" y="1938528"/>
+            <a:ext cx="5120640" cy="329184"/>
+          </a:xfrm>
+          <a:prstGeom prst="rect">
+            <a:avLst/>
+          </a:prstGeom>
+          <a:solidFill>
+            <a:srgbClr val="FFFFFF"/>
+          </a:solidFill>
+          <a:ln>
+            <a:noFill/>
+          </a:ln>
+          <a:effectLst/>
+        </p:spPr>
+        <p:style>
+          <a:lnRef idx="1">
+            <a:schemeClr val="accent1"/>
+          </a:lnRef>
+          <a:fillRef idx="3">
+            <a:schemeClr val="accent1"/>
+          </a:fillRef>
+          <a:effectRef idx="2">
+            <a:schemeClr val="accent1"/>
+          </a:effectRef>
+          <a:fontRef idx="minor">
+            <a:schemeClr val="lt1"/>
+          </a:fontRef>
+        </p:style>
+        <p:txBody>
+          <a:bodyPr rtlCol="0" anchor="ctr"/>
+          <a:lstStyle/>
+          <a:p>
+            <a:pPr algn="ctr"/>
+          </a:p>
+        </p:txBody>
+      </p:sp>
+      <p:sp>
+        <p:nvSpPr>
+          <p:cNvPr id="13" name="TextBox 12"/>
+          <p:cNvSpPr txBox="1"/>
+          <p:nvPr/>
+        </p:nvSpPr>
+        <p:spPr>
+          <a:xfrm>
+            <a:off x="749808" y="2002536"/>
+            <a:ext cx="1920240" cy="329184"/>
+          </a:xfrm>
+          <a:prstGeom prst="rect">
+            <a:avLst/>
+          </a:prstGeom>
+          <a:noFill/>
+        </p:spPr>
+        <p:txBody>
+          <a:bodyPr wrap="square" lIns="0" rIns="0">
+            <a:spAutoFit/>
+          </a:bodyPr>
+          <a:lstStyle/>
+          <a:p>
+            <a:pPr algn="l">
+              <a:lnSpc>
+                <a:spcPct val="115000"/>
+              </a:lnSpc>
+              <a:spcAft>
+                <a:spcPts val="600"/>
+              </a:spcAft>
+            </a:pPr>
+            <a:r>
+              <a:rPr sz="1300" b="0">
+                <a:solidFill>
+                  <a:srgbClr val="101B33"/>
+                </a:solidFill>
+                <a:latin typeface="Arial"/>
+              </a:rPr>
+              <a:t>Decoder</a:t>
+            </a:r>
+          </a:p>
+        </p:txBody>
+      </p:sp>
+      <p:sp>
+        <p:nvSpPr>
+          <p:cNvPr id="14" name="TextBox 13"/>
+          <p:cNvSpPr txBox="1"/>
+          <p:nvPr/>
+        </p:nvSpPr>
+        <p:spPr>
+          <a:xfrm>
+            <a:off x="2670048" y="2002536"/>
+            <a:ext cx="3200400" cy="329184"/>
+          </a:xfrm>
+          <a:prstGeom prst="rect">
+            <a:avLst/>
+          </a:prstGeom>
+          <a:noFill/>
+        </p:spPr>
+        <p:txBody>
+          <a:bodyPr wrap="square" lIns="0" rIns="0">
+            <a:spAutoFit/>
+          </a:bodyPr>
+          <a:lstStyle/>
+          <a:p>
+            <a:pPr algn="l">
+              <a:lnSpc>
+                <a:spcPct val="115000"/>
+              </a:lnSpc>
+              <a:spcAft>
+                <a:spcPts val="600"/>
+              </a:spcAft>
+            </a:pPr>
+            <a:r>
+              <a:rPr sz="1300" b="0">
+                <a:solidFill>
+                  <a:srgbClr val="101B33"/>
+                </a:solidFill>
+                <a:latin typeface="Arial"/>
+              </a:rPr>
+              <a:t>3,51 M tham số</a:t>
+            </a:r>
+          </a:p>
+        </p:txBody>
+      </p:sp>
+      <p:sp>
+        <p:nvSpPr>
+          <p:cNvPr id="15" name="Rectangle 14"/>
+          <p:cNvSpPr/>
+          <p:nvPr/>
+        </p:nvSpPr>
+        <p:spPr>
+          <a:xfrm>
+            <a:off x="640080" y="2267712"/>
+            <a:ext cx="5120640" cy="329184"/>
+          </a:xfrm>
+          <a:prstGeom prst="rect">
+            <a:avLst/>
+          </a:prstGeom>
+          <a:solidFill>
+            <a:srgbClr val="F4F6FA"/>
+          </a:solidFill>
+          <a:ln>
+            <a:noFill/>
+          </a:ln>
+          <a:effectLst/>
+        </p:spPr>
+        <p:style>
+          <a:lnRef idx="1">
+            <a:schemeClr val="accent1"/>
+          </a:lnRef>
+          <a:fillRef idx="3">
+            <a:schemeClr val="accent1"/>
+          </a:fillRef>
+          <a:effectRef idx="2">
+            <a:schemeClr val="accent1"/>
+          </a:effectRef>
+          <a:fontRef idx="minor">
+            <a:schemeClr val="lt1"/>
+          </a:fontRef>
+        </p:style>
+        <p:txBody>
+          <a:bodyPr rtlCol="0" anchor="ctr"/>
+          <a:lstStyle/>
+          <a:p>
+            <a:pPr algn="ctr"/>
+          </a:p>
+        </p:txBody>
+      </p:sp>
+      <p:sp>
+        <p:nvSpPr>
+          <p:cNvPr id="16" name="TextBox 15"/>
+          <p:cNvSpPr txBox="1"/>
+          <p:nvPr/>
+        </p:nvSpPr>
+        <p:spPr>
+          <a:xfrm>
+            <a:off x="749808" y="2331720"/>
+            <a:ext cx="1920240" cy="329184"/>
+          </a:xfrm>
+          <a:prstGeom prst="rect">
+            <a:avLst/>
+          </a:prstGeom>
+          <a:noFill/>
+        </p:spPr>
+        <p:txBody>
+          <a:bodyPr wrap="square" lIns="0" rIns="0">
+            <a:spAutoFit/>
+          </a:bodyPr>
+          <a:lstStyle/>
+          <a:p>
+            <a:pPr algn="l">
+              <a:lnSpc>
+                <a:spcPct val="115000"/>
+              </a:lnSpc>
+              <a:spcAft>
+                <a:spcPts val="600"/>
+              </a:spcAft>
+            </a:pPr>
+            <a:r>
+              <a:rPr sz="1300" b="0">
+                <a:solidFill>
+                  <a:srgbClr val="101B33"/>
+                </a:solidFill>
+                <a:latin typeface="Arial"/>
+              </a:rPr>
+              <a:t>Ảnh huấn luyện</a:t>
+            </a:r>
+          </a:p>
+        </p:txBody>
+      </p:sp>
+      <p:sp>
+        <p:nvSpPr>
+          <p:cNvPr id="17" name="TextBox 16"/>
+          <p:cNvSpPr txBox="1"/>
+          <p:nvPr/>
+        </p:nvSpPr>
+        <p:spPr>
+          <a:xfrm>
+            <a:off x="2670048" y="2331720"/>
+            <a:ext cx="3200400" cy="329184"/>
+          </a:xfrm>
+          <a:prstGeom prst="rect">
+            <a:avLst/>
+          </a:prstGeom>
+          <a:noFill/>
+        </p:spPr>
+        <p:txBody>
+          <a:bodyPr wrap="square" lIns="0" rIns="0">
+            <a:spAutoFit/>
+          </a:bodyPr>
+          <a:lstStyle/>
+          <a:p>
+            <a:pPr algn="l">
+              <a:lnSpc>
+                <a:spcPct val="115000"/>
+              </a:lnSpc>
+              <a:spcAft>
+                <a:spcPts val="600"/>
+              </a:spcAft>
+            </a:pPr>
+            <a:r>
+              <a:rPr sz="1300" b="0">
+                <a:solidFill>
+                  <a:srgbClr val="101B33"/>
+                </a:solidFill>
+                <a:latin typeface="Arial"/>
+              </a:rPr>
+              <a:t>2.160 nội dung × 1.327 style</a:t>
+            </a:r>
+          </a:p>
+        </p:txBody>
+      </p:sp>
+      <p:sp>
+        <p:nvSpPr>
+          <p:cNvPr id="18" name="Rectangle 17"/>
+          <p:cNvSpPr/>
+          <p:nvPr/>
+        </p:nvSpPr>
+        <p:spPr>
+          <a:xfrm>
+            <a:off x="640080" y="2596896"/>
+            <a:ext cx="5120640" cy="329184"/>
+          </a:xfrm>
+          <a:prstGeom prst="rect">
+            <a:avLst/>
+          </a:prstGeom>
+          <a:solidFill>
+            <a:srgbClr val="FFFFFF"/>
+          </a:solidFill>
+          <a:ln>
+            <a:noFill/>
+          </a:ln>
+          <a:effectLst/>
+        </p:spPr>
+        <p:style>
+          <a:lnRef idx="1">
+            <a:schemeClr val="accent1"/>
+          </a:lnRef>
+          <a:fillRef idx="3">
+            <a:schemeClr val="accent1"/>
+          </a:fillRef>
+          <a:effectRef idx="2">
+            <a:schemeClr val="accent1"/>
+          </a:effectRef>
+          <a:fontRef idx="minor">
+            <a:schemeClr val="lt1"/>
+          </a:fontRef>
+        </p:style>
+        <p:txBody>
+          <a:bodyPr rtlCol="0" anchor="ctr"/>
+          <a:lstStyle/>
+          <a:p>
+            <a:pPr algn="ctr"/>
+          </a:p>
+        </p:txBody>
+      </p:sp>
+      <p:sp>
+        <p:nvSpPr>
+          <p:cNvPr id="19" name="TextBox 18"/>
+          <p:cNvSpPr txBox="1"/>
+          <p:nvPr/>
+        </p:nvSpPr>
+        <p:spPr>
+          <a:xfrm>
+            <a:off x="749808" y="2660904"/>
+            <a:ext cx="1920240" cy="329184"/>
+          </a:xfrm>
+          <a:prstGeom prst="rect">
+            <a:avLst/>
+          </a:prstGeom>
+          <a:noFill/>
+        </p:spPr>
+        <p:txBody>
+          <a:bodyPr wrap="square" lIns="0" rIns="0">
+            <a:spAutoFit/>
+          </a:bodyPr>
+          <a:lstStyle/>
+          <a:p>
+            <a:pPr algn="l">
+              <a:lnSpc>
+                <a:spcPct val="115000"/>
+              </a:lnSpc>
+              <a:spcAft>
+                <a:spcPts val="600"/>
+              </a:spcAft>
+            </a:pPr>
+            <a:r>
+              <a:rPr sz="1300" b="0">
+                <a:solidFill>
+                  <a:srgbClr val="101B33"/>
+                </a:solidFill>
+                <a:latin typeface="Arial"/>
+              </a:rPr>
+              <a:t>Kích thước</a:t>
+            </a:r>
+          </a:p>
+        </p:txBody>
+      </p:sp>
+      <p:sp>
+        <p:nvSpPr>
+          <p:cNvPr id="20" name="TextBox 19"/>
+          <p:cNvSpPr txBox="1"/>
+          <p:nvPr/>
+        </p:nvSpPr>
+        <p:spPr>
+          <a:xfrm>
+            <a:off x="2670048" y="2660904"/>
+            <a:ext cx="3200400" cy="329184"/>
+          </a:xfrm>
+          <a:prstGeom prst="rect">
+            <a:avLst/>
+          </a:prstGeom>
+          <a:noFill/>
+        </p:spPr>
+        <p:txBody>
+          <a:bodyPr wrap="square" lIns="0" rIns="0">
+            <a:spAutoFit/>
+          </a:bodyPr>
+          <a:lstStyle/>
+          <a:p>
+            <a:pPr algn="l">
+              <a:lnSpc>
+                <a:spcPct val="115000"/>
+              </a:lnSpc>
+              <a:spcAft>
+                <a:spcPts val="600"/>
+              </a:spcAft>
+            </a:pPr>
+            <a:r>
+              <a:rPr sz="1300" b="0">
+                <a:solidFill>
+                  <a:srgbClr val="101B33"/>
+                </a:solidFill>
+                <a:latin typeface="Arial"/>
+              </a:rPr>
+              <a:t>resize 320 → crop 256</a:t>
+            </a:r>
+          </a:p>
+        </p:txBody>
+      </p:sp>
+      <p:sp>
+        <p:nvSpPr>
+          <p:cNvPr id="21" name="Rectangle 20"/>
+          <p:cNvSpPr/>
+          <p:nvPr/>
+        </p:nvSpPr>
+        <p:spPr>
+          <a:xfrm>
+            <a:off x="640080" y="2926080"/>
+            <a:ext cx="5120640" cy="329184"/>
+          </a:xfrm>
+          <a:prstGeom prst="rect">
+            <a:avLst/>
+          </a:prstGeom>
+          <a:solidFill>
+            <a:srgbClr val="F4F6FA"/>
+          </a:solidFill>
+          <a:ln>
+            <a:noFill/>
+          </a:ln>
+          <a:effectLst/>
+        </p:spPr>
+        <p:style>
+          <a:lnRef idx="1">
+            <a:schemeClr val="accent1"/>
+          </a:lnRef>
+          <a:fillRef idx="3">
+            <a:schemeClr val="accent1"/>
+          </a:fillRef>
+          <a:effectRef idx="2">
+            <a:schemeClr val="accent1"/>
+          </a:effectRef>
+          <a:fontRef idx="minor">
+            <a:schemeClr val="lt1"/>
+          </a:fontRef>
+        </p:style>
+        <p:txBody>
+          <a:bodyPr rtlCol="0" anchor="ctr"/>
+          <a:lstStyle/>
+          <a:p>
+            <a:pPr algn="ctr"/>
+          </a:p>
+        </p:txBody>
+      </p:sp>
+      <p:sp>
+        <p:nvSpPr>
+          <p:cNvPr id="22" name="TextBox 21"/>
+          <p:cNvSpPr txBox="1"/>
+          <p:nvPr/>
+        </p:nvSpPr>
+        <p:spPr>
+          <a:xfrm>
+            <a:off x="749808" y="2990088"/>
+            <a:ext cx="1920240" cy="329184"/>
+          </a:xfrm>
+          <a:prstGeom prst="rect">
+            <a:avLst/>
+          </a:prstGeom>
+          <a:noFill/>
+        </p:spPr>
+        <p:txBody>
+          <a:bodyPr wrap="square" lIns="0" rIns="0">
+            <a:spAutoFit/>
+          </a:bodyPr>
+          <a:lstStyle/>
+          <a:p>
+            <a:pPr algn="l">
+              <a:lnSpc>
+                <a:spcPct val="115000"/>
+              </a:lnSpc>
+              <a:spcAft>
+                <a:spcPts val="600"/>
+              </a:spcAft>
+            </a:pPr>
+            <a:r>
+              <a:rPr sz="1300" b="0">
+                <a:solidFill>
+                  <a:srgbClr val="101B33"/>
+                </a:solidFill>
+                <a:latin typeface="Arial"/>
+              </a:rPr>
+              <a:t>Batch / bước</a:t>
+            </a:r>
+          </a:p>
+        </p:txBody>
+      </p:sp>
+      <p:sp>
+        <p:nvSpPr>
+          <p:cNvPr id="23" name="TextBox 22"/>
+          <p:cNvSpPr txBox="1"/>
+          <p:nvPr/>
+        </p:nvSpPr>
+        <p:spPr>
+          <a:xfrm>
+            <a:off x="2670048" y="2990088"/>
+            <a:ext cx="3200400" cy="329184"/>
+          </a:xfrm>
+          <a:prstGeom prst="rect">
+            <a:avLst/>
+          </a:prstGeom>
+          <a:noFill/>
+        </p:spPr>
+        <p:txBody>
+          <a:bodyPr wrap="square" lIns="0" rIns="0">
+            <a:spAutoFit/>
+          </a:bodyPr>
+          <a:lstStyle/>
+          <a:p>
+            <a:pPr algn="l">
+              <a:lnSpc>
+                <a:spcPct val="115000"/>
+              </a:lnSpc>
+              <a:spcAft>
+                <a:spcPts val="600"/>
+              </a:spcAft>
+            </a:pPr>
+            <a:r>
+              <a:rPr sz="1300" b="0">
+                <a:solidFill>
+                  <a:srgbClr val="101B33"/>
+                </a:solidFill>
+                <a:latin typeface="Arial"/>
+              </a:rPr>
+              <a:t>8 / 12.000</a:t>
+            </a:r>
+          </a:p>
+        </p:txBody>
+      </p:sp>
+      <p:sp>
+        <p:nvSpPr>
+          <p:cNvPr id="24" name="Rectangle 23"/>
+          <p:cNvSpPr/>
+          <p:nvPr/>
+        </p:nvSpPr>
+        <p:spPr>
+          <a:xfrm>
+            <a:off x="640080" y="3255264"/>
+            <a:ext cx="5120640" cy="329184"/>
+          </a:xfrm>
+          <a:prstGeom prst="rect">
+            <a:avLst/>
+          </a:prstGeom>
+          <a:solidFill>
+            <a:srgbClr val="FFFFFF"/>
+          </a:solidFill>
+          <a:ln>
+            <a:noFill/>
+          </a:ln>
+          <a:effectLst/>
+        </p:spPr>
+        <p:style>
+          <a:lnRef idx="1">
+            <a:schemeClr val="accent1"/>
+          </a:lnRef>
+          <a:fillRef idx="3">
+            <a:schemeClr val="accent1"/>
+          </a:fillRef>
+          <a:effectRef idx="2">
+            <a:schemeClr val="accent1"/>
+          </a:effectRef>
+          <a:fontRef idx="minor">
+            <a:schemeClr val="lt1"/>
+          </a:fontRef>
+        </p:style>
+        <p:txBody>
+          <a:bodyPr rtlCol="0" anchor="ctr"/>
+          <a:lstStyle/>
+          <a:p>
+            <a:pPr algn="ctr"/>
+          </a:p>
+        </p:txBody>
+      </p:sp>
+      <p:sp>
+        <p:nvSpPr>
+          <p:cNvPr id="25" name="TextBox 24"/>
+          <p:cNvSpPr txBox="1"/>
+          <p:nvPr/>
+        </p:nvSpPr>
+        <p:spPr>
+          <a:xfrm>
+            <a:off x="749808" y="3319272"/>
+            <a:ext cx="1920240" cy="329184"/>
+          </a:xfrm>
+          <a:prstGeom prst="rect">
+            <a:avLst/>
+          </a:prstGeom>
+          <a:noFill/>
+        </p:spPr>
+        <p:txBody>
+          <a:bodyPr wrap="square" lIns="0" rIns="0">
+            <a:spAutoFit/>
+          </a:bodyPr>
+          <a:lstStyle/>
+          <a:p>
+            <a:pPr algn="l">
+              <a:lnSpc>
+                <a:spcPct val="115000"/>
+              </a:lnSpc>
+              <a:spcAft>
+                <a:spcPts val="600"/>
+              </a:spcAft>
+            </a:pPr>
+            <a:r>
+              <a:rPr sz="1300" b="0">
+                <a:solidFill>
+                  <a:srgbClr val="101B33"/>
+                </a:solidFill>
+                <a:latin typeface="Arial"/>
+              </a:rPr>
+              <a:t>Optimizer</a:t>
+            </a:r>
+          </a:p>
+        </p:txBody>
+      </p:sp>
+      <p:sp>
+        <p:nvSpPr>
+          <p:cNvPr id="26" name="TextBox 25"/>
+          <p:cNvSpPr txBox="1"/>
+          <p:nvPr/>
+        </p:nvSpPr>
+        <p:spPr>
+          <a:xfrm>
+            <a:off x="2670048" y="3319272"/>
+            <a:ext cx="3200400" cy="329184"/>
+          </a:xfrm>
+          <a:prstGeom prst="rect">
+            <a:avLst/>
+          </a:prstGeom>
+          <a:noFill/>
+        </p:spPr>
+        <p:txBody>
+          <a:bodyPr wrap="square" lIns="0" rIns="0">
+            <a:spAutoFit/>
+          </a:bodyPr>
+          <a:lstStyle/>
+          <a:p>
+            <a:pPr algn="l">
+              <a:lnSpc>
+                <a:spcPct val="115000"/>
+              </a:lnSpc>
+              <a:spcAft>
+                <a:spcPts val="600"/>
+              </a:spcAft>
+            </a:pPr>
+            <a:r>
+              <a:rPr sz="1300" b="0">
+                <a:solidFill>
+                  <a:srgbClr val="101B33"/>
+                </a:solidFill>
+                <a:latin typeface="Arial"/>
+              </a:rPr>
+              <a:t>Adam, lr 1e-4, decay 5e-5</a:t>
+            </a:r>
+          </a:p>
+        </p:txBody>
+      </p:sp>
+      <p:sp>
+        <p:nvSpPr>
+          <p:cNvPr id="27" name="Rectangle 26"/>
+          <p:cNvSpPr/>
+          <p:nvPr/>
+        </p:nvSpPr>
+        <p:spPr>
+          <a:xfrm>
+            <a:off x="640080" y="3584448"/>
+            <a:ext cx="5120640" cy="329184"/>
+          </a:xfrm>
+          <a:prstGeom prst="rect">
+            <a:avLst/>
+          </a:prstGeom>
+          <a:solidFill>
+            <a:srgbClr val="F4F6FA"/>
+          </a:solidFill>
+          <a:ln>
+            <a:noFill/>
+          </a:ln>
+          <a:effectLst/>
+        </p:spPr>
+        <p:style>
+          <a:lnRef idx="1">
+            <a:schemeClr val="accent1"/>
+          </a:lnRef>
+          <a:fillRef idx="3">
+            <a:schemeClr val="accent1"/>
+          </a:fillRef>
+          <a:effectRef idx="2">
+            <a:schemeClr val="accent1"/>
+          </a:effectRef>
+          <a:fontRef idx="minor">
+            <a:schemeClr val="lt1"/>
+          </a:fontRef>
+        </p:style>
+        <p:txBody>
+          <a:bodyPr rtlCol="0" anchor="ctr"/>
+          <a:lstStyle/>
+          <a:p>
+            <a:pPr algn="ctr"/>
+          </a:p>
+        </p:txBody>
+      </p:sp>
+      <p:sp>
+        <p:nvSpPr>
+          <p:cNvPr id="28" name="TextBox 27"/>
+          <p:cNvSpPr txBox="1"/>
+          <p:nvPr/>
+        </p:nvSpPr>
+        <p:spPr>
+          <a:xfrm>
+            <a:off x="749808" y="3648456"/>
+            <a:ext cx="1920240" cy="329184"/>
+          </a:xfrm>
+          <a:prstGeom prst="rect">
+            <a:avLst/>
+          </a:prstGeom>
+          <a:noFill/>
+        </p:spPr>
+        <p:txBody>
+          <a:bodyPr wrap="square" lIns="0" rIns="0">
+            <a:spAutoFit/>
+          </a:bodyPr>
+          <a:lstStyle/>
+          <a:p>
+            <a:pPr algn="l">
+              <a:lnSpc>
+                <a:spcPct val="115000"/>
+              </a:lnSpc>
+              <a:spcAft>
+                <a:spcPts val="600"/>
+              </a:spcAft>
+            </a:pPr>
+            <a:r>
+              <a:rPr sz="1300" b="0">
+                <a:solidFill>
+                  <a:srgbClr val="101B33"/>
+                </a:solidFill>
+                <a:latin typeface="Arial"/>
+              </a:rPr>
+              <a:t>Mixed precision</a:t>
+            </a:r>
+          </a:p>
+        </p:txBody>
+      </p:sp>
+      <p:sp>
+        <p:nvSpPr>
+          <p:cNvPr id="29" name="TextBox 28"/>
+          <p:cNvSpPr txBox="1"/>
+          <p:nvPr/>
+        </p:nvSpPr>
+        <p:spPr>
+          <a:xfrm>
+            <a:off x="2670048" y="3648456"/>
+            <a:ext cx="3200400" cy="329184"/>
+          </a:xfrm>
+          <a:prstGeom prst="rect">
+            <a:avLst/>
+          </a:prstGeom>
+          <a:noFill/>
+        </p:spPr>
+        <p:txBody>
+          <a:bodyPr wrap="square" lIns="0" rIns="0">
+            <a:spAutoFit/>
+          </a:bodyPr>
+          <a:lstStyle/>
+          <a:p>
+            <a:pPr algn="l">
+              <a:lnSpc>
+                <a:spcPct val="115000"/>
+              </a:lnSpc>
+              <a:spcAft>
+                <a:spcPts val="600"/>
+              </a:spcAft>
+            </a:pPr>
+            <a:r>
+              <a:rPr sz="1300" b="0">
+                <a:solidFill>
+                  <a:srgbClr val="101B33"/>
+                </a:solidFill>
+                <a:latin typeface="Arial"/>
+              </a:rPr>
+              <a:t>bfloat16</a:t>
+            </a:r>
+          </a:p>
+        </p:txBody>
+      </p:sp>
+      <p:sp>
+        <p:nvSpPr>
+          <p:cNvPr id="30" name="Rectangle 29"/>
+          <p:cNvSpPr/>
+          <p:nvPr/>
+        </p:nvSpPr>
+        <p:spPr>
+          <a:xfrm>
+            <a:off x="640080" y="3913632"/>
+            <a:ext cx="5120640" cy="329184"/>
+          </a:xfrm>
+          <a:prstGeom prst="rect">
+            <a:avLst/>
+          </a:prstGeom>
+          <a:solidFill>
+            <a:srgbClr val="FFFFFF"/>
+          </a:solidFill>
+          <a:ln>
+            <a:noFill/>
+          </a:ln>
+          <a:effectLst/>
+        </p:spPr>
+        <p:style>
+          <a:lnRef idx="1">
+            <a:schemeClr val="accent1"/>
+          </a:lnRef>
+          <a:fillRef idx="3">
+            <a:schemeClr val="accent1"/>
+          </a:fillRef>
+          <a:effectRef idx="2">
+            <a:schemeClr val="accent1"/>
+          </a:effectRef>
+          <a:fontRef idx="minor">
+            <a:schemeClr val="lt1"/>
+          </a:fontRef>
+        </p:style>
+        <p:txBody>
+          <a:bodyPr rtlCol="0" anchor="ctr"/>
+          <a:lstStyle/>
+          <a:p>
+            <a:pPr algn="ctr"/>
+          </a:p>
+        </p:txBody>
+      </p:sp>
+      <p:sp>
+        <p:nvSpPr>
+          <p:cNvPr id="31" name="TextBox 30"/>
+          <p:cNvSpPr txBox="1"/>
+          <p:nvPr/>
+        </p:nvSpPr>
+        <p:spPr>
+          <a:xfrm>
+            <a:off x="749808" y="3977640"/>
+            <a:ext cx="1920240" cy="329184"/>
+          </a:xfrm>
+          <a:prstGeom prst="rect">
+            <a:avLst/>
+          </a:prstGeom>
+          <a:noFill/>
+        </p:spPr>
+        <p:txBody>
+          <a:bodyPr wrap="square" lIns="0" rIns="0">
+            <a:spAutoFit/>
+          </a:bodyPr>
+          <a:lstStyle/>
+          <a:p>
+            <a:pPr algn="l">
+              <a:lnSpc>
+                <a:spcPct val="115000"/>
+              </a:lnSpc>
+              <a:spcAft>
+                <a:spcPts val="600"/>
+              </a:spcAft>
+            </a:pPr>
+            <a:r>
+              <a:rPr sz="1300" b="0">
+                <a:solidFill>
+                  <a:srgbClr val="101B33"/>
+                </a:solidFill>
+                <a:latin typeface="Arial"/>
+              </a:rPr>
+              <a:t>Thời gian</a:t>
+            </a:r>
+          </a:p>
+        </p:txBody>
+      </p:sp>
+      <p:sp>
+        <p:nvSpPr>
+          <p:cNvPr id="32" name="TextBox 31"/>
+          <p:cNvSpPr txBox="1"/>
+          <p:nvPr/>
+        </p:nvSpPr>
+        <p:spPr>
+          <a:xfrm>
+            <a:off x="2670048" y="3977640"/>
+            <a:ext cx="3200400" cy="329184"/>
+          </a:xfrm>
+          <a:prstGeom prst="rect">
+            <a:avLst/>
+          </a:prstGeom>
+          <a:noFill/>
+        </p:spPr>
+        <p:txBody>
+          <a:bodyPr wrap="square" lIns="0" rIns="0">
+            <a:spAutoFit/>
+          </a:bodyPr>
+          <a:lstStyle/>
+          <a:p>
+            <a:pPr algn="l">
+              <a:lnSpc>
+                <a:spcPct val="115000"/>
+              </a:lnSpc>
+              <a:spcAft>
+                <a:spcPts val="600"/>
+              </a:spcAft>
+            </a:pPr>
+            <a:r>
+              <a:rPr sz="1300" b="0">
+                <a:solidFill>
+                  <a:srgbClr val="101B33"/>
+                </a:solidFill>
+                <a:latin typeface="Arial"/>
+              </a:rPr>
+              <a:t>37 phút (RTX 5060 Ti)</a:t>
+            </a:r>
+          </a:p>
+        </p:txBody>
+      </p:sp>
+      <p:sp>
+        <p:nvSpPr>
+          <p:cNvPr id="33" name="TextBox 32"/>
+          <p:cNvSpPr txBox="1"/>
+          <p:nvPr/>
+        </p:nvSpPr>
+        <p:spPr>
+          <a:xfrm>
+            <a:off x="6126480" y="1280160"/>
+            <a:ext cx="5394960" cy="2194560"/>
+          </a:xfrm>
+          <a:prstGeom prst="rect">
+            <a:avLst/>
+          </a:prstGeom>
+          <a:noFill/>
+        </p:spPr>
+        <p:txBody>
+          <a:bodyPr wrap="square" lIns="0" rIns="0">
+            <a:spAutoFit/>
+          </a:bodyPr>
+          <a:lstStyle/>
+          <a:p>
+            <a:pPr algn="l">
+              <a:lnSpc>
+                <a:spcPct val="115000"/>
+              </a:lnSpc>
+              <a:spcAft>
+                <a:spcPts val="600"/>
+              </a:spcAft>
+            </a:pPr>
+            <a:r>
+              <a:rPr sz="1900" b="1">
+                <a:solidFill>
+                  <a:srgbClr val="101B33"/>
+                </a:solidFill>
+                <a:latin typeface="Arial"/>
+              </a:rPr>
+              <a:t>Hàm mất mát</a:t>
+            </a:r>
+          </a:p>
+          <a:p>
+            <a:pPr algn="l">
+              <a:lnSpc>
+                <a:spcPct val="115000"/>
+              </a:lnSpc>
+              <a:spcAft>
+                <a:spcPts val="600"/>
+              </a:spcAft>
+            </a:pPr>
+            <a:r>
+              <a:rPr sz="1500" b="1">
+                <a:solidFill>
+                  <a:srgbClr val="2E6FD9"/>
+                </a:solidFill>
+                <a:latin typeface="Arial"/>
+              </a:rPr>
+              <a:t>L  =  L_content  +  10 · L_style  +  1 · L_identity</a:t>
+            </a:r>
+          </a:p>
+          <a:p>
+            <a:pPr algn="l">
+              <a:lnSpc>
+                <a:spcPct val="115000"/>
+              </a:lnSpc>
+              <a:spcAft>
+                <a:spcPts val="600"/>
+              </a:spcAft>
+            </a:pPr>
+            <a:r>
+              <a:rPr sz="1400" b="0">
+                <a:solidFill>
+                  <a:srgbClr val="5A6375"/>
+                </a:solidFill>
+                <a:latin typeface="Arial"/>
+              </a:rPr>
+              <a:t>· L_content — khớp đặc trưng đầu ra với đặc trưng AdaIN → giữ bố cục.</a:t>
+            </a:r>
+          </a:p>
+          <a:p>
+            <a:pPr algn="l">
+              <a:lnSpc>
+                <a:spcPct val="115000"/>
+              </a:lnSpc>
+              <a:spcAft>
+                <a:spcPts val="600"/>
+              </a:spcAft>
+            </a:pPr>
+            <a:r>
+              <a:rPr sz="1400" b="0">
+                <a:solidFill>
+                  <a:srgbClr val="5A6375"/>
+                </a:solidFill>
+                <a:latin typeface="Arial"/>
+              </a:rPr>
+              <a:t>· L_style — khớp mean/std ở 4 tầng VGG → giống tông thời tiết.</a:t>
+            </a:r>
+          </a:p>
+          <a:p>
+            <a:pPr algn="l">
+              <a:lnSpc>
+                <a:spcPct val="115000"/>
+              </a:lnSpc>
+              <a:spcAft>
+                <a:spcPts val="600"/>
+              </a:spcAft>
+            </a:pPr>
+            <a:r>
+              <a:rPr sz="1400" b="0">
+                <a:solidFill>
+                  <a:srgbClr val="5A6375"/>
+                </a:solidFill>
+                <a:latin typeface="Arial"/>
+              </a:rPr>
+              <a:t>· L_identity — khi style = content thì đầu ra phải bằng ảnh gốc.</a:t>
+            </a:r>
+          </a:p>
+          <a:p>
+            <a:pPr algn="l">
+              <a:lnSpc>
+                <a:spcPct val="115000"/>
+              </a:lnSpc>
+              <a:spcAft>
+                <a:spcPts val="600"/>
+              </a:spcAft>
+            </a:pPr>
+            <a:r>
+              <a:rPr sz="1400" b="0">
+                <a:solidFill>
+                  <a:srgbClr val="5A6375"/>
+                </a:solidFill>
+                <a:latin typeface="Arial"/>
+              </a:rPr>
+              <a:t>   Đây là điểm bổ sung so với AdaIN gốc: ép decoder trung thực,</a:t>
+            </a:r>
+          </a:p>
+          <a:p>
+            <a:pPr algn="l">
+              <a:lnSpc>
+                <a:spcPct val="115000"/>
+              </a:lnSpc>
+              <a:spcAft>
+                <a:spcPts val="600"/>
+              </a:spcAft>
+            </a:pPr>
+            <a:r>
+              <a:rPr sz="1400" b="0">
+                <a:solidFill>
+                  <a:srgbClr val="5A6375"/>
+                </a:solidFill>
+                <a:latin typeface="Arial"/>
+              </a:rPr>
+              <a:t>   giảm méo cấu trúc — điều kiện sống còn để nhãn còn dùng được.</a:t>
+            </a:r>
+          </a:p>
+        </p:txBody>
+      </p:sp>
       <p:pic>
         <p:nvPicPr>
-          <p:cNvPr id="6" name="Picture 5" descr="fig_weather_types.jpg"/>
+          <p:cNvPr id="34" name="Picture 33" descr="fig_loss.png"/>
           <p:cNvPicPr>
             <a:picLocks noChangeAspect="1"/>
           </p:cNvPicPr>
@@ -13914,8 +14228,8 @@
         </p:blipFill>
         <p:spPr>
           <a:xfrm>
-            <a:off x="457200" y="2208193"/>
-            <a:ext cx="11247120" cy="3173133"/>
+            <a:off x="2123667" y="4434840"/>
+            <a:ext cx="7914185" cy="2011680"/>
           </a:xfrm>
           <a:prstGeom prst="rect">
             <a:avLst/>
@@ -14065,7 +14379,7 @@
                 </a:solidFill>
                 <a:latin typeface="Arial"/>
               </a:rPr>
-              <a:t>Kết quả — ví dụ đầu vào/đầu ra</a:t>
+              <a:t>Kết quả — 5 loại thời tiết</a:t>
             </a:r>
           </a:p>
           <a:p>
@@ -14084,7 +14398,7 @@
                 </a:solidFill>
                 <a:latin typeface="Arial"/>
               </a:rPr>
-              <a:t>Trái: 2 đầu vào · Phải: ảnh sinh ra</a:t>
+              <a:t>Cùng một ảnh gốc, đổi ảnh tham chiếu là đổi thời tiết</a:t>
             </a:r>
           </a:p>
         </p:txBody>
@@ -14133,7 +14447,7 @@
       </p:sp>
       <p:pic>
         <p:nvPicPr>
-          <p:cNvPr id="6" name="Picture 5" descr="fig_examples.jpg"/>
+          <p:cNvPr id="6" name="Picture 5" descr="fig_weather_types.jpg"/>
           <p:cNvPicPr>
             <a:picLocks noChangeAspect="1"/>
           </p:cNvPicPr>
@@ -14147,8 +14461,8 @@
         </p:blipFill>
         <p:spPr>
           <a:xfrm>
-            <a:off x="2407987" y="1234440"/>
-            <a:ext cx="7345546" cy="5120639"/>
+            <a:off x="457200" y="2208193"/>
+            <a:ext cx="11247120" cy="3173133"/>
           </a:xfrm>
           <a:prstGeom prst="rect">
             <a:avLst/>
@@ -14298,7 +14612,7 @@
                 </a:solidFill>
                 <a:latin typeface="Arial"/>
               </a:rPr>
-              <a:t>Điều khiển cường độ bằng alpha</a:t>
+              <a:t>Kết quả — ví dụ đầu vào/đầu ra</a:t>
             </a:r>
           </a:p>
           <a:p>
@@ -14317,7 +14631,7 @@
                 </a:solidFill>
                 <a:latin typeface="Arial"/>
               </a:rPr>
-              <a:t>Một cặp ảnh sinh ra nhiều mức nặng/nhẹ → tăng độ đa dạng dữ liệu</a:t>
+              <a:t>Trái: 2 đầu vào · Phải: ảnh sinh ra</a:t>
             </a:r>
           </a:p>
         </p:txBody>
@@ -14366,7 +14680,7 @@
       </p:sp>
       <p:pic>
         <p:nvPicPr>
-          <p:cNvPr id="6" name="Picture 5" descr="fig_alpha.jpg"/>
+          <p:cNvPr id="6" name="Picture 5" descr="fig_examples.jpg"/>
           <p:cNvPicPr>
             <a:picLocks noChangeAspect="1"/>
           </p:cNvPicPr>
@@ -14380,8 +14694,8 @@
         </p:blipFill>
         <p:spPr>
           <a:xfrm>
-            <a:off x="457200" y="2497500"/>
-            <a:ext cx="11247120" cy="2594520"/>
+            <a:off x="2407987" y="1234440"/>
+            <a:ext cx="7345546" cy="5120639"/>
           </a:xfrm>
           <a:prstGeom prst="rect">
             <a:avLst/>

</xml_diff>

<commit_message>
Bổ sung phần giải thích Decoder vào slide và báo cáo
Decoder là phần DUY NHẤT được huấn luyện nhưng trước đây chỉ được nhắc tên,
chưa chỗ nào giải thích nó là gì và vì sao cần.

- Slide 5 viết lại thành "① Khối học sâu: AdaIN + Decoder", chia hai cột:
  AdaIN (0 tham số học) và Decoder (3,51 M tham số) kèm sơ đồ kiến trúc
  512 kênh @32×32 → 9 lớp Conv 3×3 + 3 lần Upsample → 3 kênh @256×256,
  và lý do dùng ReflectionPad / Upsample nearest.
- Slide 4: khối ① đổi tên thành "AdaIN + Decoder", sửa tràn chữ ngoài khung.
- Báo cáo mục 5.1: thêm phần Decoder đầy đủ — vì sao cần, kiến trúc,
  hai lựa chọn thiết kế, và vì sao thêm thời tiết mới không cần train lại.

Co-Authored-By: Claude Opus 5 (1M context) <noreply@anthropic.com>
</commit_message>
<xml_diff>
--- a/slides/BaoCao_TangCuongDuLieuThoiTiet.pptx
+++ b/slides/BaoCao_TangCuongDuLieuThoiTiet.pptx
@@ -11978,8 +11978,8 @@
         </p:nvSpPr>
         <p:spPr>
           <a:xfrm>
-            <a:off x="548640" y="1371600"/>
-            <a:ext cx="3337560" cy="3017520"/>
+            <a:off x="548640" y="1325880"/>
+            <a:ext cx="3337560" cy="3291840"/>
           </a:xfrm>
           <a:prstGeom prst="rect">
             <a:avLst/>
@@ -12022,7 +12022,7 @@
         </p:nvSpPr>
         <p:spPr>
           <a:xfrm>
-            <a:off x="548640" y="1371600"/>
+            <a:off x="548640" y="1325880"/>
             <a:ext cx="3337560" cy="82296"/>
           </a:xfrm>
           <a:prstGeom prst="rect">
@@ -12066,8 +12066,8 @@
         </p:nvSpPr>
         <p:spPr>
           <a:xfrm>
-            <a:off x="777240" y="1600200"/>
-            <a:ext cx="2926080" cy="2743200"/>
+            <a:off x="777240" y="1536192"/>
+            <a:ext cx="2926080" cy="3108960"/>
           </a:xfrm>
           <a:prstGeom prst="rect">
             <a:avLst/>
@@ -12095,27 +12095,28 @@
                 </a:solidFill>
                 <a:latin typeface="Arial"/>
               </a:rPr>
-              <a:t>① AdaIN  (học sâu)</a:t>
-            </a:r>
-          </a:p>
-          <a:p>
-            <a:pPr algn="l">
-              <a:lnSpc>
-                <a:spcPct val="115000"/>
-              </a:lnSpc>
-              <a:spcAft>
-                <a:spcPts val="600"/>
-              </a:spcAft>
-            </a:pPr>
-            <a:r>
-              <a:rPr sz="1300" b="0">
+              <a:t>① AdaIN + Decoder</a:t>
+            </a:r>
+          </a:p>
+          <a:p>
+            <a:pPr algn="l">
+              <a:lnSpc>
+                <a:spcPct val="115000"/>
+              </a:lnSpc>
+              <a:spcAft>
+                <a:spcPts val="600"/>
+              </a:spcAft>
+            </a:pPr>
+            <a:r>
+              <a:rPr sz="1200" b="0">
                 <a:solidFill>
                   <a:srgbClr val="5A6375"/>
                 </a:solidFill>
                 <a:latin typeface="Arial"/>
               </a:rPr>
-              <a:t>Chuẩn hoá đặc trưng VGG của ảnh gốc rồi nhuộm lại bằng mean/std của ảnh thời tiết.
-→ Đổi tông màu, độ sáng, độ mù toàn cục.</a:t>
+              <a:t>AdaIN nhuộm đặc trưng VGG của ảnh gốc bằng mean/std của ảnh thời tiết.
+Decoder dựng đặc trưng đã nhuộm trở lại thành ảnh RGB — phần DUY NHẤT được huấn luyện.
+→ Đổi tông màu, độ sáng, độ mù.</a:t>
             </a:r>
           </a:p>
         </p:txBody>
@@ -12128,8 +12129,8 @@
         </p:nvSpPr>
         <p:spPr>
           <a:xfrm>
-            <a:off x="4434840" y="1371600"/>
-            <a:ext cx="3337560" cy="3017520"/>
+            <a:off x="4434840" y="1325880"/>
+            <a:ext cx="3337560" cy="3291840"/>
           </a:xfrm>
           <a:prstGeom prst="rect">
             <a:avLst/>
@@ -12172,7 +12173,7 @@
         </p:nvSpPr>
         <p:spPr>
           <a:xfrm>
-            <a:off x="4434840" y="1371600"/>
+            <a:off x="4434840" y="1325880"/>
             <a:ext cx="3337560" cy="82296"/>
           </a:xfrm>
           <a:prstGeom prst="rect">
@@ -12216,8 +12217,8 @@
         </p:nvSpPr>
         <p:spPr>
           <a:xfrm>
-            <a:off x="4663440" y="1600200"/>
-            <a:ext cx="2926080" cy="2743200"/>
+            <a:off x="4663440" y="1536192"/>
+            <a:ext cx="2926080" cy="3108960"/>
           </a:xfrm>
           <a:prstGeom prst="rect">
             <a:avLst/>
@@ -12258,7 +12259,7 @@
               </a:spcAft>
             </a:pPr>
             <a:r>
-              <a:rPr sz="1300" b="0">
+              <a:rPr sz="1200" b="0">
                 <a:solidFill>
                   <a:srgbClr val="5A6375"/>
                 </a:solidFill>
@@ -12266,7 +12267,7 @@
               </a:rPr>
               <a:t>Dùng ảnh gốc làm ảnh dẫn hướng, lọc tuyến tính cục bộ q = a·I + b.
 Bán kính lớn (32) → a, b mượt → đầu ra = ẢNH GỐC nhân trường tương phản + lệch màu.
-→ Giữ 100% chi tiết ảnh chụp, chỉ đổi tông thời tiết.</a:t>
+→ Giữ 100% chi tiết ảnh chụp.</a:t>
             </a:r>
           </a:p>
         </p:txBody>
@@ -12279,8 +12280,8 @@
         </p:nvSpPr>
         <p:spPr>
           <a:xfrm>
-            <a:off x="8321040" y="1371600"/>
-            <a:ext cx="3337560" cy="3017520"/>
+            <a:off x="8321040" y="1325880"/>
+            <a:ext cx="3337560" cy="3291840"/>
           </a:xfrm>
           <a:prstGeom prst="rect">
             <a:avLst/>
@@ -12323,7 +12324,7 @@
         </p:nvSpPr>
         <p:spPr>
           <a:xfrm>
-            <a:off x="8321040" y="1371600"/>
+            <a:off x="8321040" y="1325880"/>
             <a:ext cx="3337560" cy="82296"/>
           </a:xfrm>
           <a:prstGeom prst="rect">
@@ -12367,8 +12368,8 @@
         </p:nvSpPr>
         <p:spPr>
           <a:xfrm>
-            <a:off x="8549640" y="1600200"/>
-            <a:ext cx="2926080" cy="2743200"/>
+            <a:off x="8549640" y="1536192"/>
+            <a:ext cx="2926080" cy="3108960"/>
           </a:xfrm>
           <a:prstGeom prst="rect">
             <a:avLst/>
@@ -12409,7 +12410,7 @@
               </a:spcAft>
             </a:pPr>
             <a:r>
-              <a:rPr sz="1300" b="0">
+              <a:rPr sz="1200" b="0">
                 <a:solidFill>
                   <a:srgbClr val="5A6375"/>
                 </a:solidFill>
@@ -12429,7 +12430,7 @@
         </p:nvSpPr>
         <p:spPr>
           <a:xfrm>
-            <a:off x="548640" y="4617720"/>
+            <a:off x="548640" y="4892040"/>
             <a:ext cx="11064240" cy="1463040"/>
           </a:xfrm>
           <a:prstGeom prst="rect">
@@ -12625,7 +12626,7 @@
                 </a:solidFill>
                 <a:latin typeface="Arial"/>
               </a:rPr>
-              <a:t>① AdaIN — trái tim của phương pháp</a:t>
+              <a:t>① Khối học sâu: AdaIN + Decoder</a:t>
             </a:r>
           </a:p>
           <a:p>
@@ -12644,7 +12645,7 @@
                 </a:solidFill>
                 <a:latin typeface="Arial"/>
               </a:rPr>
-              <a:t>Huang &amp; Belongie, ICCV 2017</a:t>
+              <a:t>AdaIN trộn thống kê (0 tham số) · Decoder dựng lại ảnh (phần DUY NHẤT được học)</a:t>
             </a:r>
           </a:p>
         </p:txBody>
@@ -12699,8 +12700,8 @@
         </p:nvSpPr>
         <p:spPr>
           <a:xfrm>
-            <a:off x="640080" y="1371600"/>
-            <a:ext cx="10881360" cy="1234440"/>
+            <a:off x="640080" y="1170432"/>
+            <a:ext cx="10881360" cy="914400"/>
           </a:xfrm>
           <a:prstGeom prst="rect">
             <a:avLst/>
@@ -12743,8 +12744,8 @@
         </p:nvSpPr>
         <p:spPr>
           <a:xfrm>
-            <a:off x="640080" y="1627632"/>
-            <a:ext cx="10881360" cy="914400"/>
+            <a:off x="640080" y="1316736"/>
+            <a:ext cx="10881360" cy="731520"/>
           </a:xfrm>
           <a:prstGeom prst="rect">
             <a:avLst/>
@@ -12766,7 +12767,7 @@
               </a:spcAft>
             </a:pPr>
             <a:r>
-              <a:rPr sz="3000" b="1">
+              <a:rPr sz="2600" b="1">
                 <a:solidFill>
                   <a:srgbClr val="18A099"/>
                 </a:solidFill>
@@ -12785,14 +12786,14 @@
         </p:nvSpPr>
         <p:spPr>
           <a:xfrm>
-            <a:off x="640080" y="3026664"/>
-            <a:ext cx="100584" cy="100584"/>
+            <a:off x="640080" y="2286000"/>
+            <a:ext cx="5486400" cy="3246120"/>
           </a:xfrm>
           <a:prstGeom prst="rect">
             <a:avLst/>
           </a:prstGeom>
           <a:solidFill>
-            <a:srgbClr val="18A099"/>
+            <a:srgbClr val="F4F6FA"/>
           </a:solidFill>
           <a:ln>
             <a:noFill/>
@@ -12823,62 +12824,20 @@
       </p:sp>
       <p:sp>
         <p:nvSpPr>
-          <p:cNvPr id="9" name="TextBox 8"/>
-          <p:cNvSpPr txBox="1"/>
-          <p:nvPr/>
-        </p:nvSpPr>
-        <p:spPr>
-          <a:xfrm>
-            <a:off x="914400" y="2926080"/>
-            <a:ext cx="10607040" cy="548640"/>
-          </a:xfrm>
-          <a:prstGeom prst="rect">
-            <a:avLst/>
-          </a:prstGeom>
-          <a:noFill/>
-        </p:spPr>
-        <p:txBody>
-          <a:bodyPr wrap="square" lIns="0" rIns="0">
-            <a:spAutoFit/>
-          </a:bodyPr>
-          <a:lstStyle/>
-          <a:p>
-            <a:pPr algn="l">
-              <a:lnSpc>
-                <a:spcPct val="115000"/>
-              </a:lnSpc>
-              <a:spcAft>
-                <a:spcPts val="600"/>
-              </a:spcAft>
-            </a:pPr>
-            <a:r>
-              <a:rPr sz="1600" b="1">
-                <a:solidFill>
-                  <a:srgbClr val="101B33"/>
-                </a:solidFill>
-                <a:latin typeface="Arial"/>
-              </a:rPr>
-              <a:t>c = đặc trưng VGG của ảnh giao thông,  s = đặc trưng VGG của ảnh thời tiết.</a:t>
-            </a:r>
-          </a:p>
-        </p:txBody>
-      </p:sp>
-      <p:sp>
-        <p:nvSpPr>
-          <p:cNvPr id="10" name="Rectangle 9"/>
+          <p:cNvPr id="9" name="Rectangle 8"/>
           <p:cNvSpPr/>
           <p:nvPr/>
         </p:nvSpPr>
         <p:spPr>
           <a:xfrm>
-            <a:off x="640080" y="3575304"/>
-            <a:ext cx="100584" cy="100584"/>
+            <a:off x="640080" y="2286000"/>
+            <a:ext cx="5486400" cy="73152"/>
           </a:xfrm>
           <a:prstGeom prst="rect">
             <a:avLst/>
           </a:prstGeom>
           <a:solidFill>
-            <a:srgbClr val="18A099"/>
+            <a:srgbClr val="2E6FD9"/>
           </a:solidFill>
           <a:ln>
             <a:noFill/>
@@ -12909,14 +12868,14 @@
       </p:sp>
       <p:sp>
         <p:nvSpPr>
-          <p:cNvPr id="11" name="TextBox 10"/>
+          <p:cNvPr id="10" name="TextBox 9"/>
           <p:cNvSpPr txBox="1"/>
           <p:nvPr/>
         </p:nvSpPr>
         <p:spPr>
           <a:xfrm>
-            <a:off x="914400" y="3474720"/>
-            <a:ext cx="10607040" cy="548640"/>
+            <a:off x="868680" y="2432304"/>
+            <a:ext cx="5120640" cy="3017520"/>
           </a:xfrm>
           <a:prstGeom prst="rect">
             <a:avLst/>
@@ -12931,40 +12890,211 @@
           <a:p>
             <a:pPr algn="l">
               <a:lnSpc>
-                <a:spcPct val="115000"/>
-              </a:lnSpc>
-              <a:spcAft>
-                <a:spcPts val="600"/>
-              </a:spcAft>
-            </a:pPr>
-            <a:r>
-              <a:rPr sz="1600" b="0">
+                <a:spcPct val="98000"/>
+              </a:lnSpc>
+              <a:spcAft>
+                <a:spcPts val="600"/>
+              </a:spcAft>
+            </a:pPr>
+            <a:r>
+              <a:rPr sz="1600" b="1">
                 <a:solidFill>
                   <a:srgbClr val="101B33"/>
                 </a:solidFill>
                 <a:latin typeface="Arial"/>
               </a:rPr>
-              <a:t>Bước 1 — ( c − μ(c) ) / σ(c): xoá phong cách gốc (trời quang), giữ lại cấu trúc không gian.</a:t>
-            </a:r>
-          </a:p>
-        </p:txBody>
-      </p:sp>
-      <p:sp>
-        <p:nvSpPr>
-          <p:cNvPr id="12" name="Rectangle 11"/>
+              <a:t>AdaIN — 0 THAM SỐ HỌC</a:t>
+            </a:r>
+          </a:p>
+          <a:p>
+            <a:pPr algn="l">
+              <a:lnSpc>
+                <a:spcPct val="98000"/>
+              </a:lnSpc>
+              <a:spcAft>
+                <a:spcPts val="600"/>
+              </a:spcAft>
+            </a:pPr>
+            <a:r>
+              <a:rPr sz="1200" b="0">
+                <a:solidFill>
+                  <a:srgbClr val="5A6375"/>
+                </a:solidFill>
+                <a:latin typeface="Arial"/>
+              </a:rPr>
+              <a:t>c = đặc trưng VGG ảnh giao thông</a:t>
+            </a:r>
+          </a:p>
+          <a:p>
+            <a:pPr algn="l">
+              <a:lnSpc>
+                <a:spcPct val="98000"/>
+              </a:lnSpc>
+              <a:spcAft>
+                <a:spcPts val="600"/>
+              </a:spcAft>
+            </a:pPr>
+            <a:r>
+              <a:rPr sz="1200" b="0">
+                <a:solidFill>
+                  <a:srgbClr val="5A6375"/>
+                </a:solidFill>
+                <a:latin typeface="Arial"/>
+              </a:rPr>
+              <a:t>s = đặc trưng VGG ảnh thời tiết</a:t>
+            </a:r>
+          </a:p>
+          <a:p>
+            <a:pPr algn="l">
+              <a:lnSpc>
+                <a:spcPct val="98000"/>
+              </a:lnSpc>
+              <a:spcAft>
+                <a:spcPts val="600"/>
+              </a:spcAft>
+            </a:pPr>
+            <a:r>
+              <a:rPr sz="1300" b="1">
+                <a:solidFill>
+                  <a:srgbClr val="2E6FD9"/>
+                </a:solidFill>
+                <a:latin typeface="Arial"/>
+              </a:rPr>
+              <a:t>Bước 1 — ( c − μ(c) ) / σ(c)</a:t>
+            </a:r>
+          </a:p>
+          <a:p>
+            <a:pPr algn="l">
+              <a:lnSpc>
+                <a:spcPct val="98000"/>
+              </a:lnSpc>
+              <a:spcAft>
+                <a:spcPts val="600"/>
+              </a:spcAft>
+            </a:pPr>
+            <a:r>
+              <a:rPr sz="1200" b="0">
+                <a:solidFill>
+                  <a:srgbClr val="5A6375"/>
+                </a:solidFill>
+                <a:latin typeface="Arial"/>
+              </a:rPr>
+              <a:t>     xoá phong cách gốc (tông trời quang),</a:t>
+            </a:r>
+          </a:p>
+          <a:p>
+            <a:pPr algn="l">
+              <a:lnSpc>
+                <a:spcPct val="98000"/>
+              </a:lnSpc>
+              <a:spcAft>
+                <a:spcPts val="600"/>
+              </a:spcAft>
+            </a:pPr>
+            <a:r>
+              <a:rPr sz="1200" b="0">
+                <a:solidFill>
+                  <a:srgbClr val="5A6375"/>
+                </a:solidFill>
+                <a:latin typeface="Arial"/>
+              </a:rPr>
+              <a:t>     GIỮ NGUYÊN cấu trúc không gian</a:t>
+            </a:r>
+          </a:p>
+          <a:p>
+            <a:pPr algn="l">
+              <a:lnSpc>
+                <a:spcPct val="98000"/>
+              </a:lnSpc>
+              <a:spcAft>
+                <a:spcPts val="600"/>
+              </a:spcAft>
+            </a:pPr>
+            <a:r>
+              <a:rPr sz="1300" b="1">
+                <a:solidFill>
+                  <a:srgbClr val="2E6FD9"/>
+                </a:solidFill>
+                <a:latin typeface="Arial"/>
+              </a:rPr>
+              <a:t>Bước 2 — nhân σ(s), cộng μ(s)</a:t>
+            </a:r>
+          </a:p>
+          <a:p>
+            <a:pPr algn="l">
+              <a:lnSpc>
+                <a:spcPct val="98000"/>
+              </a:lnSpc>
+              <a:spcAft>
+                <a:spcPts val="600"/>
+              </a:spcAft>
+            </a:pPr>
+            <a:r>
+              <a:rPr sz="1200" b="0">
+                <a:solidFill>
+                  <a:srgbClr val="5A6375"/>
+                </a:solidFill>
+                <a:latin typeface="Arial"/>
+              </a:rPr>
+              <a:t>     'nhuộm' bằng thống kê ảnh thời tiết</a:t>
+            </a:r>
+          </a:p>
+          <a:p>
+            <a:pPr algn="l">
+              <a:lnSpc>
+                <a:spcPct val="98000"/>
+              </a:lnSpc>
+              <a:spcAft>
+                <a:spcPts val="600"/>
+              </a:spcAft>
+            </a:pPr>
+            <a:r>
+              <a:rPr sz="1200" b="1">
+                <a:solidFill>
+                  <a:srgbClr val="101B33"/>
+                </a:solidFill>
+                <a:latin typeface="Arial"/>
+              </a:rPr>
+              <a:t>Chỉ đổi thống kê THEO KÊNH ⇒ bản đồ đặc trưng</a:t>
+            </a:r>
+          </a:p>
+          <a:p>
+            <a:pPr algn="l">
+              <a:lnSpc>
+                <a:spcPct val="98000"/>
+              </a:lnSpc>
+              <a:spcAft>
+                <a:spcPts val="600"/>
+              </a:spcAft>
+            </a:pPr>
+            <a:r>
+              <a:rPr sz="1200" b="1">
+                <a:solidFill>
+                  <a:srgbClr val="101B33"/>
+                </a:solidFill>
+                <a:latin typeface="Arial"/>
+              </a:rPr>
+              <a:t>không bị dịch chuyển ⇒ giữ nguyên bố cục.</a:t>
+            </a:r>
+          </a:p>
+        </p:txBody>
+      </p:sp>
+      <p:sp>
+        <p:nvSpPr>
+          <p:cNvPr id="11" name="Rectangle 10"/>
           <p:cNvSpPr/>
           <p:nvPr/>
         </p:nvSpPr>
         <p:spPr>
           <a:xfrm>
-            <a:off x="640080" y="4123944"/>
-            <a:ext cx="100584" cy="100584"/>
+            <a:off x="6400800" y="2286000"/>
+            <a:ext cx="5120640" cy="3246120"/>
           </a:xfrm>
           <a:prstGeom prst="rect">
             <a:avLst/>
           </a:prstGeom>
           <a:solidFill>
-            <a:srgbClr val="18A099"/>
+            <a:srgbClr val="F4F6FA"/>
           </a:solidFill>
           <a:ln>
             <a:noFill/>
@@ -12995,62 +13125,20 @@
       </p:sp>
       <p:sp>
         <p:nvSpPr>
-          <p:cNvPr id="13" name="TextBox 12"/>
-          <p:cNvSpPr txBox="1"/>
-          <p:nvPr/>
-        </p:nvSpPr>
-        <p:spPr>
-          <a:xfrm>
-            <a:off x="914400" y="4023360"/>
-            <a:ext cx="10607040" cy="548640"/>
-          </a:xfrm>
-          <a:prstGeom prst="rect">
-            <a:avLst/>
-          </a:prstGeom>
-          <a:noFill/>
-        </p:spPr>
-        <p:txBody>
-          <a:bodyPr wrap="square" lIns="0" rIns="0">
-            <a:spAutoFit/>
-          </a:bodyPr>
-          <a:lstStyle/>
-          <a:p>
-            <a:pPr algn="l">
-              <a:lnSpc>
-                <a:spcPct val="115000"/>
-              </a:lnSpc>
-              <a:spcAft>
-                <a:spcPts val="600"/>
-              </a:spcAft>
-            </a:pPr>
-            <a:r>
-              <a:rPr sz="1600" b="0">
-                <a:solidFill>
-                  <a:srgbClr val="101B33"/>
-                </a:solidFill>
-                <a:latin typeface="Arial"/>
-              </a:rPr>
-              <a:t>Bước 2 — nhân σ(s), cộng μ(s): 'nhuộm' bằng thống kê của ảnh thời tiết.</a:t>
-            </a:r>
-          </a:p>
-        </p:txBody>
-      </p:sp>
-      <p:sp>
-        <p:nvSpPr>
-          <p:cNvPr id="14" name="Rectangle 13"/>
+          <p:cNvPr id="12" name="Rectangle 11"/>
           <p:cNvSpPr/>
           <p:nvPr/>
         </p:nvSpPr>
         <p:spPr>
           <a:xfrm>
-            <a:off x="640080" y="4672584"/>
-            <a:ext cx="100584" cy="100584"/>
+            <a:off x="6400800" y="2286000"/>
+            <a:ext cx="5120640" cy="73152"/>
           </a:xfrm>
           <a:prstGeom prst="rect">
             <a:avLst/>
           </a:prstGeom>
           <a:solidFill>
-            <a:srgbClr val="18A099"/>
+            <a:srgbClr val="E48A2E"/>
           </a:solidFill>
           <a:ln>
             <a:noFill/>
@@ -13081,14 +13169,14 @@
       </p:sp>
       <p:sp>
         <p:nvSpPr>
-          <p:cNvPr id="15" name="TextBox 14"/>
+          <p:cNvPr id="13" name="TextBox 12"/>
           <p:cNvSpPr txBox="1"/>
           <p:nvPr/>
         </p:nvSpPr>
         <p:spPr>
           <a:xfrm>
-            <a:off x="914400" y="4572000"/>
-            <a:ext cx="10607040" cy="548640"/>
+            <a:off x="6629400" y="2432304"/>
+            <a:ext cx="4754880" cy="3017520"/>
           </a:xfrm>
           <a:prstGeom prst="rect">
             <a:avLst/>
@@ -13103,78 +13191,224 @@
           <a:p>
             <a:pPr algn="l">
               <a:lnSpc>
-                <a:spcPct val="115000"/>
-              </a:lnSpc>
-              <a:spcAft>
-                <a:spcPts val="600"/>
-              </a:spcAft>
-            </a:pPr>
-            <a:r>
-              <a:rPr sz="1600" b="1">
+                <a:spcPct val="96000"/>
+              </a:lnSpc>
+              <a:spcAft>
+                <a:spcPts val="600"/>
+              </a:spcAft>
+            </a:pPr>
+            <a:r>
+              <a:rPr sz="1400" b="1">
                 <a:solidFill>
                   <a:srgbClr val="101B33"/>
                 </a:solidFill>
                 <a:latin typeface="Arial"/>
               </a:rPr>
-              <a:t>Chỉ đổi thống kê THEO KÊNH ⇒ bản đồ đặc trưng không bị dịch chuyển ⇒ giữ bố cục.</a:t>
-            </a:r>
-          </a:p>
-        </p:txBody>
-      </p:sp>
-      <p:sp>
-        <p:nvSpPr>
-          <p:cNvPr id="16" name="Rectangle 15"/>
-          <p:cNvSpPr/>
-          <p:nvPr/>
-        </p:nvSpPr>
-        <p:spPr>
-          <a:xfrm>
-            <a:off x="640080" y="5221224"/>
-            <a:ext cx="100584" cy="100584"/>
-          </a:xfrm>
-          <a:prstGeom prst="rect">
-            <a:avLst/>
-          </a:prstGeom>
-          <a:solidFill>
-            <a:srgbClr val="18A099"/>
-          </a:solidFill>
-          <a:ln>
-            <a:noFill/>
-          </a:ln>
-          <a:effectLst/>
-        </p:spPr>
-        <p:style>
-          <a:lnRef idx="1">
-            <a:schemeClr val="accent1"/>
-          </a:lnRef>
-          <a:fillRef idx="3">
-            <a:schemeClr val="accent1"/>
-          </a:fillRef>
-          <a:effectRef idx="2">
-            <a:schemeClr val="accent1"/>
-          </a:effectRef>
-          <a:fontRef idx="minor">
-            <a:schemeClr val="lt1"/>
-          </a:fontRef>
-        </p:style>
-        <p:txBody>
-          <a:bodyPr rtlCol="0" anchor="ctr"/>
-          <a:lstStyle/>
-          <a:p>
-            <a:pPr algn="ctr"/>
-          </a:p>
-        </p:txBody>
-      </p:sp>
-      <p:sp>
-        <p:nvSpPr>
-          <p:cNvPr id="17" name="TextBox 16"/>
+              <a:t>DECODER — 3,51 M THAM SỐ, PHẦN DUY NHẤT ĐƯỢC HỌC</a:t>
+            </a:r>
+          </a:p>
+          <a:p>
+            <a:pPr algn="l">
+              <a:lnSpc>
+                <a:spcPct val="96000"/>
+              </a:lnSpc>
+              <a:spcAft>
+                <a:spcPts val="600"/>
+              </a:spcAft>
+            </a:pPr>
+            <a:r>
+              <a:rPr sz="1200" b="0">
+                <a:solidFill>
+                  <a:srgbClr val="5A6375"/>
+                </a:solidFill>
+                <a:latin typeface="Arial"/>
+              </a:rPr>
+              <a:t>Vì sao cần? VGG chỉ NÉN ảnh thành đặc trưng, không</a:t>
+            </a:r>
+          </a:p>
+          <a:p>
+            <a:pPr algn="l">
+              <a:lnSpc>
+                <a:spcPct val="96000"/>
+              </a:lnSpc>
+              <a:spcAft>
+                <a:spcPts val="600"/>
+              </a:spcAft>
+            </a:pPr>
+            <a:r>
+              <a:rPr sz="1200" b="0">
+                <a:solidFill>
+                  <a:srgbClr val="5A6375"/>
+                </a:solidFill>
+                <a:latin typeface="Arial"/>
+              </a:rPr>
+              <a:t>có mạng nào giải nén ngược lại ⇒ phải tự huấn luyện.</a:t>
+            </a:r>
+          </a:p>
+          <a:p>
+            <a:pPr algn="l">
+              <a:lnSpc>
+                <a:spcPct val="96000"/>
+              </a:lnSpc>
+              <a:spcAft>
+                <a:spcPts val="600"/>
+              </a:spcAft>
+            </a:pPr>
+            <a:r>
+              <a:rPr sz="1300" b="1">
+                <a:solidFill>
+                  <a:srgbClr val="E48A2E"/>
+                </a:solidFill>
+                <a:latin typeface="Arial"/>
+              </a:rPr>
+              <a:t>Kiến trúc — phản chiếu ngược VGG-19</a:t>
+            </a:r>
+          </a:p>
+          <a:p>
+            <a:pPr algn="l">
+              <a:lnSpc>
+                <a:spcPct val="96000"/>
+              </a:lnSpc>
+              <a:spcAft>
+                <a:spcPts val="600"/>
+              </a:spcAft>
+            </a:pPr>
+            <a:r>
+              <a:rPr sz="1200" b="0">
+                <a:solidFill>
+                  <a:srgbClr val="5A6375"/>
+                </a:solidFill>
+                <a:latin typeface="Arial"/>
+              </a:rPr>
+              <a:t>     512 kênh @ 32×32   (1/8 độ phân giải)</a:t>
+            </a:r>
+          </a:p>
+          <a:p>
+            <a:pPr algn="l">
+              <a:lnSpc>
+                <a:spcPct val="96000"/>
+              </a:lnSpc>
+              <a:spcAft>
+                <a:spcPts val="600"/>
+              </a:spcAft>
+            </a:pPr>
+            <a:r>
+              <a:rPr sz="1200" b="0">
+                <a:solidFill>
+                  <a:srgbClr val="5A6375"/>
+                </a:solidFill>
+                <a:latin typeface="Arial"/>
+              </a:rPr>
+              <a:t>        ↓  9 lớp Conv 3×3 + ReLU</a:t>
+            </a:r>
+          </a:p>
+          <a:p>
+            <a:pPr algn="l">
+              <a:lnSpc>
+                <a:spcPct val="96000"/>
+              </a:lnSpc>
+              <a:spcAft>
+                <a:spcPts val="600"/>
+              </a:spcAft>
+            </a:pPr>
+            <a:r>
+              <a:rPr sz="1200" b="0">
+                <a:solidFill>
+                  <a:srgbClr val="5A6375"/>
+                </a:solidFill>
+                <a:latin typeface="Arial"/>
+              </a:rPr>
+              <a:t>        ↓  3 lần Upsample ×2</a:t>
+            </a:r>
+          </a:p>
+          <a:p>
+            <a:pPr algn="l">
+              <a:lnSpc>
+                <a:spcPct val="96000"/>
+              </a:lnSpc>
+              <a:spcAft>
+                <a:spcPts val="600"/>
+              </a:spcAft>
+            </a:pPr>
+            <a:r>
+              <a:rPr sz="1200" b="0">
+                <a:solidFill>
+                  <a:srgbClr val="5A6375"/>
+                </a:solidFill>
+                <a:latin typeface="Arial"/>
+              </a:rPr>
+              <a:t>     3 kênh @ 256×256   (ảnh RGB)</a:t>
+            </a:r>
+          </a:p>
+          <a:p>
+            <a:pPr algn="l">
+              <a:lnSpc>
+                <a:spcPct val="96000"/>
+              </a:lnSpc>
+              <a:spcAft>
+                <a:spcPts val="600"/>
+              </a:spcAft>
+            </a:pPr>
+            <a:r>
+              <a:rPr sz="1200" b="0">
+                <a:solidFill>
+                  <a:srgbClr val="5A6375"/>
+                </a:solidFill>
+                <a:latin typeface="Arial"/>
+              </a:rPr>
+              <a:t>· ReflectionPad thay zero-pad → không có viền đen</a:t>
+            </a:r>
+          </a:p>
+          <a:p>
+            <a:pPr algn="l">
+              <a:lnSpc>
+                <a:spcPct val="96000"/>
+              </a:lnSpc>
+              <a:spcAft>
+                <a:spcPts val="600"/>
+              </a:spcAft>
+            </a:pPr>
+            <a:r>
+              <a:rPr sz="1200" b="0">
+                <a:solidFill>
+                  <a:srgbClr val="5A6375"/>
+                </a:solidFill>
+                <a:latin typeface="Arial"/>
+              </a:rPr>
+              <a:t>· Upsample nearest thay ConvTranspose → không bị</a:t>
+            </a:r>
+          </a:p>
+          <a:p>
+            <a:pPr algn="l">
+              <a:lnSpc>
+                <a:spcPct val="96000"/>
+              </a:lnSpc>
+              <a:spcAft>
+                <a:spcPts val="600"/>
+              </a:spcAft>
+            </a:pPr>
+            <a:r>
+              <a:rPr sz="1200" b="0">
+                <a:solidFill>
+                  <a:srgbClr val="5A6375"/>
+                </a:solidFill>
+                <a:latin typeface="Arial"/>
+              </a:rPr>
+              <a:t>   vệt caro (checkerboard artifact)</a:t>
+            </a:r>
+          </a:p>
+        </p:txBody>
+      </p:sp>
+      <p:sp>
+        <p:nvSpPr>
+          <p:cNvPr id="14" name="TextBox 13"/>
           <p:cNvSpPr txBox="1"/>
           <p:nvPr/>
         </p:nvSpPr>
         <p:spPr>
           <a:xfrm>
-            <a:off x="914400" y="5120640"/>
-            <a:ext cx="10607040" cy="548640"/>
+            <a:off x="640080" y="5715000"/>
+            <a:ext cx="10881360" cy="822960"/>
           </a:xfrm>
           <a:prstGeom prst="rect">
             <a:avLst/>
@@ -13196,99 +13430,32 @@
               </a:spcAft>
             </a:pPr>
             <a:r>
-              <a:rPr sz="1600" b="0">
+              <a:rPr sz="1400" b="1">
                 <a:solidFill>
                   <a:srgbClr val="101B33"/>
                 </a:solidFill>
                 <a:latin typeface="Arial"/>
               </a:rPr>
-              <a:t>Không có tham số học nào trong AdaIN — chỉ Decoder (3,51 triệu tham số) được huấn luyện.</a:t>
-            </a:r>
-          </a:p>
-        </p:txBody>
-      </p:sp>
-      <p:sp>
-        <p:nvSpPr>
-          <p:cNvPr id="18" name="Rectangle 17"/>
-          <p:cNvSpPr/>
-          <p:nvPr/>
-        </p:nvSpPr>
-        <p:spPr>
-          <a:xfrm>
-            <a:off x="640080" y="5769864"/>
-            <a:ext cx="100584" cy="100584"/>
-          </a:xfrm>
-          <a:prstGeom prst="rect">
-            <a:avLst/>
-          </a:prstGeom>
-          <a:solidFill>
-            <a:srgbClr val="18A099"/>
-          </a:solidFill>
-          <a:ln>
-            <a:noFill/>
-          </a:ln>
-          <a:effectLst/>
-        </p:spPr>
-        <p:style>
-          <a:lnRef idx="1">
-            <a:schemeClr val="accent1"/>
-          </a:lnRef>
-          <a:fillRef idx="3">
-            <a:schemeClr val="accent1"/>
-          </a:fillRef>
-          <a:effectRef idx="2">
-            <a:schemeClr val="accent1"/>
-          </a:effectRef>
-          <a:fontRef idx="minor">
-            <a:schemeClr val="lt1"/>
-          </a:fontRef>
-        </p:style>
-        <p:txBody>
-          <a:bodyPr rtlCol="0" anchor="ctr"/>
-          <a:lstStyle/>
-          <a:p>
-            <a:pPr algn="ctr"/>
-          </a:p>
-        </p:txBody>
-      </p:sp>
-      <p:sp>
-        <p:nvSpPr>
-          <p:cNvPr id="19" name="TextBox 18"/>
-          <p:cNvSpPr txBox="1"/>
-          <p:nvPr/>
-        </p:nvSpPr>
-        <p:spPr>
-          <a:xfrm>
-            <a:off x="914400" y="5669280"/>
-            <a:ext cx="10607040" cy="548640"/>
-          </a:xfrm>
-          <a:prstGeom prst="rect">
-            <a:avLst/>
-          </a:prstGeom>
-          <a:noFill/>
-        </p:spPr>
-        <p:txBody>
-          <a:bodyPr wrap="square" lIns="0" rIns="0">
-            <a:spAutoFit/>
-          </a:bodyPr>
-          <a:lstStyle/>
-          <a:p>
-            <a:pPr algn="l">
-              <a:lnSpc>
-                <a:spcPct val="115000"/>
-              </a:lnSpc>
-              <a:spcAft>
-                <a:spcPts val="600"/>
-              </a:spcAft>
-            </a:pPr>
-            <a:r>
-              <a:rPr sz="1600" b="1">
-                <a:solidFill>
-                  <a:srgbClr val="101B33"/>
-                </a:solidFill>
-                <a:latin typeface="Arial"/>
-              </a:rPr>
-              <a:t>Hệ quả: thời tiết mới chỉ cần đưa ảnh tham chiếu vào, KHÔNG huấn luyện lại.</a:t>
+              <a:t>Hệ quả quan trọng: AdaIN không chứa tham số nào, còn Decoder chỉ học cách "dựng ảnh từ đặc trưng" — không học riêng loại thời tiết nào.</a:t>
+            </a:r>
+          </a:p>
+          <a:p>
+            <a:pPr algn="l">
+              <a:lnSpc>
+                <a:spcPct val="115000"/>
+              </a:lnSpc>
+              <a:spcAft>
+                <a:spcPts val="600"/>
+              </a:spcAft>
+            </a:pPr>
+            <a:r>
+              <a:rPr sz="1400" b="0">
+                <a:solidFill>
+                  <a:srgbClr val="5A6375"/>
+                </a:solidFill>
+                <a:latin typeface="Arial"/>
+              </a:rPr>
+              <a:t>⇒ Thêm loại thời tiết mới chỉ cần đưa ảnh tham chiếu vào, KHÔNG phải huấn luyện lại.</a:t>
             </a:r>
           </a:p>
         </p:txBody>

</xml_diff>